<commit_message>
Simplify judge demo and ground signals in available agent data
</commit_message>
<xml_diff>
--- a/docs/Presentation.pptx
+++ b/docs/Presentation.pptx
@@ -2,22 +2,22 @@
 <file path=ppt/presentation.xml><?xml version="1.0" encoding="utf-8"?>
 <p:presentation xmlns:p="http://schemas.openxmlformats.org/presentationml/2006/main">
   <p:sldMasterIdLst>
-    <p:sldMasterId xmlns:r="http://schemas.openxmlformats.org/officeDocument/2006/relationships" id="2147483648" r:id="R5cbc019fae7a4e06"/>
+    <p:sldMasterId xmlns:r="http://schemas.openxmlformats.org/officeDocument/2006/relationships" id="2147483648" r:id="R98f859b8514b406f"/>
   </p:sldMasterIdLst>
   <p:notesMasterIdLst>
-    <p:notesMasterId xmlns:r="http://schemas.openxmlformats.org/officeDocument/2006/relationships" r:id="R9f755e3c57a0402c"/>
+    <p:notesMasterId xmlns:r="http://schemas.openxmlformats.org/officeDocument/2006/relationships" r:id="Rbac5303685fb4907"/>
   </p:notesMasterIdLst>
   <p:sldIdLst>
-    <p:sldId xmlns:r="http://schemas.openxmlformats.org/officeDocument/2006/relationships" id="256" r:id="R2d6c7103f75e4191"/>
-    <p:sldId xmlns:r="http://schemas.openxmlformats.org/officeDocument/2006/relationships" id="257" r:id="R04bdb58fc5dc46af"/>
-    <p:sldId xmlns:r="http://schemas.openxmlformats.org/officeDocument/2006/relationships" id="258" r:id="R8e4f2fc0f2e14697"/>
-    <p:sldId xmlns:r="http://schemas.openxmlformats.org/officeDocument/2006/relationships" id="259" r:id="Rc4d76e4167ae42b8"/>
-    <p:sldId xmlns:r="http://schemas.openxmlformats.org/officeDocument/2006/relationships" id="260" r:id="Rf70c228f85a54b98"/>
-    <p:sldId xmlns:r="http://schemas.openxmlformats.org/officeDocument/2006/relationships" id="261" r:id="R907c1fe9189e4fed"/>
-    <p:sldId xmlns:r="http://schemas.openxmlformats.org/officeDocument/2006/relationships" id="262" r:id="R54d10abce2344549"/>
-    <p:sldId xmlns:r="http://schemas.openxmlformats.org/officeDocument/2006/relationships" id="263" r:id="R523d14a1f8594b0f"/>
-    <p:sldId xmlns:r="http://schemas.openxmlformats.org/officeDocument/2006/relationships" id="264" r:id="Rb25d5491d2d34180"/>
-    <p:sldId xmlns:r="http://schemas.openxmlformats.org/officeDocument/2006/relationships" id="265" r:id="Rc132a63e229c44f9"/>
+    <p:sldId xmlns:r="http://schemas.openxmlformats.org/officeDocument/2006/relationships" id="256" r:id="R8ae8397fab6141a4"/>
+    <p:sldId xmlns:r="http://schemas.openxmlformats.org/officeDocument/2006/relationships" id="257" r:id="Rd9e2b9f4f6324070"/>
+    <p:sldId xmlns:r="http://schemas.openxmlformats.org/officeDocument/2006/relationships" id="258" r:id="R8800a1cecb904b52"/>
+    <p:sldId xmlns:r="http://schemas.openxmlformats.org/officeDocument/2006/relationships" id="259" r:id="Re5f5adc6af1c4702"/>
+    <p:sldId xmlns:r="http://schemas.openxmlformats.org/officeDocument/2006/relationships" id="260" r:id="R6675558f5d0a41b5"/>
+    <p:sldId xmlns:r="http://schemas.openxmlformats.org/officeDocument/2006/relationships" id="261" r:id="R61a90885a60148e5"/>
+    <p:sldId xmlns:r="http://schemas.openxmlformats.org/officeDocument/2006/relationships" id="262" r:id="Rc15e25d270e84ac5"/>
+    <p:sldId xmlns:r="http://schemas.openxmlformats.org/officeDocument/2006/relationships" id="263" r:id="R83bc89a6091843dd"/>
+    <p:sldId xmlns:r="http://schemas.openxmlformats.org/officeDocument/2006/relationships" id="264" r:id="Rf4d1c5c9401e48b3"/>
+    <p:sldId xmlns:r="http://schemas.openxmlformats.org/officeDocument/2006/relationships" id="265" r:id="Rf5fdbac9831147c8"/>
   </p:sldIdLst>
   <p:sldSz cx="12192000" cy="6858000"/>
   <p:notesSz cx="6858000" cy="9144000"/>
@@ -871,7 +871,7 @@
           <a:lstStyle xmlns:a="http://schemas.openxmlformats.org/drawingml/2006/main"/>
           <a:p xmlns:a="http://schemas.openxmlformats.org/drawingml/2006/main">
             <a:r>
-              <a:t>Actual screenshot of the running prototype. Demonstrate adjustable capital, cost, service preference and realized demand. One exchange per day; no travel delays or financing costs.</a:t>
+              <a:t>The public upay Agent app listing describes dashboard, item-wise transaction, real-time statement and commission features. These are only feature references; no private data access or actual terms are claimed.</a:t>
             </a:r>
           </a:p>
         </p:txBody>
@@ -941,7 +941,7 @@
           <a:lstStyle xmlns:a="http://schemas.openxmlformats.org/drawingml/2006/main"/>
           <a:p xmlns:a="http://schemas.openxmlformats.org/drawingml/2006/main">
             <a:r>
-              <a:t>Actual screenshot of running prototype. Score is a concern index, never a probability of fraud. The suspicious preset includes one predefined reviewed adverse case. Explain every input and do not imply AI verified a complaint.</a:t>
+              <a:t>A fictional pre-payment concept. No complaint registry, verified recipient identity, device telemetry or real upay connection is used. The index is not a fraud probability.</a:t>
             </a:r>
           </a:p>
         </p:txBody>
@@ -1128,7 +1128,7 @@
           <p:cNvPr id="4" name="Accent rule">
             <a:extLst xmlns:a="http://schemas.openxmlformats.org/drawingml/2006/main">
               <a:ext uri="{FF2B5EF4-FFF2-40B4-BE49-F238E27FC236}">
-                <a16:creationId xmlns:a16="http://schemas.microsoft.com/office/drawing/2014/main" id="{3CAF8FF3-B72C-4A4F-83C5-15F47EFC2A56}"/>
+                <a16:creationId xmlns:a16="http://schemas.microsoft.com/office/drawing/2014/main" id="{44325C5E-F17A-4C8B-A365-540FD6FDA9D6}"/>
               </a:ext>
             </a:extLst>
           </p:cNvPr>
@@ -1159,7 +1159,7 @@
           <p:cNvPr id="2" name="Title">
             <a:extLst xmlns:a="http://schemas.openxmlformats.org/drawingml/2006/main">
               <a:ext uri="{FF2B5EF4-FFF2-40B4-BE49-F238E27FC236}">
-                <a16:creationId xmlns:a16="http://schemas.microsoft.com/office/drawing/2014/main" id="{33BD77DC-DDC5-430F-AD37-7FF940EEB8AD}"/>
+                <a16:creationId xmlns:a16="http://schemas.microsoft.com/office/drawing/2014/main" id="{40E64910-C4B4-4E12-8D34-817DD281DB22}"/>
               </a:ext>
             </a:extLst>
           </p:cNvPr>
@@ -1306,7 +1306,7 @@
           <p:cNvPr id="3" name="Subtitle">
             <a:extLst xmlns:a="http://schemas.openxmlformats.org/drawingml/2006/main">
               <a:ext uri="{FF2B5EF4-FFF2-40B4-BE49-F238E27FC236}">
-                <a16:creationId xmlns:a16="http://schemas.microsoft.com/office/drawing/2014/main" id="{D1263AD6-6E29-414B-8904-D888B2FC9BCC}"/>
+                <a16:creationId xmlns:a16="http://schemas.microsoft.com/office/drawing/2014/main" id="{276350D1-3DD7-4DF2-9589-45E6110418CE}"/>
               </a:ext>
             </a:extLst>
           </p:cNvPr>
@@ -1470,7 +1470,7 @@
           <p:cNvPr id="3" name="Accent rule">
             <a:extLst xmlns:a="http://schemas.openxmlformats.org/drawingml/2006/main">
               <a:ext uri="{FF2B5EF4-FFF2-40B4-BE49-F238E27FC236}">
-                <a16:creationId xmlns:a16="http://schemas.microsoft.com/office/drawing/2014/main" id="{5BFC8E45-326E-42E0-8F98-581A420E47B9}"/>
+                <a16:creationId xmlns:a16="http://schemas.microsoft.com/office/drawing/2014/main" id="{6BBC1DE0-7CDC-48B6-9933-B303158B5A4A}"/>
               </a:ext>
             </a:extLst>
           </p:cNvPr>
@@ -1501,7 +1501,7 @@
           <p:cNvPr id="2" name="Section title">
             <a:extLst xmlns:a="http://schemas.openxmlformats.org/drawingml/2006/main">
               <a:ext uri="{FF2B5EF4-FFF2-40B4-BE49-F238E27FC236}">
-                <a16:creationId xmlns:a16="http://schemas.microsoft.com/office/drawing/2014/main" id="{E4CF55F2-60A4-454F-BEFF-374DB2473C7D}"/>
+                <a16:creationId xmlns:a16="http://schemas.microsoft.com/office/drawing/2014/main" id="{2A35B52A-4C95-4D96-86A5-6EF4DA742232}"/>
               </a:ext>
             </a:extLst>
           </p:cNvPr>
@@ -1665,7 +1665,7 @@
           <p:cNvPr id="4" name="Accent rule">
             <a:extLst xmlns:a="http://schemas.openxmlformats.org/drawingml/2006/main">
               <a:ext uri="{FF2B5EF4-FFF2-40B4-BE49-F238E27FC236}">
-                <a16:creationId xmlns:a16="http://schemas.microsoft.com/office/drawing/2014/main" id="{6E5D8FCC-BF12-4A7E-AD11-4EFA814AB9B0}"/>
+                <a16:creationId xmlns:a16="http://schemas.microsoft.com/office/drawing/2014/main" id="{32F5A09D-A576-4302-AC8F-227573D660E0}"/>
               </a:ext>
             </a:extLst>
           </p:cNvPr>
@@ -1696,7 +1696,7 @@
           <p:cNvPr id="2" name="Title">
             <a:extLst xmlns:a="http://schemas.openxmlformats.org/drawingml/2006/main">
               <a:ext uri="{FF2B5EF4-FFF2-40B4-BE49-F238E27FC236}">
-                <a16:creationId xmlns:a16="http://schemas.microsoft.com/office/drawing/2014/main" id="{4476AEF5-EE9D-4DB1-8535-E01A4736C3D0}"/>
+                <a16:creationId xmlns:a16="http://schemas.microsoft.com/office/drawing/2014/main" id="{094FE95C-99A6-4CA0-8D2E-2A23D3C3AF63}"/>
               </a:ext>
             </a:extLst>
           </p:cNvPr>
@@ -1843,7 +1843,7 @@
           <p:cNvPr id="3" name="Body">
             <a:extLst xmlns:a="http://schemas.openxmlformats.org/drawingml/2006/main">
               <a:ext uri="{FF2B5EF4-FFF2-40B4-BE49-F238E27FC236}">
-                <a16:creationId xmlns:a16="http://schemas.microsoft.com/office/drawing/2014/main" id="{5AC8387C-BB2E-4ECF-AE5B-2BA5C226B9C8}"/>
+                <a16:creationId xmlns:a16="http://schemas.microsoft.com/office/drawing/2014/main" id="{14B0BF23-4FD8-41ED-A005-9CE8D454B89A}"/>
               </a:ext>
             </a:extLst>
           </p:cNvPr>
@@ -2007,7 +2007,7 @@
           <p:cNvPr id="5" name="Accent rule">
             <a:extLst xmlns:a="http://schemas.openxmlformats.org/drawingml/2006/main">
               <a:ext uri="{FF2B5EF4-FFF2-40B4-BE49-F238E27FC236}">
-                <a16:creationId xmlns:a16="http://schemas.microsoft.com/office/drawing/2014/main" id="{55B5BAD7-C8EE-40AA-9050-73A5F70B872E}"/>
+                <a16:creationId xmlns:a16="http://schemas.microsoft.com/office/drawing/2014/main" id="{C74D5D0A-D4C8-40DC-99FD-530219250E27}"/>
               </a:ext>
             </a:extLst>
           </p:cNvPr>
@@ -2038,7 +2038,7 @@
           <p:cNvPr id="2" name="Title">
             <a:extLst xmlns:a="http://schemas.openxmlformats.org/drawingml/2006/main">
               <a:ext uri="{FF2B5EF4-FFF2-40B4-BE49-F238E27FC236}">
-                <a16:creationId xmlns:a16="http://schemas.microsoft.com/office/drawing/2014/main" id="{1AFCC985-3C5D-4CF0-9A66-57E3128C56A1}"/>
+                <a16:creationId xmlns:a16="http://schemas.microsoft.com/office/drawing/2014/main" id="{D3BE7D82-3DF4-4189-A9E3-90C569CD3078}"/>
               </a:ext>
             </a:extLst>
           </p:cNvPr>
@@ -2185,7 +2185,7 @@
           <p:cNvPr id="3" name="Left column">
             <a:extLst xmlns:a="http://schemas.openxmlformats.org/drawingml/2006/main">
               <a:ext uri="{FF2B5EF4-FFF2-40B4-BE49-F238E27FC236}">
-                <a16:creationId xmlns:a16="http://schemas.microsoft.com/office/drawing/2014/main" id="{0B04A3AB-BFDD-4894-BBF9-9B83102CFAE9}"/>
+                <a16:creationId xmlns:a16="http://schemas.microsoft.com/office/drawing/2014/main" id="{697B84EC-B3D1-4A8F-836F-0B9ACD21DBD7}"/>
               </a:ext>
             </a:extLst>
           </p:cNvPr>
@@ -2332,7 +2332,7 @@
           <p:cNvPr id="4" name="Right column">
             <a:extLst xmlns:a="http://schemas.openxmlformats.org/drawingml/2006/main">
               <a:ext uri="{FF2B5EF4-FFF2-40B4-BE49-F238E27FC236}">
-                <a16:creationId xmlns:a16="http://schemas.microsoft.com/office/drawing/2014/main" id="{5CBDBA57-2069-47D2-8D11-A6E93E7A8BD0}"/>
+                <a16:creationId xmlns:a16="http://schemas.microsoft.com/office/drawing/2014/main" id="{3C2BC674-5A5B-4D66-8D4F-48BC3FD5D659}"/>
               </a:ext>
             </a:extLst>
           </p:cNvPr>
@@ -2496,7 +2496,7 @@
           <p:cNvPr id="4" name="Accent rule">
             <a:extLst xmlns:a="http://schemas.openxmlformats.org/drawingml/2006/main">
               <a:ext uri="{FF2B5EF4-FFF2-40B4-BE49-F238E27FC236}">
-                <a16:creationId xmlns:a16="http://schemas.microsoft.com/office/drawing/2014/main" id="{44ACDC50-4713-40B9-BA6F-054FFFF85254}"/>
+                <a16:creationId xmlns:a16="http://schemas.microsoft.com/office/drawing/2014/main" id="{51757D35-D26F-44CA-8F75-A94F62341C88}"/>
               </a:ext>
             </a:extLst>
           </p:cNvPr>
@@ -2527,7 +2527,7 @@
           <p:cNvPr id="2" name="Title">
             <a:extLst xmlns:a="http://schemas.openxmlformats.org/drawingml/2006/main">
               <a:ext uri="{FF2B5EF4-FFF2-40B4-BE49-F238E27FC236}">
-                <a16:creationId xmlns:a16="http://schemas.microsoft.com/office/drawing/2014/main" id="{D36D662A-C49F-4CEA-B89F-9E6C363CD98E}"/>
+                <a16:creationId xmlns:a16="http://schemas.microsoft.com/office/drawing/2014/main" id="{FFD3496A-B1AD-4C39-B58F-F4F31FB2FAB7}"/>
               </a:ext>
             </a:extLst>
           </p:cNvPr>
@@ -2674,7 +2674,7 @@
           <p:cNvPr id="3" name="Left column">
             <a:extLst xmlns:a="http://schemas.openxmlformats.org/drawingml/2006/main">
               <a:ext uri="{FF2B5EF4-FFF2-40B4-BE49-F238E27FC236}">
-                <a16:creationId xmlns:a16="http://schemas.microsoft.com/office/drawing/2014/main" id="{728191AA-369E-48FF-9DDB-613FA5B06D80}"/>
+                <a16:creationId xmlns:a16="http://schemas.microsoft.com/office/drawing/2014/main" id="{4B146D77-EAB3-431E-851D-033BE8948804}"/>
               </a:ext>
             </a:extLst>
           </p:cNvPr>
@@ -2859,12 +2859,12 @@
   </p:cSld>
   <p:clrMap bg1="lt1" tx1="dk1" bg2="lt2" tx2="dk2" accent1="accent1" accent2="accent2" accent3="accent3" accent4="accent4" accent5="accent5" accent6="accent6" hlink="hlink" folHlink="folHlink"/>
   <p:sldLayoutIdLst>
-    <p:sldLayoutId xmlns:r="http://schemas.openxmlformats.org/officeDocument/2006/relationships" id="2147483649" r:id="R7fdfd23678074404"/>
-    <p:sldLayoutId xmlns:r="http://schemas.openxmlformats.org/officeDocument/2006/relationships" id="2147483650" r:id="Re6f9d51f3bd34ae7"/>
-    <p:sldLayoutId xmlns:r="http://schemas.openxmlformats.org/officeDocument/2006/relationships" id="2147483651" r:id="Raf951fc11d804aa4"/>
-    <p:sldLayoutId xmlns:r="http://schemas.openxmlformats.org/officeDocument/2006/relationships" id="2147483652" r:id="R7ef79671b7004222"/>
-    <p:sldLayoutId xmlns:r="http://schemas.openxmlformats.org/officeDocument/2006/relationships" id="2147483653" r:id="R6f9f7edec71249db"/>
-    <p:sldLayoutId xmlns:r="http://schemas.openxmlformats.org/officeDocument/2006/relationships" id="2147483654" r:id="R3fee7678620f4b55"/>
+    <p:sldLayoutId xmlns:r="http://schemas.openxmlformats.org/officeDocument/2006/relationships" id="2147483649" r:id="R7d40f888dd574acd"/>
+    <p:sldLayoutId xmlns:r="http://schemas.openxmlformats.org/officeDocument/2006/relationships" id="2147483650" r:id="Raeb61a2f132f4849"/>
+    <p:sldLayoutId xmlns:r="http://schemas.openxmlformats.org/officeDocument/2006/relationships" id="2147483651" r:id="R2259d36968da4215"/>
+    <p:sldLayoutId xmlns:r="http://schemas.openxmlformats.org/officeDocument/2006/relationships" id="2147483652" r:id="R3aca2f1ece224e66"/>
+    <p:sldLayoutId xmlns:r="http://schemas.openxmlformats.org/officeDocument/2006/relationships" id="2147483653" r:id="R3d2227c13b4f4426"/>
+    <p:sldLayoutId xmlns:r="http://schemas.openxmlformats.org/officeDocument/2006/relationships" id="2147483654" r:id="R9299e0cb511e49bd"/>
   </p:sldLayoutIdLst>
   <p:txStyles>
     <p:titleStyle>
@@ -3392,7 +3392,7 @@
 </file>
 
 <file path=ppt/slides/charts/chart1.xml><?xml version="1.0" encoding="utf-8"?>
-<c:chartSpace xmlns:c="http://schemas.openxmlformats.org/drawingml/2006/chart" xmlns:r="http://schemas.openxmlformats.org/officeDocument/2006/relationships">
+<c:chartSpace xmlns:c="http://schemas.openxmlformats.org/drawingml/2006/chart">
   <c:lang val="en-US"/>
   <c:chart>
     <c:plotArea>
@@ -3412,33 +3412,27 @@
             </a:solidFill>
           </c:spPr>
           <c:cat>
-            <c:strRef>
-              <c:f>'Chart Data'!$A$2:$A$3</c:f>
-              <c:strCache>
-                <c:ptCount val="2"/>
-                <c:pt idx="0">
-                  <c:v>Cash-in</c:v>
-                </c:pt>
-                <c:pt idx="1">
-                  <c:v>Cash-out</c:v>
-                </c:pt>
-              </c:strCache>
-            </c:strRef>
+            <c:strLit>
+              <c:ptCount val="2"/>
+              <c:pt idx="0">
+                <c:v>Cash-in</c:v>
+              </c:pt>
+              <c:pt idx="1">
+                <c:v>Cash-out</c:v>
+              </c:pt>
+            </c:strLit>
           </c:cat>
           <c:val>
-            <c:numRef>
-              <c:f>'Chart Data'!$B$2:$B$3</c:f>
-              <c:numCache>
-                <c:formatCode>0</c:formatCode>
-                <c:ptCount val="2"/>
-                <c:pt idx="0">
-                  <c:v>1466.07</c:v>
-                </c:pt>
-                <c:pt idx="1">
-                  <c:v>2274.67</c:v>
-                </c:pt>
-              </c:numCache>
-            </c:numRef>
+            <c:numLit>
+              <c:formatCode>0</c:formatCode>
+              <c:ptCount val="2"/>
+              <c:pt idx="0">
+                <c:v>1466.07</c:v>
+              </c:pt>
+              <c:pt idx="1">
+                <c:v>2274.67</c:v>
+              </c:pt>
+            </c:numLit>
           </c:val>
         </c:ser>
         <c:ser>
@@ -3453,33 +3447,27 @@
             </a:solidFill>
           </c:spPr>
           <c:cat>
-            <c:strRef>
-              <c:f>'Chart Data'!$C$2:$C$3</c:f>
-              <c:strCache>
-                <c:ptCount val="2"/>
-                <c:pt idx="0">
-                  <c:v>Cash-in</c:v>
-                </c:pt>
-                <c:pt idx="1">
-                  <c:v>Cash-out</c:v>
-                </c:pt>
-              </c:strCache>
-            </c:strRef>
+            <c:strLit>
+              <c:ptCount val="2"/>
+              <c:pt idx="0">
+                <c:v>Cash-in</c:v>
+              </c:pt>
+              <c:pt idx="1">
+                <c:v>Cash-out</c:v>
+              </c:pt>
+            </c:strLit>
           </c:cat>
           <c:val>
-            <c:numRef>
-              <c:f>'Chart Data'!$D$2:$D$3</c:f>
-              <c:numCache>
-                <c:formatCode>0</c:formatCode>
-                <c:ptCount val="2"/>
-                <c:pt idx="0">
-                  <c:v>1209.83</c:v>
-                </c:pt>
-                <c:pt idx="1">
-                  <c:v>1613.86</c:v>
-                </c:pt>
-              </c:numCache>
-            </c:numRef>
+            <c:numLit>
+              <c:formatCode>0</c:formatCode>
+              <c:ptCount val="2"/>
+              <c:pt idx="0">
+                <c:v>1209.83</c:v>
+              </c:pt>
+              <c:pt idx="1">
+                <c:v>1613.86</c:v>
+              </c:pt>
+            </c:numLit>
           </c:val>
         </c:ser>
         <c:dLbls>
@@ -3646,14 +3634,11 @@
       <a:srgbClr val="F7F9FB"/>
     </a:solidFill>
   </c:spPr>
-  <c:externalData r:id="rIdChartSnapshot1">
-    <c:autoUpdate val="0"/>
-  </c:externalData>
 </c:chartSpace>
 </file>
 
 <file path=ppt/slides/charts/chart2.xml><?xml version="1.0" encoding="utf-8"?>
-<c:chartSpace xmlns:c="http://schemas.openxmlformats.org/drawingml/2006/chart" xmlns:r="http://schemas.openxmlformats.org/officeDocument/2006/relationships">
+<c:chartSpace xmlns:c="http://schemas.openxmlformats.org/drawingml/2006/chart">
   <c:lang val="en-US"/>
   <c:chart>
     <c:plotArea>
@@ -3673,47 +3658,41 @@
             </a:solidFill>
           </c:spPr>
           <c:cat>
-            <c:strRef>
-              <c:f>'Chart Data'!$A$2:$A$5</c:f>
-              <c:strCache>
-                <c:ptCount val="4"/>
-                <c:pt idx="0">
-                  <c:v>Fixed 50/50</c:v>
-                </c:pt>
-                <c:pt idx="1">
-                  <c:v>Historical +
+            <c:strLit>
+              <c:ptCount val="4"/>
+              <c:pt idx="0">
+                <c:v>Fixed 50/50</c:v>
+              </c:pt>
+              <c:pt idx="1">
+                <c:v>Historical +
 optimizer</c:v>
-                </c:pt>
-                <c:pt idx="2">
-                  <c:v>No action</c:v>
-                </c:pt>
-                <c:pt idx="3">
-                  <c:v>ML +
+              </c:pt>
+              <c:pt idx="2">
+                <c:v>No action</c:v>
+              </c:pt>
+              <c:pt idx="3">
+                <c:v>ML +
 optimizer</c:v>
-                </c:pt>
-              </c:strCache>
-            </c:strRef>
+              </c:pt>
+            </c:strLit>
           </c:cat>
           <c:val>
-            <c:numRef>
-              <c:f>'Chart Data'!$B$2:$B$5</c:f>
-              <c:numCache>
-                <c:formatCode>0</c:formatCode>
-                <c:ptCount val="4"/>
-                <c:pt idx="0">
-                  <c:v>316.356</c:v>
-                </c:pt>
-                <c:pt idx="1">
-                  <c:v>328.889</c:v>
-                </c:pt>
-                <c:pt idx="2">
-                  <c:v>334.654</c:v>
-                </c:pt>
-                <c:pt idx="3">
-                  <c:v>339.876</c:v>
-                </c:pt>
-              </c:numCache>
-            </c:numRef>
+            <c:numLit>
+              <c:formatCode>0</c:formatCode>
+              <c:ptCount val="4"/>
+              <c:pt idx="0">
+                <c:v>316.356</c:v>
+              </c:pt>
+              <c:pt idx="1">
+                <c:v>328.889</c:v>
+              </c:pt>
+              <c:pt idx="2">
+                <c:v>334.654</c:v>
+              </c:pt>
+              <c:pt idx="3">
+                <c:v>339.876</c:v>
+              </c:pt>
+            </c:numLit>
           </c:val>
         </c:ser>
         <c:dLbls>
@@ -3863,14 +3842,11 @@
       <a:srgbClr val="F7F9FB"/>
     </a:solidFill>
   </c:spPr>
-  <c:externalData r:id="rIdChartSnapshot1">
-    <c:autoUpdate val="0"/>
-  </c:externalData>
 </c:chartSpace>
 </file>
 
 <file path=ppt/slides/charts/chart3.xml><?xml version="1.0" encoding="utf-8"?>
-<c:chartSpace xmlns:c="http://schemas.openxmlformats.org/drawingml/2006/chart" xmlns:r="http://schemas.openxmlformats.org/officeDocument/2006/relationships">
+<c:chartSpace xmlns:c="http://schemas.openxmlformats.org/drawingml/2006/chart">
   <c:lang val="en-US"/>
   <c:chart>
     <c:plotArea>
@@ -3890,46 +3866,40 @@
             </a:solidFill>
           </c:spPr>
           <c:cat>
-            <c:strRef>
-              <c:f>'Chart Data'!$A$2:$A$5</c:f>
-              <c:strCache>
-                <c:ptCount val="4"/>
-                <c:pt idx="0">
-                  <c:v>True alerts</c:v>
-                </c:pt>
-                <c:pt idx="1">
-                  <c:v>False alerts</c:v>
-                </c:pt>
-                <c:pt idx="2">
-                  <c:v>Missed scams</c:v>
-                </c:pt>
-                <c:pt idx="3">
-                  <c:v>Correct
+            <c:strLit>
+              <c:ptCount val="4"/>
+              <c:pt idx="0">
+                <c:v>True alerts</c:v>
+              </c:pt>
+              <c:pt idx="1">
+                <c:v>False alerts</c:v>
+              </c:pt>
+              <c:pt idx="2">
+                <c:v>Missed scams</c:v>
+              </c:pt>
+              <c:pt idx="3">
+                <c:v>Correct
 non-alerts</c:v>
-                </c:pt>
-              </c:strCache>
-            </c:strRef>
+              </c:pt>
+            </c:strLit>
           </c:cat>
           <c:val>
-            <c:numRef>
-              <c:f>'Chart Data'!$B$2:$B$5</c:f>
-              <c:numCache>
-                <c:formatCode>0</c:formatCode>
-                <c:ptCount val="4"/>
-                <c:pt idx="0">
-                  <c:v>11</c:v>
-                </c:pt>
-                <c:pt idx="1">
-                  <c:v>2</c:v>
-                </c:pt>
-                <c:pt idx="2">
-                  <c:v>1</c:v>
-                </c:pt>
-                <c:pt idx="3">
-                  <c:v>10</c:v>
-                </c:pt>
-              </c:numCache>
-            </c:numRef>
+            <c:numLit>
+              <c:formatCode>0</c:formatCode>
+              <c:ptCount val="4"/>
+              <c:pt idx="0">
+                <c:v>11</c:v>
+              </c:pt>
+              <c:pt idx="1">
+                <c:v>2</c:v>
+              </c:pt>
+              <c:pt idx="2">
+                <c:v>1</c:v>
+              </c:pt>
+              <c:pt idx="3">
+                <c:v>10</c:v>
+              </c:pt>
+            </c:numLit>
           </c:val>
         </c:ser>
         <c:ser>
@@ -3944,46 +3914,40 @@
             </a:solidFill>
           </c:spPr>
           <c:cat>
-            <c:strRef>
-              <c:f>'Chart Data'!$C$2:$C$5</c:f>
-              <c:strCache>
-                <c:ptCount val="4"/>
-                <c:pt idx="0">
-                  <c:v>True alerts</c:v>
-                </c:pt>
-                <c:pt idx="1">
-                  <c:v>False alerts</c:v>
-                </c:pt>
-                <c:pt idx="2">
-                  <c:v>Missed scams</c:v>
-                </c:pt>
-                <c:pt idx="3">
-                  <c:v>Correct
+            <c:strLit>
+              <c:ptCount val="4"/>
+              <c:pt idx="0">
+                <c:v>True alerts</c:v>
+              </c:pt>
+              <c:pt idx="1">
+                <c:v>False alerts</c:v>
+              </c:pt>
+              <c:pt idx="2">
+                <c:v>Missed scams</c:v>
+              </c:pt>
+              <c:pt idx="3">
+                <c:v>Correct
 non-alerts</c:v>
-                </c:pt>
-              </c:strCache>
-            </c:strRef>
+              </c:pt>
+            </c:strLit>
           </c:cat>
           <c:val>
-            <c:numRef>
-              <c:f>'Chart Data'!$D$2:$D$5</c:f>
-              <c:numCache>
-                <c:formatCode>0</c:formatCode>
-                <c:ptCount val="4"/>
-                <c:pt idx="0">
-                  <c:v>3</c:v>
-                </c:pt>
-                <c:pt idx="1">
-                  <c:v>3</c:v>
-                </c:pt>
-                <c:pt idx="2">
-                  <c:v>9</c:v>
-                </c:pt>
-                <c:pt idx="3">
-                  <c:v>9</c:v>
-                </c:pt>
-              </c:numCache>
-            </c:numRef>
+            <c:numLit>
+              <c:formatCode>0</c:formatCode>
+              <c:ptCount val="4"/>
+              <c:pt idx="0">
+                <c:v>3</c:v>
+              </c:pt>
+              <c:pt idx="1">
+                <c:v>3</c:v>
+              </c:pt>
+              <c:pt idx="2">
+                <c:v>9</c:v>
+              </c:pt>
+              <c:pt idx="3">
+                <c:v>9</c:v>
+              </c:pt>
+            </c:numLit>
           </c:val>
         </c:ser>
         <c:dLbls>
@@ -4150,9 +4114,6 @@
       <a:srgbClr val="F7F9FB"/>
     </a:solidFill>
   </c:spPr>
-  <c:externalData r:id="rIdChartSnapshot1">
-    <c:autoUpdate val="0"/>
-  </c:externalData>
 </c:chartSpace>
 </file>
 
@@ -4180,7 +4141,7 @@
           <p:cNvPr id="5" name="">
             <a:extLst xmlns:a="http://schemas.openxmlformats.org/drawingml/2006/main">
               <a:ext uri="{FF2B5EF4-FFF2-40B4-BE49-F238E27FC236}">
-                <a16:creationId xmlns:a16="http://schemas.microsoft.com/office/drawing/2014/main" id="{C3021B6D-E221-42C7-9135-94959735146D}"/>
+                <a16:creationId xmlns:a16="http://schemas.microsoft.com/office/drawing/2014/main" id="{AB41E2FA-7765-4D57-907C-4A369500999A}"/>
               </a:ext>
             </a:extLst>
           </p:cNvPr>
@@ -4260,7 +4221,7 @@
           <p:cNvPr id="2" name="">
             <a:extLst xmlns:a="http://schemas.openxmlformats.org/drawingml/2006/main">
               <a:ext uri="{FF2B5EF4-FFF2-40B4-BE49-F238E27FC236}">
-                <a16:creationId xmlns:a16="http://schemas.microsoft.com/office/drawing/2014/main" id="{34DF6DED-2878-497F-A096-96780BCE2D66}"/>
+                <a16:creationId xmlns:a16="http://schemas.microsoft.com/office/drawing/2014/main" id="{60A1FC55-361C-44A7-B716-F165A0EF6C52}"/>
               </a:ext>
             </a:extLst>
           </p:cNvPr>
@@ -4317,7 +4278,7 @@
           <p:cNvPr id="3" name="">
             <a:extLst xmlns:a="http://schemas.openxmlformats.org/drawingml/2006/main">
               <a:ext uri="{FF2B5EF4-FFF2-40B4-BE49-F238E27FC236}">
-                <a16:creationId xmlns:a16="http://schemas.microsoft.com/office/drawing/2014/main" id="{2A3A7BEE-34FD-4511-9202-C5CD0BF19510}"/>
+                <a16:creationId xmlns:a16="http://schemas.microsoft.com/office/drawing/2014/main" id="{B0EFA735-0CB9-4AE2-9ACA-7B16B99B5120}"/>
               </a:ext>
             </a:extLst>
           </p:cNvPr>
@@ -4374,7 +4335,7 @@
           <p:cNvPr id="4" name="">
             <a:extLst xmlns:a="http://schemas.openxmlformats.org/drawingml/2006/main">
               <a:ext uri="{FF2B5EF4-FFF2-40B4-BE49-F238E27FC236}">
-                <a16:creationId xmlns:a16="http://schemas.microsoft.com/office/drawing/2014/main" id="{06EE02D4-ABE3-458E-9810-119497889F09}"/>
+                <a16:creationId xmlns:a16="http://schemas.microsoft.com/office/drawing/2014/main" id="{D80262FA-E4D7-4A7F-9A19-CDF09F83A679}"/>
               </a:ext>
             </a:extLst>
           </p:cNvPr>
@@ -4429,7 +4390,7 @@
     </p:spTree>
     <p:extLst>
       <p:ext uri="{BB962C8B-B14F-4D97-AF65-F5344CB8AC3E}">
-        <p14:creationId xmlns:p14="http://schemas.microsoft.com/office/powerpoint/2010/main" val="777707713"/>
+        <p14:creationId xmlns:p14="http://schemas.microsoft.com/office/powerpoint/2010/main" val="529995328"/>
       </p:ext>
     </p:extLst>
   </p:cSld>
@@ -4460,7 +4421,7 @@
           <p:cNvPr id="7" name="">
             <a:extLst xmlns:a="http://schemas.openxmlformats.org/drawingml/2006/main">
               <a:ext uri="{FF2B5EF4-FFF2-40B4-BE49-F238E27FC236}">
-                <a16:creationId xmlns:a16="http://schemas.microsoft.com/office/drawing/2014/main" id="{CF012486-159C-43B7-B774-57293D158078}"/>
+                <a16:creationId xmlns:a16="http://schemas.microsoft.com/office/drawing/2014/main" id="{6EFAC72C-2702-4580-8AAC-9E7348345EB8}"/>
               </a:ext>
             </a:extLst>
           </p:cNvPr>
@@ -4517,7 +4478,7 @@
           <p:cNvPr id="2" name="">
             <a:extLst xmlns:a="http://schemas.openxmlformats.org/drawingml/2006/main">
               <a:ext uri="{FF2B5EF4-FFF2-40B4-BE49-F238E27FC236}">
-                <a16:creationId xmlns:a16="http://schemas.microsoft.com/office/drawing/2014/main" id="{8B460840-FA67-4E8A-9D09-E1F5A6E8608F}"/>
+                <a16:creationId xmlns:a16="http://schemas.microsoft.com/office/drawing/2014/main" id="{F847726B-C79B-480B-8B22-6CAFB540DE0B}"/>
               </a:ext>
             </a:extLst>
           </p:cNvPr>
@@ -4574,7 +4535,7 @@
           <p:cNvPr id="3" name="">
             <a:extLst xmlns:a="http://schemas.openxmlformats.org/drawingml/2006/main">
               <a:ext uri="{FF2B5EF4-FFF2-40B4-BE49-F238E27FC236}">
-                <a16:creationId xmlns:a16="http://schemas.microsoft.com/office/drawing/2014/main" id="{E786E327-90F0-46D2-8E75-BD6BCD3E77D0}"/>
+                <a16:creationId xmlns:a16="http://schemas.microsoft.com/office/drawing/2014/main" id="{9F4AD920-CE02-4503-8B6C-60E0921AEC9D}"/>
               </a:ext>
             </a:extLst>
           </p:cNvPr>
@@ -4654,7 +4615,7 @@
           <p:cNvPr id="4" name="">
             <a:extLst xmlns:a="http://schemas.openxmlformats.org/drawingml/2006/main">
               <a:ext uri="{FF2B5EF4-FFF2-40B4-BE49-F238E27FC236}">
-                <a16:creationId xmlns:a16="http://schemas.microsoft.com/office/drawing/2014/main" id="{45FA8236-E2B2-436E-A8BC-E7C5E6C5E0D5}"/>
+                <a16:creationId xmlns:a16="http://schemas.microsoft.com/office/drawing/2014/main" id="{A6B06B7B-B58B-4411-AF4E-09999FFF4D03}"/>
               </a:ext>
             </a:extLst>
           </p:cNvPr>
@@ -4711,7 +4672,7 @@
           <p:cNvPr id="5" name="">
             <a:extLst xmlns:a="http://schemas.openxmlformats.org/drawingml/2006/main">
               <a:ext uri="{FF2B5EF4-FFF2-40B4-BE49-F238E27FC236}">
-                <a16:creationId xmlns:a16="http://schemas.microsoft.com/office/drawing/2014/main" id="{D5FDB284-2A6B-4FA5-9ABD-35C79189069E}"/>
+                <a16:creationId xmlns:a16="http://schemas.microsoft.com/office/drawing/2014/main" id="{0120E31D-997D-4ACA-A111-9566E7FB704D}"/>
               </a:ext>
             </a:extLst>
           </p:cNvPr>
@@ -4791,7 +4752,7 @@
           <p:cNvPr id="6" name="">
             <a:extLst xmlns:a="http://schemas.openxmlformats.org/drawingml/2006/main">
               <a:ext uri="{FF2B5EF4-FFF2-40B4-BE49-F238E27FC236}">
-                <a16:creationId xmlns:a16="http://schemas.microsoft.com/office/drawing/2014/main" id="{431E0F78-604C-4967-AF1E-2C011B013515}"/>
+                <a16:creationId xmlns:a16="http://schemas.microsoft.com/office/drawing/2014/main" id="{969715D3-B48E-4A4D-AD38-171B97C10DBC}"/>
               </a:ext>
             </a:extLst>
           </p:cNvPr>
@@ -4846,7 +4807,7 @@
     </p:spTree>
     <p:extLst>
       <p:ext uri="{BB962C8B-B14F-4D97-AF65-F5344CB8AC3E}">
-        <p14:creationId xmlns:p14="http://schemas.microsoft.com/office/powerpoint/2010/main" val="959476613"/>
+        <p14:creationId xmlns:p14="http://schemas.microsoft.com/office/powerpoint/2010/main" val="443008730"/>
       </p:ext>
     </p:extLst>
   </p:cSld>
@@ -4877,7 +4838,7 @@
           <p:cNvPr id="9" name="">
             <a:extLst xmlns:a="http://schemas.openxmlformats.org/drawingml/2006/main">
               <a:ext uri="{FF2B5EF4-FFF2-40B4-BE49-F238E27FC236}">
-                <a16:creationId xmlns:a16="http://schemas.microsoft.com/office/drawing/2014/main" id="{DC70BC7C-83A8-4EA2-A0D7-1CEF97C0F179}"/>
+                <a16:creationId xmlns:a16="http://schemas.microsoft.com/office/drawing/2014/main" id="{B4D2C928-14B9-4B4B-A0FF-25AEC50CE2D1}"/>
               </a:ext>
             </a:extLst>
           </p:cNvPr>
@@ -4934,7 +4895,7 @@
           <p:cNvPr id="2" name="">
             <a:extLst xmlns:a="http://schemas.openxmlformats.org/drawingml/2006/main">
               <a:ext uri="{FF2B5EF4-FFF2-40B4-BE49-F238E27FC236}">
-                <a16:creationId xmlns:a16="http://schemas.microsoft.com/office/drawing/2014/main" id="{5AA106F8-BAE8-4577-BA63-D78D38A06637}"/>
+                <a16:creationId xmlns:a16="http://schemas.microsoft.com/office/drawing/2014/main" id="{4BE70481-6AC1-44D6-B975-0D3CB12CB917}"/>
               </a:ext>
             </a:extLst>
           </p:cNvPr>
@@ -4991,7 +4952,7 @@
           <p:cNvPr id="3" name="">
             <a:extLst xmlns:a="http://schemas.openxmlformats.org/drawingml/2006/main">
               <a:ext uri="{FF2B5EF4-FFF2-40B4-BE49-F238E27FC236}">
-                <a16:creationId xmlns:a16="http://schemas.microsoft.com/office/drawing/2014/main" id="{E2828CB4-443D-4E02-9EE1-E6600D708E0A}"/>
+                <a16:creationId xmlns:a16="http://schemas.microsoft.com/office/drawing/2014/main" id="{43A11740-E779-4D44-85E3-6B8410B92DF3}"/>
               </a:ext>
             </a:extLst>
           </p:cNvPr>
@@ -5071,7 +5032,7 @@
           <p:cNvPr id="4" name="">
             <a:extLst xmlns:a="http://schemas.openxmlformats.org/drawingml/2006/main">
               <a:ext uri="{FF2B5EF4-FFF2-40B4-BE49-F238E27FC236}">
-                <a16:creationId xmlns:a16="http://schemas.microsoft.com/office/drawing/2014/main" id="{781F169F-707F-4861-9B9D-69DB652D1E58}"/>
+                <a16:creationId xmlns:a16="http://schemas.microsoft.com/office/drawing/2014/main" id="{FCDFDD0A-198F-42EC-8B70-B0333C44A9CD}"/>
               </a:ext>
             </a:extLst>
           </p:cNvPr>
@@ -5174,7 +5135,7 @@
           <p:cNvPr id="5" name="">
             <a:extLst xmlns:a="http://schemas.openxmlformats.org/drawingml/2006/main">
               <a:ext uri="{FF2B5EF4-FFF2-40B4-BE49-F238E27FC236}">
-                <a16:creationId xmlns:a16="http://schemas.microsoft.com/office/drawing/2014/main" id="{B36E7962-C9AD-4633-92B1-5E39F663C985}"/>
+                <a16:creationId xmlns:a16="http://schemas.microsoft.com/office/drawing/2014/main" id="{6D6F7C64-D639-49D4-910E-04328D23145A}"/>
               </a:ext>
             </a:extLst>
           </p:cNvPr>
@@ -5231,7 +5192,7 @@
           <p:cNvPr id="6" name="">
             <a:extLst xmlns:a="http://schemas.openxmlformats.org/drawingml/2006/main">
               <a:ext uri="{FF2B5EF4-FFF2-40B4-BE49-F238E27FC236}">
-                <a16:creationId xmlns:a16="http://schemas.microsoft.com/office/drawing/2014/main" id="{AE3FD8F9-1ECE-475E-B8D9-179CCBB9751A}"/>
+                <a16:creationId xmlns:a16="http://schemas.microsoft.com/office/drawing/2014/main" id="{F0029DE6-FA46-4FFB-A4F6-CB78900A3B55}"/>
               </a:ext>
             </a:extLst>
           </p:cNvPr>
@@ -5311,7 +5272,7 @@
           <p:cNvPr id="7" name="">
             <a:extLst xmlns:a="http://schemas.openxmlformats.org/drawingml/2006/main">
               <a:ext uri="{FF2B5EF4-FFF2-40B4-BE49-F238E27FC236}">
-                <a16:creationId xmlns:a16="http://schemas.microsoft.com/office/drawing/2014/main" id="{6EE8425B-3276-4AA3-BF16-950E6652268D}"/>
+                <a16:creationId xmlns:a16="http://schemas.microsoft.com/office/drawing/2014/main" id="{E2713538-1013-4225-A48C-365E34907D58}"/>
               </a:ext>
             </a:extLst>
           </p:cNvPr>
@@ -5414,7 +5375,7 @@
           <p:cNvPr id="8" name="">
             <a:extLst xmlns:a="http://schemas.openxmlformats.org/drawingml/2006/main">
               <a:ext uri="{FF2B5EF4-FFF2-40B4-BE49-F238E27FC236}">
-                <a16:creationId xmlns:a16="http://schemas.microsoft.com/office/drawing/2014/main" id="{91A5D3FC-09EA-430C-9519-2850A79D9C3A}"/>
+                <a16:creationId xmlns:a16="http://schemas.microsoft.com/office/drawing/2014/main" id="{66ADF2BF-E055-4102-81D0-F87722B71581}"/>
               </a:ext>
             </a:extLst>
           </p:cNvPr>
@@ -5469,7 +5430,7 @@
     </p:spTree>
     <p:extLst>
       <p:ext uri="{BB962C8B-B14F-4D97-AF65-F5344CB8AC3E}">
-        <p14:creationId xmlns:p14="http://schemas.microsoft.com/office/powerpoint/2010/main" val="705392171"/>
+        <p14:creationId xmlns:p14="http://schemas.microsoft.com/office/powerpoint/2010/main" val="512804488"/>
       </p:ext>
     </p:extLst>
   </p:cSld>
@@ -5500,7 +5461,7 @@
           <p:cNvPr id="8" name="">
             <a:extLst xmlns:a="http://schemas.openxmlformats.org/drawingml/2006/main">
               <a:ext uri="{FF2B5EF4-FFF2-40B4-BE49-F238E27FC236}">
-                <a16:creationId xmlns:a16="http://schemas.microsoft.com/office/drawing/2014/main" id="{443D9C80-B8AD-49A5-B46B-0BF9791920D6}"/>
+                <a16:creationId xmlns:a16="http://schemas.microsoft.com/office/drawing/2014/main" id="{561267DF-FE75-413F-AC5C-DCB34971D1D6}"/>
               </a:ext>
             </a:extLst>
           </p:cNvPr>
@@ -5557,7 +5518,7 @@
           <p:cNvPr id="2" name="">
             <a:extLst xmlns:a="http://schemas.openxmlformats.org/drawingml/2006/main">
               <a:ext uri="{FF2B5EF4-FFF2-40B4-BE49-F238E27FC236}">
-                <a16:creationId xmlns:a16="http://schemas.microsoft.com/office/drawing/2014/main" id="{A569411C-79FC-4CBD-9B96-C2D0127FB605}"/>
+                <a16:creationId xmlns:a16="http://schemas.microsoft.com/office/drawing/2014/main" id="{DCB6D55B-EA81-4CAF-930B-CDDC475BD629}"/>
               </a:ext>
             </a:extLst>
           </p:cNvPr>
@@ -5614,7 +5575,7 @@
           <p:cNvPr id="3" name="">
             <a:extLst xmlns:a="http://schemas.openxmlformats.org/drawingml/2006/main">
               <a:ext uri="{FF2B5EF4-FFF2-40B4-BE49-F238E27FC236}">
-                <a16:creationId xmlns:a16="http://schemas.microsoft.com/office/drawing/2014/main" id="{F4E7A8E4-EF09-4F2E-A1CB-8C6F771F0C16}"/>
+                <a16:creationId xmlns:a16="http://schemas.microsoft.com/office/drawing/2014/main" id="{6A1CF44A-5DBD-42B5-9D33-B57C4D3A48FA}"/>
               </a:ext>
             </a:extLst>
           </p:cNvPr>
@@ -5671,7 +5632,7 @@
           <p:cNvPr id="4" name="">
             <a:extLst xmlns:a="http://schemas.openxmlformats.org/drawingml/2006/main">
               <a:ext uri="{FF2B5EF4-FFF2-40B4-BE49-F238E27FC236}">
-                <a16:creationId xmlns:a16="http://schemas.microsoft.com/office/drawing/2014/main" id="{471DA5DC-1341-4297-B39A-871F6E1582AE}"/>
+                <a16:creationId xmlns:a16="http://schemas.microsoft.com/office/drawing/2014/main" id="{61D772B4-30B1-418B-A60B-C646E11E279A}"/>
               </a:ext>
             </a:extLst>
           </p:cNvPr>
@@ -5728,7 +5689,7 @@
           <p:cNvPr id="5" name="">
             <a:extLst xmlns:a="http://schemas.openxmlformats.org/drawingml/2006/main">
               <a:ext uri="{FF2B5EF4-FFF2-40B4-BE49-F238E27FC236}">
-                <a16:creationId xmlns:a16="http://schemas.microsoft.com/office/drawing/2014/main" id="{BC93F3E2-5B83-48A8-8159-DE0287EB1014}"/>
+                <a16:creationId xmlns:a16="http://schemas.microsoft.com/office/drawing/2014/main" id="{DC866B43-1FDB-497A-A3B0-0A05DBD013E5}"/>
               </a:ext>
             </a:extLst>
           </p:cNvPr>
@@ -5785,7 +5746,7 @@
           <p:cNvPr id="6" name="">
             <a:extLst xmlns:a="http://schemas.openxmlformats.org/drawingml/2006/main">
               <a:ext uri="{FF2B5EF4-FFF2-40B4-BE49-F238E27FC236}">
-                <a16:creationId xmlns:a16="http://schemas.microsoft.com/office/drawing/2014/main" id="{21B2E7AB-DFAE-45AD-AA61-BCE0B21E1A1D}"/>
+                <a16:creationId xmlns:a16="http://schemas.microsoft.com/office/drawing/2014/main" id="{EB89157E-0C97-4ECB-8EF3-ACA15C9042CD}"/>
               </a:ext>
             </a:extLst>
           </p:cNvPr>
@@ -5842,7 +5803,7 @@
           <p:cNvPr id="7" name="">
             <a:extLst xmlns:a="http://schemas.openxmlformats.org/drawingml/2006/main">
               <a:ext uri="{FF2B5EF4-FFF2-40B4-BE49-F238E27FC236}">
-                <a16:creationId xmlns:a16="http://schemas.microsoft.com/office/drawing/2014/main" id="{702573F4-6FCC-4650-8B1B-B283B409F692}"/>
+                <a16:creationId xmlns:a16="http://schemas.microsoft.com/office/drawing/2014/main" id="{28B61DF0-1072-411C-9FA8-3F2CD261D3A7}"/>
               </a:ext>
             </a:extLst>
           </p:cNvPr>
@@ -5897,7 +5858,7 @@
     </p:spTree>
     <p:extLst>
       <p:ext uri="{BB962C8B-B14F-4D97-AF65-F5344CB8AC3E}">
-        <p14:creationId xmlns:p14="http://schemas.microsoft.com/office/powerpoint/2010/main" val="2015301623"/>
+        <p14:creationId xmlns:p14="http://schemas.microsoft.com/office/powerpoint/2010/main" val="765140056"/>
       </p:ext>
     </p:extLst>
   </p:cSld>
@@ -5928,7 +5889,7 @@
           <p:cNvPr id="4" name="">
             <a:extLst xmlns:a="http://schemas.openxmlformats.org/drawingml/2006/main">
               <a:ext uri="{FF2B5EF4-FFF2-40B4-BE49-F238E27FC236}">
-                <a16:creationId xmlns:a16="http://schemas.microsoft.com/office/drawing/2014/main" id="{01E779DE-DD34-42FD-820C-A9B8DD068FBC}"/>
+                <a16:creationId xmlns:a16="http://schemas.microsoft.com/office/drawing/2014/main" id="{D25FD9FE-AD5B-4F35-846D-2880EBFA21DD}"/>
               </a:ext>
             </a:extLst>
           </p:cNvPr>
@@ -5992,7 +5953,7 @@
         </p:xfrm>
         <a:graphic xmlns:a="http://schemas.openxmlformats.org/drawingml/2006/main">
           <a:graphicData uri="http://schemas.openxmlformats.org/drawingml/2006/chart">
-            <c:chart xmlns:r="http://schemas.openxmlformats.org/officeDocument/2006/relationships" xmlns:c="http://schemas.openxmlformats.org/drawingml/2006/chart" r:id="R9838afbaccb349f0"/>
+            <c:chart xmlns:r="http://schemas.openxmlformats.org/officeDocument/2006/relationships" xmlns:c="http://schemas.openxmlformats.org/drawingml/2006/chart" r:id="Rea20fa16e3e14a59"/>
           </a:graphicData>
         </a:graphic>
       </p:graphicFrame>
@@ -6001,7 +5962,7 @@
           <p:cNvPr id="3" name="">
             <a:extLst xmlns:a="http://schemas.openxmlformats.org/drawingml/2006/main">
               <a:ext uri="{FF2B5EF4-FFF2-40B4-BE49-F238E27FC236}">
-                <a16:creationId xmlns:a16="http://schemas.microsoft.com/office/drawing/2014/main" id="{298723A8-2314-4127-BF61-B0420D69C78C}"/>
+                <a16:creationId xmlns:a16="http://schemas.microsoft.com/office/drawing/2014/main" id="{5B60C1C5-1661-44DB-986A-9521ED6E25AC}"/>
               </a:ext>
             </a:extLst>
           </p:cNvPr>
@@ -6056,7 +6017,7 @@
     </p:spTree>
     <p:extLst>
       <p:ext uri="{BB962C8B-B14F-4D97-AF65-F5344CB8AC3E}">
-        <p14:creationId xmlns:p14="http://schemas.microsoft.com/office/powerpoint/2010/main" val="627569646"/>
+        <p14:creationId xmlns:p14="http://schemas.microsoft.com/office/powerpoint/2010/main" val="838215429"/>
       </p:ext>
     </p:extLst>
   </p:cSld>
@@ -6087,7 +6048,7 @@
           <p:cNvPr id="5" name="">
             <a:extLst xmlns:a="http://schemas.openxmlformats.org/drawingml/2006/main">
               <a:ext uri="{FF2B5EF4-FFF2-40B4-BE49-F238E27FC236}">
-                <a16:creationId xmlns:a16="http://schemas.microsoft.com/office/drawing/2014/main" id="{8D0BCF85-3BFB-4765-84AF-00EE4323CAD7}"/>
+                <a16:creationId xmlns:a16="http://schemas.microsoft.com/office/drawing/2014/main" id="{2148FC85-4E12-4A3F-9903-679DE8F423C3}"/>
               </a:ext>
             </a:extLst>
           </p:cNvPr>
@@ -6151,7 +6112,7 @@
         </p:xfrm>
         <a:graphic xmlns:a="http://schemas.openxmlformats.org/drawingml/2006/main">
           <a:graphicData uri="http://schemas.openxmlformats.org/drawingml/2006/chart">
-            <c:chart xmlns:r="http://schemas.openxmlformats.org/officeDocument/2006/relationships" xmlns:c="http://schemas.openxmlformats.org/drawingml/2006/chart" r:id="R047ee1d1487a4552"/>
+            <c:chart xmlns:r="http://schemas.openxmlformats.org/officeDocument/2006/relationships" xmlns:c="http://schemas.openxmlformats.org/drawingml/2006/chart" r:id="Rf1a9513dafbd47a0"/>
           </a:graphicData>
         </a:graphic>
       </p:graphicFrame>
@@ -6160,7 +6121,7 @@
           <p:cNvPr id="3" name="">
             <a:extLst xmlns:a="http://schemas.openxmlformats.org/drawingml/2006/main">
               <a:ext uri="{FF2B5EF4-FFF2-40B4-BE49-F238E27FC236}">
-                <a16:creationId xmlns:a16="http://schemas.microsoft.com/office/drawing/2014/main" id="{35A9F095-34A6-4ECC-82A4-41599D63E929}"/>
+                <a16:creationId xmlns:a16="http://schemas.microsoft.com/office/drawing/2014/main" id="{40E8DBF7-8F78-4E44-BEFF-8DAE8E296C50}"/>
               </a:ext>
             </a:extLst>
           </p:cNvPr>
@@ -6217,7 +6178,7 @@
           <p:cNvPr id="4" name="">
             <a:extLst xmlns:a="http://schemas.openxmlformats.org/drawingml/2006/main">
               <a:ext uri="{FF2B5EF4-FFF2-40B4-BE49-F238E27FC236}">
-                <a16:creationId xmlns:a16="http://schemas.microsoft.com/office/drawing/2014/main" id="{501DD835-6427-4A94-942F-17F574F1DD80}"/>
+                <a16:creationId xmlns:a16="http://schemas.microsoft.com/office/drawing/2014/main" id="{A88CD7A7-ADAF-46F1-B0DF-850A37B422D3}"/>
               </a:ext>
             </a:extLst>
           </p:cNvPr>
@@ -6272,7 +6233,7 @@
     </p:spTree>
     <p:extLst>
       <p:ext uri="{BB962C8B-B14F-4D97-AF65-F5344CB8AC3E}">
-        <p14:creationId xmlns:p14="http://schemas.microsoft.com/office/powerpoint/2010/main" val="1469971477"/>
+        <p14:creationId xmlns:p14="http://schemas.microsoft.com/office/powerpoint/2010/main" val="1016758337"/>
       </p:ext>
     </p:extLst>
   </p:cSld>
@@ -6300,10 +6261,10 @@
       </p:grpSpPr>
       <p:sp>
         <p:nvSpPr>
-          <p:cNvPr id="4" name="">
+          <p:cNvPr id="8" name="">
             <a:extLst xmlns:a="http://schemas.openxmlformats.org/drawingml/2006/main">
               <a:ext uri="{FF2B5EF4-FFF2-40B4-BE49-F238E27FC236}">
-                <a16:creationId xmlns:a16="http://schemas.microsoft.com/office/drawing/2014/main" id="{0A0796E4-A7BE-40E7-B33B-00A46205C215}"/>
+                <a16:creationId xmlns:a16="http://schemas.microsoft.com/office/drawing/2014/main" id="{9CF7087A-B14F-46FB-BA4B-CD8627AAE36C}"/>
               </a:ext>
             </a:extLst>
           </p:cNvPr>
@@ -6350,40 +6311,302 @@
                 <a:ea typeface="DejaVu Sans"/>
                 <a:cs typeface="DejaVu Sans"/>
               </a:rPr>
-              <a:t>Agent Planning: forecast, act, replay</a:t>
+              <a:t>Agent Planning: a clear next action</a:t>
             </a:r>
           </a:p>
         </p:txBody>
       </p:sp>
-      <p:pic>
-        <p:nvPicPr>
-          <p:cNvPr id="5" name=""/>
-          <p:cNvPicPr>
-            <a:picLocks xmlns:a="http://schemas.openxmlformats.org/drawingml/2006/main" noChangeAspect="1"/>
-          </p:cNvPicPr>
+      <p:sp>
+        <p:nvSpPr>
+          <p:cNvPr id="2" name="">
+            <a:extLst xmlns:a="http://schemas.openxmlformats.org/drawingml/2006/main">
+              <a:ext uri="{FF2B5EF4-FFF2-40B4-BE49-F238E27FC236}">
+                <a16:creationId xmlns:a16="http://schemas.microsoft.com/office/drawing/2014/main" id="{947174CB-7BC8-4DA8-8EBE-ED08BC8EA150}"/>
+              </a:ext>
+            </a:extLst>
+          </p:cNvPr>
+          <p:cNvSpPr>
+            <a:spLocks xmlns:a="http://schemas.openxmlformats.org/drawingml/2006/main" noGrp="1"/>
+          </p:cNvSpPr>
           <p:nvPr/>
-        </p:nvPicPr>
-        <p:blipFill>
-          <a:blip xmlns:r="http://schemas.openxmlformats.org/officeDocument/2006/relationships" xmlns:a="http://schemas.openxmlformats.org/drawingml/2006/main" r:embed="Rca7531f926bd40f5"/>
-          <a:srcRect xmlns:a="http://schemas.openxmlformats.org/drawingml/2006/main" l="26400" t="16000" r="5560" b="49000"/>
-          <a:stretch xmlns:a="http://schemas.openxmlformats.org/drawingml/2006/main"/>
-        </p:blipFill>
+        </p:nvSpPr>
         <p:spPr>
           <a:xfrm xmlns:a="http://schemas.openxmlformats.org/drawingml/2006/main">
-            <a:off x="590550" y="1524000"/>
-            <a:ext cx="11010900" cy="3933825"/>
+            <a:off x="666750" y="1619250"/>
+            <a:ext cx="10477500" cy="523875"/>
           </a:xfrm>
           <a:prstGeom xmlns:a="http://schemas.openxmlformats.org/drawingml/2006/main" prst="rect">
             <a:avLst/>
           </a:prstGeom>
+          <a:noFill xmlns:a="http://schemas.openxmlformats.org/drawingml/2006/main"/>
+          <a:ln xmlns:a="http://schemas.openxmlformats.org/drawingml/2006/main" w="0">
+            <a:noFill/>
+          </a:ln>
         </p:spPr>
-      </p:pic>
+        <p:txBody>
+          <a:bodyPr xmlns:a="http://schemas.openxmlformats.org/drawingml/2006/main">
+            <a:noAutofit/>
+          </a:bodyPr>
+          <a:lstStyle xmlns:a="http://schemas.openxmlformats.org/drawingml/2006/main"/>
+          <a:p xmlns:a="http://schemas.openxmlformats.org/drawingml/2006/main">
+            <a:pPr>
+              <a:defRPr sz="2400" b="1">
+                <a:solidFill>
+                  <a:srgbClr val="07866E"/>
+                </a:solidFill>
+                <a:latin typeface="DejaVu Sans"/>
+                <a:ea typeface="DejaVu Sans"/>
+                <a:cs typeface="DejaVu Sans"/>
+              </a:defRPr>
+            </a:pPr>
+            <a:r>
+              <a:rPr sz="2400" b="1">
+                <a:solidFill>
+                  <a:srgbClr val="07866E"/>
+                </a:solidFill>
+                <a:latin typeface="DejaVu Sans"/>
+                <a:ea typeface="DejaVu Sans"/>
+                <a:cs typeface="DejaVu Sans"/>
+              </a:rPr>
+              <a:t>Inputs visible to agent</a:t>
+            </a:r>
+          </a:p>
+        </p:txBody>
+      </p:sp>
       <p:sp>
         <p:nvSpPr>
           <p:cNvPr id="3" name="">
             <a:extLst xmlns:a="http://schemas.openxmlformats.org/drawingml/2006/main">
               <a:ext uri="{FF2B5EF4-FFF2-40B4-BE49-F238E27FC236}">
-                <a16:creationId xmlns:a16="http://schemas.microsoft.com/office/drawing/2014/main" id="{D1E532FE-1071-46D4-A5A0-C03C65A6ABA5}"/>
+                <a16:creationId xmlns:a16="http://schemas.microsoft.com/office/drawing/2014/main" id="{239B680C-619D-45DE-8214-F99924F8C94B}"/>
+              </a:ext>
+            </a:extLst>
+          </p:cNvPr>
+          <p:cNvSpPr>
+            <a:spLocks xmlns:a="http://schemas.openxmlformats.org/drawingml/2006/main" noGrp="1"/>
+          </p:cNvSpPr>
+          <p:nvPr/>
+        </p:nvSpPr>
+        <p:spPr>
+          <a:xfrm xmlns:a="http://schemas.openxmlformats.org/drawingml/2006/main">
+            <a:off x="666750" y="2190750"/>
+            <a:ext cx="10477500" cy="523875"/>
+          </a:xfrm>
+          <a:prstGeom xmlns:a="http://schemas.openxmlformats.org/drawingml/2006/main" prst="rect">
+            <a:avLst/>
+          </a:prstGeom>
+          <a:noFill xmlns:a="http://schemas.openxmlformats.org/drawingml/2006/main"/>
+          <a:ln xmlns:a="http://schemas.openxmlformats.org/drawingml/2006/main" w="0">
+            <a:noFill/>
+          </a:ln>
+        </p:spPr>
+        <p:txBody>
+          <a:bodyPr xmlns:a="http://schemas.openxmlformats.org/drawingml/2006/main">
+            <a:noAutofit/>
+          </a:bodyPr>
+          <a:lstStyle xmlns:a="http://schemas.openxmlformats.org/drawingml/2006/main"/>
+          <a:p xmlns:a="http://schemas.openxmlformats.org/drawingml/2006/main">
+            <a:pPr>
+              <a:defRPr sz="2325" b="0">
+                <a:solidFill>
+                  <a:srgbClr val="14283E"/>
+                </a:solidFill>
+                <a:latin typeface="DejaVu Sans"/>
+                <a:ea typeface="DejaVu Sans"/>
+                <a:cs typeface="DejaVu Sans"/>
+              </a:defRPr>
+            </a:pPr>
+            <a:r>
+              <a:rPr sz="2325" b="0">
+                <a:solidFill>
+                  <a:srgbClr val="14283E"/>
+                </a:solidFill>
+                <a:latin typeface="DejaVu Sans"/>
+                <a:ea typeface="DejaVu Sans"/>
+                <a:cs typeface="DejaVu Sans"/>
+              </a:rPr>
+              <a:t>Counted physical cash + sample electronic float</a:t>
+            </a:r>
+          </a:p>
+        </p:txBody>
+      </p:sp>
+      <p:sp>
+        <p:nvSpPr>
+          <p:cNvPr id="4" name="">
+            <a:extLst xmlns:a="http://schemas.openxmlformats.org/drawingml/2006/main">
+              <a:ext uri="{FF2B5EF4-FFF2-40B4-BE49-F238E27FC236}">
+                <a16:creationId xmlns:a16="http://schemas.microsoft.com/office/drawing/2014/main" id="{0D0DB649-923A-4FFA-B42B-8E34C079CDFF}"/>
+              </a:ext>
+            </a:extLst>
+          </p:cNvPr>
+          <p:cNvSpPr>
+            <a:spLocks xmlns:a="http://schemas.openxmlformats.org/drawingml/2006/main" noGrp="1"/>
+          </p:cNvSpPr>
+          <p:nvPr/>
+        </p:nvSpPr>
+        <p:spPr>
+          <a:xfrm xmlns:a="http://schemas.openxmlformats.org/drawingml/2006/main">
+            <a:off x="666750" y="3143250"/>
+            <a:ext cx="10477500" cy="523875"/>
+          </a:xfrm>
+          <a:prstGeom xmlns:a="http://schemas.openxmlformats.org/drawingml/2006/main" prst="rect">
+            <a:avLst/>
+          </a:prstGeom>
+          <a:noFill xmlns:a="http://schemas.openxmlformats.org/drawingml/2006/main"/>
+          <a:ln xmlns:a="http://schemas.openxmlformats.org/drawingml/2006/main" w="0">
+            <a:noFill/>
+          </a:ln>
+        </p:spPr>
+        <p:txBody>
+          <a:bodyPr xmlns:a="http://schemas.openxmlformats.org/drawingml/2006/main">
+            <a:noAutofit/>
+          </a:bodyPr>
+          <a:lstStyle xmlns:a="http://schemas.openxmlformats.org/drawingml/2006/main"/>
+          <a:p xmlns:a="http://schemas.openxmlformats.org/drawingml/2006/main">
+            <a:pPr>
+              <a:defRPr sz="2400" b="1">
+                <a:solidFill>
+                  <a:srgbClr val="07866E"/>
+                </a:solidFill>
+                <a:latin typeface="DejaVu Sans"/>
+                <a:ea typeface="DejaVu Sans"/>
+                <a:cs typeface="DejaVu Sans"/>
+              </a:defRPr>
+            </a:pPr>
+            <a:r>
+              <a:rPr sz="2400" b="1">
+                <a:solidFill>
+                  <a:srgbClr val="07866E"/>
+                </a:solidFill>
+                <a:latin typeface="DejaVu Sans"/>
+                <a:ea typeface="DejaVu Sans"/>
+                <a:cs typeface="DejaVu Sans"/>
+              </a:rPr>
+              <a:t>Suggestion</a:t>
+            </a:r>
+          </a:p>
+        </p:txBody>
+      </p:sp>
+      <p:sp>
+        <p:nvSpPr>
+          <p:cNvPr id="5" name="">
+            <a:extLst xmlns:a="http://schemas.openxmlformats.org/drawingml/2006/main">
+              <a:ext uri="{FF2B5EF4-FFF2-40B4-BE49-F238E27FC236}">
+                <a16:creationId xmlns:a16="http://schemas.microsoft.com/office/drawing/2014/main" id="{1A3B08E5-7F6C-4DB6-9779-7DB375ECAC22}"/>
+              </a:ext>
+            </a:extLst>
+          </p:cNvPr>
+          <p:cNvSpPr>
+            <a:spLocks xmlns:a="http://schemas.openxmlformats.org/drawingml/2006/main" noGrp="1"/>
+          </p:cNvSpPr>
+          <p:nvPr/>
+        </p:nvSpPr>
+        <p:spPr>
+          <a:xfrm xmlns:a="http://schemas.openxmlformats.org/drawingml/2006/main">
+            <a:off x="666750" y="3714750"/>
+            <a:ext cx="10572750" cy="904875"/>
+          </a:xfrm>
+          <a:prstGeom xmlns:a="http://schemas.openxmlformats.org/drawingml/2006/main" prst="rect">
+            <a:avLst/>
+          </a:prstGeom>
+          <a:noFill xmlns:a="http://schemas.openxmlformats.org/drawingml/2006/main"/>
+          <a:ln xmlns:a="http://schemas.openxmlformats.org/drawingml/2006/main" w="0">
+            <a:noFill/>
+          </a:ln>
+        </p:spPr>
+        <p:txBody>
+          <a:bodyPr xmlns:a="http://schemas.openxmlformats.org/drawingml/2006/main">
+            <a:noAutofit/>
+          </a:bodyPr>
+          <a:lstStyle xmlns:a="http://schemas.openxmlformats.org/drawingml/2006/main"/>
+          <a:p xmlns:a="http://schemas.openxmlformats.org/drawingml/2006/main">
+            <a:pPr>
+              <a:defRPr sz="2250" b="1">
+                <a:solidFill>
+                  <a:srgbClr val="14283E"/>
+                </a:solidFill>
+                <a:latin typeface="DejaVu Sans"/>
+                <a:ea typeface="DejaVu Sans"/>
+                <a:cs typeface="DejaVu Sans"/>
+              </a:defRPr>
+            </a:pPr>
+            <a:r>
+              <a:rPr sz="2250" b="1">
+                <a:solidFill>
+                  <a:srgbClr val="14283E"/>
+                </a:solidFill>
+                <a:latin typeface="DejaVu Sans"/>
+                <a:ea typeface="DejaVu Sans"/>
+                <a:cs typeface="DejaVu Sans"/>
+              </a:rPr>
+              <a:t>Exchange an affordable amount before the busy hour, or keep balances.</a:t>
+            </a:r>
+          </a:p>
+        </p:txBody>
+      </p:sp>
+      <p:sp>
+        <p:nvSpPr>
+          <p:cNvPr id="6" name="">
+            <a:extLst xmlns:a="http://schemas.openxmlformats.org/drawingml/2006/main">
+              <a:ext uri="{FF2B5EF4-FFF2-40B4-BE49-F238E27FC236}">
+                <a16:creationId xmlns:a16="http://schemas.microsoft.com/office/drawing/2014/main" id="{7AB27E2D-7112-4A00-9414-B6E4347B4A3F}"/>
+              </a:ext>
+            </a:extLst>
+          </p:cNvPr>
+          <p:cNvSpPr>
+            <a:spLocks xmlns:a="http://schemas.openxmlformats.org/drawingml/2006/main" noGrp="1"/>
+          </p:cNvSpPr>
+          <p:nvPr/>
+        </p:nvSpPr>
+        <p:spPr>
+          <a:xfrm xmlns:a="http://schemas.openxmlformats.org/drawingml/2006/main">
+            <a:off x="666750" y="5095875"/>
+            <a:ext cx="10572750" cy="619125"/>
+          </a:xfrm>
+          <a:prstGeom xmlns:a="http://schemas.openxmlformats.org/drawingml/2006/main" prst="rect">
+            <a:avLst/>
+          </a:prstGeom>
+          <a:noFill xmlns:a="http://schemas.openxmlformats.org/drawingml/2006/main"/>
+          <a:ln xmlns:a="http://schemas.openxmlformats.org/drawingml/2006/main" w="0">
+            <a:noFill/>
+          </a:ln>
+        </p:spPr>
+        <p:txBody>
+          <a:bodyPr xmlns:a="http://schemas.openxmlformats.org/drawingml/2006/main">
+            <a:noAutofit/>
+          </a:bodyPr>
+          <a:lstStyle xmlns:a="http://schemas.openxmlformats.org/drawingml/2006/main"/>
+          <a:p xmlns:a="http://schemas.openxmlformats.org/drawingml/2006/main">
+            <a:pPr>
+              <a:defRPr sz="1875" b="0">
+                <a:solidFill>
+                  <a:srgbClr val="14283E"/>
+                </a:solidFill>
+                <a:latin typeface="DejaVu Sans"/>
+                <a:ea typeface="DejaVu Sans"/>
+                <a:cs typeface="DejaVu Sans"/>
+              </a:defRPr>
+            </a:pPr>
+            <a:r>
+              <a:rPr sz="1875" b="0">
+                <a:solidFill>
+                  <a:srgbClr val="14283E"/>
+                </a:solidFill>
+                <a:latin typeface="DejaVu Sans"/>
+                <a:ea typeface="DejaVu Sans"/>
+                <a:cs typeface="DejaVu Sans"/>
+              </a:rPr>
+              <a:t>Why: fictional transaction history, forecast cash-in/out, assumed exchange cost.</a:t>
+            </a:r>
+          </a:p>
+        </p:txBody>
+      </p:sp>
+      <p:sp>
+        <p:nvSpPr>
+          <p:cNvPr id="7" name="">
+            <a:extLst xmlns:a="http://schemas.openxmlformats.org/drawingml/2006/main">
+              <a:ext uri="{FF2B5EF4-FFF2-40B4-BE49-F238E27FC236}">
+                <a16:creationId xmlns:a16="http://schemas.microsoft.com/office/drawing/2014/main" id="{C03B3FBA-BF2E-4A94-BD4F-A0AE8B426F87}"/>
               </a:ext>
             </a:extLst>
           </p:cNvPr>
@@ -6430,7 +6653,7 @@
                 <a:ea typeface="DejaVu Sans"/>
                 <a:cs typeface="DejaVu Sans"/>
               </a:rPr>
-              <a:t>Try high exchange costs, low capital and an unannounced cash-out surge.</a:t>
+              <a:t>The actual synthetic day can be revealed for a same-demand comparison.</a:t>
             </a:r>
           </a:p>
         </p:txBody>
@@ -6438,7 +6661,7 @@
     </p:spTree>
     <p:extLst>
       <p:ext uri="{BB962C8B-B14F-4D97-AF65-F5344CB8AC3E}">
-        <p14:creationId xmlns:p14="http://schemas.microsoft.com/office/powerpoint/2010/main" val="1337940089"/>
+        <p14:creationId xmlns:p14="http://schemas.microsoft.com/office/powerpoint/2010/main" val="1698463695"/>
       </p:ext>
     </p:extLst>
   </p:cSld>
@@ -6466,10 +6689,10 @@
       </p:grpSpPr>
       <p:sp>
         <p:nvSpPr>
-          <p:cNvPr id="4" name="">
+          <p:cNvPr id="8" name="">
             <a:extLst xmlns:a="http://schemas.openxmlformats.org/drawingml/2006/main">
               <a:ext uri="{FF2B5EF4-FFF2-40B4-BE49-F238E27FC236}">
-                <a16:creationId xmlns:a16="http://schemas.microsoft.com/office/drawing/2014/main" id="{9BA7C5D7-597D-44CF-A64D-69EDE3E6B470}"/>
+                <a16:creationId xmlns:a16="http://schemas.microsoft.com/office/drawing/2014/main" id="{B95211E8-F23C-4A1F-B5EB-4E242BBAA681}"/>
               </a:ext>
             </a:extLst>
           </p:cNvPr>
@@ -6516,40 +6739,302 @@
                 <a:ea typeface="DejaVu Sans"/>
                 <a:cs typeface="DejaVu Sans"/>
               </a:rPr>
-              <a:t>Payment Safety: evidence before action</a:t>
+              <a:t>Payment Safety: explain each signal</a:t>
             </a:r>
           </a:p>
         </p:txBody>
       </p:sp>
-      <p:pic>
-        <p:nvPicPr>
-          <p:cNvPr id="5" name=""/>
-          <p:cNvPicPr>
-            <a:picLocks xmlns:a="http://schemas.openxmlformats.org/drawingml/2006/main" noChangeAspect="1"/>
-          </p:cNvPicPr>
+      <p:sp>
+        <p:nvSpPr>
+          <p:cNvPr id="2" name="">
+            <a:extLst xmlns:a="http://schemas.openxmlformats.org/drawingml/2006/main">
+              <a:ext uri="{FF2B5EF4-FFF2-40B4-BE49-F238E27FC236}">
+                <a16:creationId xmlns:a16="http://schemas.microsoft.com/office/drawing/2014/main" id="{695C25C4-0A1C-4938-8E6E-FE83DCA9E0AE}"/>
+              </a:ext>
+            </a:extLst>
+          </p:cNvPr>
+          <p:cNvSpPr>
+            <a:spLocks xmlns:a="http://schemas.openxmlformats.org/drawingml/2006/main" noGrp="1"/>
+          </p:cNvSpPr>
           <p:nvPr/>
-        </p:nvPicPr>
-        <p:blipFill>
-          <a:blip xmlns:r="http://schemas.openxmlformats.org/officeDocument/2006/relationships" xmlns:a="http://schemas.openxmlformats.org/drawingml/2006/main" r:embed="Rd76cda10a8c74b51"/>
-          <a:srcRect xmlns:a="http://schemas.openxmlformats.org/drawingml/2006/main" l="26400" t="30000" r="5560" b="15000"/>
-          <a:stretch xmlns:a="http://schemas.openxmlformats.org/drawingml/2006/main"/>
-        </p:blipFill>
+        </p:nvSpPr>
         <p:spPr>
           <a:xfrm xmlns:a="http://schemas.openxmlformats.org/drawingml/2006/main">
-            <a:off x="2095500" y="1362075"/>
-            <a:ext cx="8001000" cy="4495800"/>
+            <a:off x="666750" y="1666875"/>
+            <a:ext cx="10572750" cy="523875"/>
           </a:xfrm>
           <a:prstGeom xmlns:a="http://schemas.openxmlformats.org/drawingml/2006/main" prst="rect">
             <a:avLst/>
           </a:prstGeom>
+          <a:noFill xmlns:a="http://schemas.openxmlformats.org/drawingml/2006/main"/>
+          <a:ln xmlns:a="http://schemas.openxmlformats.org/drawingml/2006/main" w="0">
+            <a:noFill/>
+          </a:ln>
         </p:spPr>
-      </p:pic>
+        <p:txBody>
+          <a:bodyPr xmlns:a="http://schemas.openxmlformats.org/drawingml/2006/main">
+            <a:noAutofit/>
+          </a:bodyPr>
+          <a:lstStyle xmlns:a="http://schemas.openxmlformats.org/drawingml/2006/main"/>
+          <a:p xmlns:a="http://schemas.openxmlformats.org/drawingml/2006/main">
+            <a:pPr>
+              <a:defRPr sz="2400" b="1">
+                <a:solidFill>
+                  <a:srgbClr val="07866E"/>
+                </a:solidFill>
+                <a:latin typeface="DejaVu Sans"/>
+                <a:ea typeface="DejaVu Sans"/>
+                <a:cs typeface="DejaVu Sans"/>
+              </a:defRPr>
+            </a:pPr>
+            <a:r>
+              <a:rPr sz="2400" b="1">
+                <a:solidFill>
+                  <a:srgbClr val="07866E"/>
+                </a:solidFill>
+                <a:latin typeface="DejaVu Sans"/>
+                <a:ea typeface="DejaVu Sans"/>
+                <a:cs typeface="DejaVu Sans"/>
+              </a:rPr>
+              <a:t>Customer enters</a:t>
+            </a:r>
+          </a:p>
+        </p:txBody>
+      </p:sp>
       <p:sp>
         <p:nvSpPr>
           <p:cNvPr id="3" name="">
             <a:extLst xmlns:a="http://schemas.openxmlformats.org/drawingml/2006/main">
               <a:ext uri="{FF2B5EF4-FFF2-40B4-BE49-F238E27FC236}">
-                <a16:creationId xmlns:a16="http://schemas.microsoft.com/office/drawing/2014/main" id="{D98CF291-7170-4E04-B2E7-A79BA5FFDAC9}"/>
+                <a16:creationId xmlns:a16="http://schemas.microsoft.com/office/drawing/2014/main" id="{F07CFADA-62E3-41EF-9D3B-3543F2C2232A}"/>
+              </a:ext>
+            </a:extLst>
+          </p:cNvPr>
+          <p:cNvSpPr>
+            <a:spLocks xmlns:a="http://schemas.openxmlformats.org/drawingml/2006/main" noGrp="1"/>
+          </p:cNvSpPr>
+          <p:nvPr/>
+        </p:nvSpPr>
+        <p:spPr>
+          <a:xfrm xmlns:a="http://schemas.openxmlformats.org/drawingml/2006/main">
+            <a:off x="666750" y="2209800"/>
+            <a:ext cx="10572750" cy="571500"/>
+          </a:xfrm>
+          <a:prstGeom xmlns:a="http://schemas.openxmlformats.org/drawingml/2006/main" prst="rect">
+            <a:avLst/>
+          </a:prstGeom>
+          <a:noFill xmlns:a="http://schemas.openxmlformats.org/drawingml/2006/main"/>
+          <a:ln xmlns:a="http://schemas.openxmlformats.org/drawingml/2006/main" w="0">
+            <a:noFill/>
+          </a:ln>
+        </p:spPr>
+        <p:txBody>
+          <a:bodyPr xmlns:a="http://schemas.openxmlformats.org/drawingml/2006/main">
+            <a:noAutofit/>
+          </a:bodyPr>
+          <a:lstStyle xmlns:a="http://schemas.openxmlformats.org/drawingml/2006/main"/>
+          <a:p xmlns:a="http://schemas.openxmlformats.org/drawingml/2006/main">
+            <a:pPr>
+              <a:defRPr sz="2325" b="0">
+                <a:solidFill>
+                  <a:srgbClr val="14283E"/>
+                </a:solidFill>
+                <a:latin typeface="DejaVu Sans"/>
+                <a:ea typeface="DejaVu Sans"/>
+                <a:cs typeface="DejaVu Sans"/>
+              </a:defRPr>
+            </a:pPr>
+            <a:r>
+              <a:rPr sz="2325" b="0">
+                <a:solidFill>
+                  <a:srgbClr val="14283E"/>
+                </a:solidFill>
+                <a:latin typeface="DejaVu Sans"/>
+                <a:ea typeface="DejaVu Sans"/>
+                <a:cs typeface="DejaVu Sans"/>
+              </a:rPr>
+              <a:t>Amount and optional reason for sending</a:t>
+            </a:r>
+          </a:p>
+        </p:txBody>
+      </p:sp>
+      <p:sp>
+        <p:nvSpPr>
+          <p:cNvPr id="4" name="">
+            <a:extLst xmlns:a="http://schemas.openxmlformats.org/drawingml/2006/main">
+              <a:ext uri="{FF2B5EF4-FFF2-40B4-BE49-F238E27FC236}">
+                <a16:creationId xmlns:a16="http://schemas.microsoft.com/office/drawing/2014/main" id="{E77A0D67-2DD4-4D2B-AB4A-6BCB5A3C11AB}"/>
+              </a:ext>
+            </a:extLst>
+          </p:cNvPr>
+          <p:cNvSpPr>
+            <a:spLocks xmlns:a="http://schemas.openxmlformats.org/drawingml/2006/main" noGrp="1"/>
+          </p:cNvSpPr>
+          <p:nvPr/>
+        </p:nvSpPr>
+        <p:spPr>
+          <a:xfrm xmlns:a="http://schemas.openxmlformats.org/drawingml/2006/main">
+            <a:off x="666750" y="3286125"/>
+            <a:ext cx="10572750" cy="523875"/>
+          </a:xfrm>
+          <a:prstGeom xmlns:a="http://schemas.openxmlformats.org/drawingml/2006/main" prst="rect">
+            <a:avLst/>
+          </a:prstGeom>
+          <a:noFill xmlns:a="http://schemas.openxmlformats.org/drawingml/2006/main"/>
+          <a:ln xmlns:a="http://schemas.openxmlformats.org/drawingml/2006/main" w="0">
+            <a:noFill/>
+          </a:ln>
+        </p:spPr>
+        <p:txBody>
+          <a:bodyPr xmlns:a="http://schemas.openxmlformats.org/drawingml/2006/main">
+            <a:noAutofit/>
+          </a:bodyPr>
+          <a:lstStyle xmlns:a="http://schemas.openxmlformats.org/drawingml/2006/main"/>
+          <a:p xmlns:a="http://schemas.openxmlformats.org/drawingml/2006/main">
+            <a:pPr>
+              <a:defRPr sz="2400" b="1">
+                <a:solidFill>
+                  <a:srgbClr val="07866E"/>
+                </a:solidFill>
+                <a:latin typeface="DejaVu Sans"/>
+                <a:ea typeface="DejaVu Sans"/>
+                <a:cs typeface="DejaVu Sans"/>
+              </a:defRPr>
+            </a:pPr>
+            <a:r>
+              <a:rPr sz="2400" b="1">
+                <a:solidFill>
+                  <a:srgbClr val="07866E"/>
+                </a:solidFill>
+                <a:latin typeface="DejaVu Sans"/>
+                <a:ea typeface="DejaVu Sans"/>
+                <a:cs typeface="DejaVu Sans"/>
+              </a:rPr>
+              <a:t>Fictional history provides</a:t>
+            </a:r>
+          </a:p>
+        </p:txBody>
+      </p:sp>
+      <p:sp>
+        <p:nvSpPr>
+          <p:cNvPr id="5" name="">
+            <a:extLst xmlns:a="http://schemas.openxmlformats.org/drawingml/2006/main">
+              <a:ext uri="{FF2B5EF4-FFF2-40B4-BE49-F238E27FC236}">
+                <a16:creationId xmlns:a16="http://schemas.microsoft.com/office/drawing/2014/main" id="{A1F44D1C-895E-42B7-99DE-A0A768E1FF38}"/>
+              </a:ext>
+            </a:extLst>
+          </p:cNvPr>
+          <p:cNvSpPr>
+            <a:spLocks xmlns:a="http://schemas.openxmlformats.org/drawingml/2006/main" noGrp="1"/>
+          </p:cNvSpPr>
+          <p:nvPr/>
+        </p:nvSpPr>
+        <p:spPr>
+          <a:xfrm xmlns:a="http://schemas.openxmlformats.org/drawingml/2006/main">
+            <a:off x="666750" y="3829050"/>
+            <a:ext cx="10572750" cy="619125"/>
+          </a:xfrm>
+          <a:prstGeom xmlns:a="http://schemas.openxmlformats.org/drawingml/2006/main" prst="rect">
+            <a:avLst/>
+          </a:prstGeom>
+          <a:noFill xmlns:a="http://schemas.openxmlformats.org/drawingml/2006/main"/>
+          <a:ln xmlns:a="http://schemas.openxmlformats.org/drawingml/2006/main" w="0">
+            <a:noFill/>
+          </a:ln>
+        </p:spPr>
+        <p:txBody>
+          <a:bodyPr xmlns:a="http://schemas.openxmlformats.org/drawingml/2006/main">
+            <a:noAutofit/>
+          </a:bodyPr>
+          <a:lstStyle xmlns:a="http://schemas.openxmlformats.org/drawingml/2006/main"/>
+          <a:p xmlns:a="http://schemas.openxmlformats.org/drawingml/2006/main">
+            <a:pPr>
+              <a:defRPr sz="2325" b="0">
+                <a:solidFill>
+                  <a:srgbClr val="14283E"/>
+                </a:solidFill>
+                <a:latin typeface="DejaVu Sans"/>
+                <a:ea typeface="DejaVu Sans"/>
+                <a:cs typeface="DejaVu Sans"/>
+              </a:defRPr>
+            </a:pPr>
+            <a:r>
+              <a:rPr sz="2325" b="0">
+                <a:solidFill>
+                  <a:srgbClr val="14283E"/>
+                </a:solidFill>
+                <a:latin typeface="DejaVu Sans"/>
+                <a:ea typeface="DejaVu Sans"/>
+                <a:cs typeface="DejaVu Sans"/>
+              </a:rPr>
+              <a:t>Usual amount and whether this is a first payment</a:t>
+            </a:r>
+          </a:p>
+        </p:txBody>
+      </p:sp>
+      <p:sp>
+        <p:nvSpPr>
+          <p:cNvPr id="6" name="">
+            <a:extLst xmlns:a="http://schemas.openxmlformats.org/drawingml/2006/main">
+              <a:ext uri="{FF2B5EF4-FFF2-40B4-BE49-F238E27FC236}">
+                <a16:creationId xmlns:a16="http://schemas.microsoft.com/office/drawing/2014/main" id="{373EAD3C-2E3D-40B6-BD5E-6024E3BABE7B}"/>
+              </a:ext>
+            </a:extLst>
+          </p:cNvPr>
+          <p:cNvSpPr>
+            <a:spLocks xmlns:a="http://schemas.openxmlformats.org/drawingml/2006/main" noGrp="1"/>
+          </p:cNvSpPr>
+          <p:nvPr/>
+        </p:nvSpPr>
+        <p:spPr>
+          <a:xfrm xmlns:a="http://schemas.openxmlformats.org/drawingml/2006/main">
+            <a:off x="666750" y="5143500"/>
+            <a:ext cx="10668000" cy="666750"/>
+          </a:xfrm>
+          <a:prstGeom xmlns:a="http://schemas.openxmlformats.org/drawingml/2006/main" prst="rect">
+            <a:avLst/>
+          </a:prstGeom>
+          <a:noFill xmlns:a="http://schemas.openxmlformats.org/drawingml/2006/main"/>
+          <a:ln xmlns:a="http://schemas.openxmlformats.org/drawingml/2006/main" w="0">
+            <a:noFill/>
+          </a:ln>
+        </p:spPr>
+        <p:txBody>
+          <a:bodyPr xmlns:a="http://schemas.openxmlformats.org/drawingml/2006/main">
+            <a:noAutofit/>
+          </a:bodyPr>
+          <a:lstStyle xmlns:a="http://schemas.openxmlformats.org/drawingml/2006/main"/>
+          <a:p xmlns:a="http://schemas.openxmlformats.org/drawingml/2006/main">
+            <a:pPr>
+              <a:defRPr sz="2025" b="1">
+                <a:solidFill>
+                  <a:srgbClr val="14283E"/>
+                </a:solidFill>
+                <a:latin typeface="DejaVu Sans"/>
+                <a:ea typeface="DejaVu Sans"/>
+                <a:cs typeface="DejaVu Sans"/>
+              </a:defRPr>
+            </a:pPr>
+            <a:r>
+              <a:rPr sz="2025" b="1">
+                <a:solidFill>
+                  <a:srgbClr val="14283E"/>
+                </a:solidFill>
+                <a:latin typeface="DejaVu Sans"/>
+                <a:ea typeface="DejaVu Sans"/>
+                <a:cs typeface="DejaVu Sans"/>
+              </a:rPr>
+              <a:t>Output: concern, reasons, independent verification and a demo choice.</a:t>
+            </a:r>
+          </a:p>
+        </p:txBody>
+      </p:sp>
+      <p:sp>
+        <p:nvSpPr>
+          <p:cNvPr id="7" name="">
+            <a:extLst xmlns:a="http://schemas.openxmlformats.org/drawingml/2006/main">
+              <a:ext uri="{FF2B5EF4-FFF2-40B4-BE49-F238E27FC236}">
+                <a16:creationId xmlns:a16="http://schemas.microsoft.com/office/drawing/2014/main" id="{68A724C9-96FC-4AC4-A288-D2502C335D40}"/>
               </a:ext>
             </a:extLst>
           </p:cNvPr>
@@ -6596,7 +7081,7 @@
                 <a:ea typeface="DejaVu Sans"/>
                 <a:cs typeface="DejaVu Sans"/>
               </a:rPr>
-              <a:t>Text classifier + explicit context rules · No real transfer, accusation or account restriction</a:t>
+              <a:t>A legitimate hospital bill may still raise concern · No real money moves</a:t>
             </a:r>
           </a:p>
         </p:txBody>
@@ -6604,7 +7089,7 @@
     </p:spTree>
     <p:extLst>
       <p:ext uri="{BB962C8B-B14F-4D97-AF65-F5344CB8AC3E}">
-        <p14:creationId xmlns:p14="http://schemas.microsoft.com/office/powerpoint/2010/main" val="972429379"/>
+        <p14:creationId xmlns:p14="http://schemas.microsoft.com/office/powerpoint/2010/main" val="1628488048"/>
       </p:ext>
     </p:extLst>
   </p:cSld>
@@ -6635,7 +7120,7 @@
           <p:cNvPr id="5" name="">
             <a:extLst xmlns:a="http://schemas.openxmlformats.org/drawingml/2006/main">
               <a:ext uri="{FF2B5EF4-FFF2-40B4-BE49-F238E27FC236}">
-                <a16:creationId xmlns:a16="http://schemas.microsoft.com/office/drawing/2014/main" id="{1D40B3B4-D989-4C11-A211-7CA274CDAB20}"/>
+                <a16:creationId xmlns:a16="http://schemas.microsoft.com/office/drawing/2014/main" id="{0A42C3AA-86F0-4305-B45B-313B44A26D45}"/>
               </a:ext>
             </a:extLst>
           </p:cNvPr>
@@ -6699,7 +7184,7 @@
         </p:xfrm>
         <a:graphic xmlns:a="http://schemas.openxmlformats.org/drawingml/2006/main">
           <a:graphicData uri="http://schemas.openxmlformats.org/drawingml/2006/chart">
-            <c:chart xmlns:r="http://schemas.openxmlformats.org/officeDocument/2006/relationships" xmlns:c="http://schemas.openxmlformats.org/drawingml/2006/chart" r:id="R4bc6606c89ef4af9"/>
+            <c:chart xmlns:r="http://schemas.openxmlformats.org/officeDocument/2006/relationships" xmlns:c="http://schemas.openxmlformats.org/drawingml/2006/chart" r:id="R481f118c9f504943"/>
           </a:graphicData>
         </a:graphic>
       </p:graphicFrame>
@@ -6708,7 +7193,7 @@
           <p:cNvPr id="3" name="">
             <a:extLst xmlns:a="http://schemas.openxmlformats.org/drawingml/2006/main">
               <a:ext uri="{FF2B5EF4-FFF2-40B4-BE49-F238E27FC236}">
-                <a16:creationId xmlns:a16="http://schemas.microsoft.com/office/drawing/2014/main" id="{F0F703CA-3F6F-40C7-9F5E-24BE512D1FD0}"/>
+                <a16:creationId xmlns:a16="http://schemas.microsoft.com/office/drawing/2014/main" id="{4B7BC5BB-81D6-40C2-B1DE-1BBBFF5CA4B7}"/>
               </a:ext>
             </a:extLst>
           </p:cNvPr>
@@ -6765,7 +7250,7 @@
           <p:cNvPr id="4" name="">
             <a:extLst xmlns:a="http://schemas.openxmlformats.org/drawingml/2006/main">
               <a:ext uri="{FF2B5EF4-FFF2-40B4-BE49-F238E27FC236}">
-                <a16:creationId xmlns:a16="http://schemas.microsoft.com/office/drawing/2014/main" id="{634EEFB3-1B85-435A-B355-0628D0D8BE83}"/>
+                <a16:creationId xmlns:a16="http://schemas.microsoft.com/office/drawing/2014/main" id="{D5CDA3FE-2899-4C84-B0E8-A7C4BDC05347}"/>
               </a:ext>
             </a:extLst>
           </p:cNvPr>
@@ -6820,7 +7305,7 @@
     </p:spTree>
     <p:extLst>
       <p:ext uri="{BB962C8B-B14F-4D97-AF65-F5344CB8AC3E}">
-        <p14:creationId xmlns:p14="http://schemas.microsoft.com/office/powerpoint/2010/main" val="1685094947"/>
+        <p14:creationId xmlns:p14="http://schemas.microsoft.com/office/powerpoint/2010/main" val="1036903283"/>
       </p:ext>
     </p:extLst>
   </p:cSld>
@@ -6851,7 +7336,7 @@
           <p:cNvPr id="8" name="">
             <a:extLst xmlns:a="http://schemas.openxmlformats.org/drawingml/2006/main">
               <a:ext uri="{FF2B5EF4-FFF2-40B4-BE49-F238E27FC236}">
-                <a16:creationId xmlns:a16="http://schemas.microsoft.com/office/drawing/2014/main" id="{14577F38-909E-4DA3-B3A6-E80B9A849D79}"/>
+                <a16:creationId xmlns:a16="http://schemas.microsoft.com/office/drawing/2014/main" id="{641904BA-FF40-444B-AD77-2BE7391FA078}"/>
               </a:ext>
             </a:extLst>
           </p:cNvPr>
@@ -6908,7 +7393,7 @@
           <p:cNvPr id="2" name="">
             <a:extLst xmlns:a="http://schemas.openxmlformats.org/drawingml/2006/main">
               <a:ext uri="{FF2B5EF4-FFF2-40B4-BE49-F238E27FC236}">
-                <a16:creationId xmlns:a16="http://schemas.microsoft.com/office/drawing/2014/main" id="{DA42A28E-EB09-4EE9-9204-737E0773BCD4}"/>
+                <a16:creationId xmlns:a16="http://schemas.microsoft.com/office/drawing/2014/main" id="{FFAC5F5C-E693-4841-A4E6-B5FC2CC53B5F}"/>
               </a:ext>
             </a:extLst>
           </p:cNvPr>
@@ -6965,7 +7450,7 @@
           <p:cNvPr id="3" name="">
             <a:extLst xmlns:a="http://schemas.openxmlformats.org/drawingml/2006/main">
               <a:ext uri="{FF2B5EF4-FFF2-40B4-BE49-F238E27FC236}">
-                <a16:creationId xmlns:a16="http://schemas.microsoft.com/office/drawing/2014/main" id="{EA903737-2569-4701-833F-ECBCF81500B5}"/>
+                <a16:creationId xmlns:a16="http://schemas.microsoft.com/office/drawing/2014/main" id="{FD76FC4B-BC79-4AD5-9037-CDE062119EDD}"/>
               </a:ext>
             </a:extLst>
           </p:cNvPr>
@@ -7045,7 +7530,7 @@
           <p:cNvPr id="4" name="">
             <a:extLst xmlns:a="http://schemas.openxmlformats.org/drawingml/2006/main">
               <a:ext uri="{FF2B5EF4-FFF2-40B4-BE49-F238E27FC236}">
-                <a16:creationId xmlns:a16="http://schemas.microsoft.com/office/drawing/2014/main" id="{4E27BFD1-9CC8-4456-854D-8DC3F785B241}"/>
+                <a16:creationId xmlns:a16="http://schemas.microsoft.com/office/drawing/2014/main" id="{1F9067BB-951B-4CD9-857F-98F0440611FC}"/>
               </a:ext>
             </a:extLst>
           </p:cNvPr>
@@ -7102,7 +7587,7 @@
           <p:cNvPr id="5" name="">
             <a:extLst xmlns:a="http://schemas.openxmlformats.org/drawingml/2006/main">
               <a:ext uri="{FF2B5EF4-FFF2-40B4-BE49-F238E27FC236}">
-                <a16:creationId xmlns:a16="http://schemas.microsoft.com/office/drawing/2014/main" id="{F94D586D-E474-4987-8CAC-8F2B581B2810}"/>
+                <a16:creationId xmlns:a16="http://schemas.microsoft.com/office/drawing/2014/main" id="{31C0C0BC-11FD-4E33-AB21-7AD2793A6C18}"/>
               </a:ext>
             </a:extLst>
           </p:cNvPr>
@@ -7182,7 +7667,7 @@
           <p:cNvPr id="6" name="">
             <a:extLst xmlns:a="http://schemas.openxmlformats.org/drawingml/2006/main">
               <a:ext uri="{FF2B5EF4-FFF2-40B4-BE49-F238E27FC236}">
-                <a16:creationId xmlns:a16="http://schemas.microsoft.com/office/drawing/2014/main" id="{9F1646E6-0027-4D98-8AEE-AAAB2029AEE7}"/>
+                <a16:creationId xmlns:a16="http://schemas.microsoft.com/office/drawing/2014/main" id="{3659B535-91D8-4745-94C6-F247A30FD9C0}"/>
               </a:ext>
             </a:extLst>
           </p:cNvPr>
@@ -7239,7 +7724,7 @@
           <p:cNvPr id="7" name="">
             <a:extLst xmlns:a="http://schemas.openxmlformats.org/drawingml/2006/main">
               <a:ext uri="{FF2B5EF4-FFF2-40B4-BE49-F238E27FC236}">
-                <a16:creationId xmlns:a16="http://schemas.microsoft.com/office/drawing/2014/main" id="{B66CCB03-27DF-4271-AAB9-F3D2F6F18442}"/>
+                <a16:creationId xmlns:a16="http://schemas.microsoft.com/office/drawing/2014/main" id="{76A68C1C-0C2D-4AF8-A57F-069EE04E044E}"/>
               </a:ext>
             </a:extLst>
           </p:cNvPr>
@@ -7294,7 +7779,7 @@
     </p:spTree>
     <p:extLst>
       <p:ext uri="{BB962C8B-B14F-4D97-AF65-F5344CB8AC3E}">
-        <p14:creationId xmlns:p14="http://schemas.microsoft.com/office/powerpoint/2010/main" val="510870151"/>
+        <p14:creationId xmlns:p14="http://schemas.microsoft.com/office/powerpoint/2010/main" val="1245578541"/>
       </p:ext>
     </p:extLst>
   </p:cSld>

</xml_diff>

<commit_message>
Apply upay-inspired blue and yellow theme and explain exchange cost
</commit_message>
<xml_diff>
--- a/docs/Presentation.pptx
+++ b/docs/Presentation.pptx
@@ -2,22 +2,22 @@
 <file path=ppt/presentation.xml><?xml version="1.0" encoding="utf-8"?>
 <p:presentation xmlns:p="http://schemas.openxmlformats.org/presentationml/2006/main">
   <p:sldMasterIdLst>
-    <p:sldMasterId xmlns:r="http://schemas.openxmlformats.org/officeDocument/2006/relationships" id="2147483648" r:id="R98f859b8514b406f"/>
+    <p:sldMasterId xmlns:r="http://schemas.openxmlformats.org/officeDocument/2006/relationships" id="2147483648" r:id="R0bcba0338b9c42cf"/>
   </p:sldMasterIdLst>
   <p:notesMasterIdLst>
-    <p:notesMasterId xmlns:r="http://schemas.openxmlformats.org/officeDocument/2006/relationships" r:id="Rbac5303685fb4907"/>
+    <p:notesMasterId xmlns:r="http://schemas.openxmlformats.org/officeDocument/2006/relationships" r:id="Rc4c899e0138042bf"/>
   </p:notesMasterIdLst>
   <p:sldIdLst>
-    <p:sldId xmlns:r="http://schemas.openxmlformats.org/officeDocument/2006/relationships" id="256" r:id="R8ae8397fab6141a4"/>
-    <p:sldId xmlns:r="http://schemas.openxmlformats.org/officeDocument/2006/relationships" id="257" r:id="Rd9e2b9f4f6324070"/>
-    <p:sldId xmlns:r="http://schemas.openxmlformats.org/officeDocument/2006/relationships" id="258" r:id="R8800a1cecb904b52"/>
-    <p:sldId xmlns:r="http://schemas.openxmlformats.org/officeDocument/2006/relationships" id="259" r:id="Re5f5adc6af1c4702"/>
-    <p:sldId xmlns:r="http://schemas.openxmlformats.org/officeDocument/2006/relationships" id="260" r:id="R6675558f5d0a41b5"/>
-    <p:sldId xmlns:r="http://schemas.openxmlformats.org/officeDocument/2006/relationships" id="261" r:id="R61a90885a60148e5"/>
-    <p:sldId xmlns:r="http://schemas.openxmlformats.org/officeDocument/2006/relationships" id="262" r:id="Rc15e25d270e84ac5"/>
-    <p:sldId xmlns:r="http://schemas.openxmlformats.org/officeDocument/2006/relationships" id="263" r:id="R83bc89a6091843dd"/>
-    <p:sldId xmlns:r="http://schemas.openxmlformats.org/officeDocument/2006/relationships" id="264" r:id="Rf4d1c5c9401e48b3"/>
-    <p:sldId xmlns:r="http://schemas.openxmlformats.org/officeDocument/2006/relationships" id="265" r:id="Rf5fdbac9831147c8"/>
+    <p:sldId xmlns:r="http://schemas.openxmlformats.org/officeDocument/2006/relationships" id="256" r:id="R08b601e9bc064fbe"/>
+    <p:sldId xmlns:r="http://schemas.openxmlformats.org/officeDocument/2006/relationships" id="257" r:id="R65dafd8ad9754169"/>
+    <p:sldId xmlns:r="http://schemas.openxmlformats.org/officeDocument/2006/relationships" id="258" r:id="Ree2113e67dc6460b"/>
+    <p:sldId xmlns:r="http://schemas.openxmlformats.org/officeDocument/2006/relationships" id="259" r:id="Rf9e518b873774a82"/>
+    <p:sldId xmlns:r="http://schemas.openxmlformats.org/officeDocument/2006/relationships" id="260" r:id="Rf9090e6db27545d2"/>
+    <p:sldId xmlns:r="http://schemas.openxmlformats.org/officeDocument/2006/relationships" id="261" r:id="R86ba259ba9b4499c"/>
+    <p:sldId xmlns:r="http://schemas.openxmlformats.org/officeDocument/2006/relationships" id="262" r:id="R91279c0c122c4a02"/>
+    <p:sldId xmlns:r="http://schemas.openxmlformats.org/officeDocument/2006/relationships" id="263" r:id="R88d73e43102d4ef4"/>
+    <p:sldId xmlns:r="http://schemas.openxmlformats.org/officeDocument/2006/relationships" id="264" r:id="Rc52df8e2863c4490"/>
+    <p:sldId xmlns:r="http://schemas.openxmlformats.org/officeDocument/2006/relationships" id="265" r:id="R55406f9b05a6495b"/>
   </p:sldIdLst>
   <p:sldSz cx="12192000" cy="6858000"/>
   <p:notesSz cx="6858000" cy="9144000"/>
@@ -1128,7 +1128,7 @@
           <p:cNvPr id="4" name="Accent rule">
             <a:extLst xmlns:a="http://schemas.openxmlformats.org/drawingml/2006/main">
               <a:ext uri="{FF2B5EF4-FFF2-40B4-BE49-F238E27FC236}">
-                <a16:creationId xmlns:a16="http://schemas.microsoft.com/office/drawing/2014/main" id="{44325C5E-F17A-4C8B-A365-540FD6FDA9D6}"/>
+                <a16:creationId xmlns:a16="http://schemas.microsoft.com/office/drawing/2014/main" id="{4B3BF13F-F196-4F2D-ACF6-41427CEF665A}"/>
               </a:ext>
             </a:extLst>
           </p:cNvPr>
@@ -1159,7 +1159,7 @@
           <p:cNvPr id="2" name="Title">
             <a:extLst xmlns:a="http://schemas.openxmlformats.org/drawingml/2006/main">
               <a:ext uri="{FF2B5EF4-FFF2-40B4-BE49-F238E27FC236}">
-                <a16:creationId xmlns:a16="http://schemas.microsoft.com/office/drawing/2014/main" id="{40E64910-C4B4-4E12-8D34-817DD281DB22}"/>
+                <a16:creationId xmlns:a16="http://schemas.microsoft.com/office/drawing/2014/main" id="{49B7ABEC-A140-48F1-89BC-8D0996B548BD}"/>
               </a:ext>
             </a:extLst>
           </p:cNvPr>
@@ -1306,7 +1306,7 @@
           <p:cNvPr id="3" name="Subtitle">
             <a:extLst xmlns:a="http://schemas.openxmlformats.org/drawingml/2006/main">
               <a:ext uri="{FF2B5EF4-FFF2-40B4-BE49-F238E27FC236}">
-                <a16:creationId xmlns:a16="http://schemas.microsoft.com/office/drawing/2014/main" id="{276350D1-3DD7-4DF2-9589-45E6110418CE}"/>
+                <a16:creationId xmlns:a16="http://schemas.microsoft.com/office/drawing/2014/main" id="{A10C314C-79E9-4F77-BD20-6C5F3E3D8991}"/>
               </a:ext>
             </a:extLst>
           </p:cNvPr>
@@ -1470,7 +1470,7 @@
           <p:cNvPr id="3" name="Accent rule">
             <a:extLst xmlns:a="http://schemas.openxmlformats.org/drawingml/2006/main">
               <a:ext uri="{FF2B5EF4-FFF2-40B4-BE49-F238E27FC236}">
-                <a16:creationId xmlns:a16="http://schemas.microsoft.com/office/drawing/2014/main" id="{6BBC1DE0-7CDC-48B6-9933-B303158B5A4A}"/>
+                <a16:creationId xmlns:a16="http://schemas.microsoft.com/office/drawing/2014/main" id="{5A5433A2-39A0-4B30-924A-484A1C349AA2}"/>
               </a:ext>
             </a:extLst>
           </p:cNvPr>
@@ -1501,7 +1501,7 @@
           <p:cNvPr id="2" name="Section title">
             <a:extLst xmlns:a="http://schemas.openxmlformats.org/drawingml/2006/main">
               <a:ext uri="{FF2B5EF4-FFF2-40B4-BE49-F238E27FC236}">
-                <a16:creationId xmlns:a16="http://schemas.microsoft.com/office/drawing/2014/main" id="{2A35B52A-4C95-4D96-86A5-6EF4DA742232}"/>
+                <a16:creationId xmlns:a16="http://schemas.microsoft.com/office/drawing/2014/main" id="{6CEDC2C7-5DE6-4EC8-B97D-670836C544CB}"/>
               </a:ext>
             </a:extLst>
           </p:cNvPr>
@@ -1665,7 +1665,7 @@
           <p:cNvPr id="4" name="Accent rule">
             <a:extLst xmlns:a="http://schemas.openxmlformats.org/drawingml/2006/main">
               <a:ext uri="{FF2B5EF4-FFF2-40B4-BE49-F238E27FC236}">
-                <a16:creationId xmlns:a16="http://schemas.microsoft.com/office/drawing/2014/main" id="{32F5A09D-A576-4302-AC8F-227573D660E0}"/>
+                <a16:creationId xmlns:a16="http://schemas.microsoft.com/office/drawing/2014/main" id="{3CE9963D-69DC-47FD-9986-4F5082C44997}"/>
               </a:ext>
             </a:extLst>
           </p:cNvPr>
@@ -1696,7 +1696,7 @@
           <p:cNvPr id="2" name="Title">
             <a:extLst xmlns:a="http://schemas.openxmlformats.org/drawingml/2006/main">
               <a:ext uri="{FF2B5EF4-FFF2-40B4-BE49-F238E27FC236}">
-                <a16:creationId xmlns:a16="http://schemas.microsoft.com/office/drawing/2014/main" id="{094FE95C-99A6-4CA0-8D2E-2A23D3C3AF63}"/>
+                <a16:creationId xmlns:a16="http://schemas.microsoft.com/office/drawing/2014/main" id="{C8EB6B13-9727-42B7-A131-C64AF4B6E3A1}"/>
               </a:ext>
             </a:extLst>
           </p:cNvPr>
@@ -1843,7 +1843,7 @@
           <p:cNvPr id="3" name="Body">
             <a:extLst xmlns:a="http://schemas.openxmlformats.org/drawingml/2006/main">
               <a:ext uri="{FF2B5EF4-FFF2-40B4-BE49-F238E27FC236}">
-                <a16:creationId xmlns:a16="http://schemas.microsoft.com/office/drawing/2014/main" id="{14B0BF23-4FD8-41ED-A005-9CE8D454B89A}"/>
+                <a16:creationId xmlns:a16="http://schemas.microsoft.com/office/drawing/2014/main" id="{BC02CDE2-99C4-46BA-A773-E30CCB999544}"/>
               </a:ext>
             </a:extLst>
           </p:cNvPr>
@@ -2007,7 +2007,7 @@
           <p:cNvPr id="5" name="Accent rule">
             <a:extLst xmlns:a="http://schemas.openxmlformats.org/drawingml/2006/main">
               <a:ext uri="{FF2B5EF4-FFF2-40B4-BE49-F238E27FC236}">
-                <a16:creationId xmlns:a16="http://schemas.microsoft.com/office/drawing/2014/main" id="{C74D5D0A-D4C8-40DC-99FD-530219250E27}"/>
+                <a16:creationId xmlns:a16="http://schemas.microsoft.com/office/drawing/2014/main" id="{CDD5A8FA-1979-464C-86DC-E1C1725C2CAF}"/>
               </a:ext>
             </a:extLst>
           </p:cNvPr>
@@ -2038,7 +2038,7 @@
           <p:cNvPr id="2" name="Title">
             <a:extLst xmlns:a="http://schemas.openxmlformats.org/drawingml/2006/main">
               <a:ext uri="{FF2B5EF4-FFF2-40B4-BE49-F238E27FC236}">
-                <a16:creationId xmlns:a16="http://schemas.microsoft.com/office/drawing/2014/main" id="{D3BE7D82-3DF4-4189-A9E3-90C569CD3078}"/>
+                <a16:creationId xmlns:a16="http://schemas.microsoft.com/office/drawing/2014/main" id="{8946BE16-7709-4A81-93C9-E663E9C60068}"/>
               </a:ext>
             </a:extLst>
           </p:cNvPr>
@@ -2185,7 +2185,7 @@
           <p:cNvPr id="3" name="Left column">
             <a:extLst xmlns:a="http://schemas.openxmlformats.org/drawingml/2006/main">
               <a:ext uri="{FF2B5EF4-FFF2-40B4-BE49-F238E27FC236}">
-                <a16:creationId xmlns:a16="http://schemas.microsoft.com/office/drawing/2014/main" id="{697B84EC-B3D1-4A8F-836F-0B9ACD21DBD7}"/>
+                <a16:creationId xmlns:a16="http://schemas.microsoft.com/office/drawing/2014/main" id="{EBED6F74-6EBD-47EE-BAC2-50572E0DEB92}"/>
               </a:ext>
             </a:extLst>
           </p:cNvPr>
@@ -2332,7 +2332,7 @@
           <p:cNvPr id="4" name="Right column">
             <a:extLst xmlns:a="http://schemas.openxmlformats.org/drawingml/2006/main">
               <a:ext uri="{FF2B5EF4-FFF2-40B4-BE49-F238E27FC236}">
-                <a16:creationId xmlns:a16="http://schemas.microsoft.com/office/drawing/2014/main" id="{3C2BC674-5A5B-4D66-8D4F-48BC3FD5D659}"/>
+                <a16:creationId xmlns:a16="http://schemas.microsoft.com/office/drawing/2014/main" id="{1CEBC8A3-C608-4EF9-B05C-B650178FFAA6}"/>
               </a:ext>
             </a:extLst>
           </p:cNvPr>
@@ -2496,7 +2496,7 @@
           <p:cNvPr id="4" name="Accent rule">
             <a:extLst xmlns:a="http://schemas.openxmlformats.org/drawingml/2006/main">
               <a:ext uri="{FF2B5EF4-FFF2-40B4-BE49-F238E27FC236}">
-                <a16:creationId xmlns:a16="http://schemas.microsoft.com/office/drawing/2014/main" id="{51757D35-D26F-44CA-8F75-A94F62341C88}"/>
+                <a16:creationId xmlns:a16="http://schemas.microsoft.com/office/drawing/2014/main" id="{F9ACB0D7-034A-4FD7-B70C-97BF023D4913}"/>
               </a:ext>
             </a:extLst>
           </p:cNvPr>
@@ -2527,7 +2527,7 @@
           <p:cNvPr id="2" name="Title">
             <a:extLst xmlns:a="http://schemas.openxmlformats.org/drawingml/2006/main">
               <a:ext uri="{FF2B5EF4-FFF2-40B4-BE49-F238E27FC236}">
-                <a16:creationId xmlns:a16="http://schemas.microsoft.com/office/drawing/2014/main" id="{FFD3496A-B1AD-4C39-B58F-F4F31FB2FAB7}"/>
+                <a16:creationId xmlns:a16="http://schemas.microsoft.com/office/drawing/2014/main" id="{F285C15A-5353-4307-9EE1-217319548ABB}"/>
               </a:ext>
             </a:extLst>
           </p:cNvPr>
@@ -2674,7 +2674,7 @@
           <p:cNvPr id="3" name="Left column">
             <a:extLst xmlns:a="http://schemas.openxmlformats.org/drawingml/2006/main">
               <a:ext uri="{FF2B5EF4-FFF2-40B4-BE49-F238E27FC236}">
-                <a16:creationId xmlns:a16="http://schemas.microsoft.com/office/drawing/2014/main" id="{4B146D77-EAB3-431E-851D-033BE8948804}"/>
+                <a16:creationId xmlns:a16="http://schemas.microsoft.com/office/drawing/2014/main" id="{976E9811-CF16-4C97-A846-0DEFF51487CF}"/>
               </a:ext>
             </a:extLst>
           </p:cNvPr>
@@ -2859,12 +2859,12 @@
   </p:cSld>
   <p:clrMap bg1="lt1" tx1="dk1" bg2="lt2" tx2="dk2" accent1="accent1" accent2="accent2" accent3="accent3" accent4="accent4" accent5="accent5" accent6="accent6" hlink="hlink" folHlink="folHlink"/>
   <p:sldLayoutIdLst>
-    <p:sldLayoutId xmlns:r="http://schemas.openxmlformats.org/officeDocument/2006/relationships" id="2147483649" r:id="R7d40f888dd574acd"/>
-    <p:sldLayoutId xmlns:r="http://schemas.openxmlformats.org/officeDocument/2006/relationships" id="2147483650" r:id="Raeb61a2f132f4849"/>
-    <p:sldLayoutId xmlns:r="http://schemas.openxmlformats.org/officeDocument/2006/relationships" id="2147483651" r:id="R2259d36968da4215"/>
-    <p:sldLayoutId xmlns:r="http://schemas.openxmlformats.org/officeDocument/2006/relationships" id="2147483652" r:id="R3aca2f1ece224e66"/>
-    <p:sldLayoutId xmlns:r="http://schemas.openxmlformats.org/officeDocument/2006/relationships" id="2147483653" r:id="R3d2227c13b4f4426"/>
-    <p:sldLayoutId xmlns:r="http://schemas.openxmlformats.org/officeDocument/2006/relationships" id="2147483654" r:id="R9299e0cb511e49bd"/>
+    <p:sldLayoutId xmlns:r="http://schemas.openxmlformats.org/officeDocument/2006/relationships" id="2147483649" r:id="R0cafa17f65064786"/>
+    <p:sldLayoutId xmlns:r="http://schemas.openxmlformats.org/officeDocument/2006/relationships" id="2147483650" r:id="R134f783c747f4e6f"/>
+    <p:sldLayoutId xmlns:r="http://schemas.openxmlformats.org/officeDocument/2006/relationships" id="2147483651" r:id="Rffa26b881054443b"/>
+    <p:sldLayoutId xmlns:r="http://schemas.openxmlformats.org/officeDocument/2006/relationships" id="2147483652" r:id="R82c4998473ac48fc"/>
+    <p:sldLayoutId xmlns:r="http://schemas.openxmlformats.org/officeDocument/2006/relationships" id="2147483653" r:id="R1b7cc5f72b994c46"/>
+    <p:sldLayoutId xmlns:r="http://schemas.openxmlformats.org/officeDocument/2006/relationships" id="2147483654" r:id="Rff7ced71b4b04818"/>
   </p:sldLayoutIdLst>
   <p:txStyles>
     <p:titleStyle>
@@ -3443,7 +3443,7 @@
           </c:tx>
           <c:spPr>
             <a:solidFill xmlns:a="http://schemas.openxmlformats.org/drawingml/2006/main">
-              <a:srgbClr val="07866E"/>
+              <a:srgbClr val="126AA7"/>
             </a:solidFill>
           </c:spPr>
           <c:cat>
@@ -3606,7 +3606,7 @@
       </c:valAx>
       <c:spPr>
         <a:solidFill xmlns:a="http://schemas.openxmlformats.org/drawingml/2006/main">
-          <a:srgbClr val="F7F9FB"/>
+          <a:srgbClr val="F4F8FC"/>
         </a:solidFill>
       </c:spPr>
     </c:plotArea>
@@ -3631,7 +3631,7 @@
   </c:chart>
   <c:spPr>
     <a:solidFill xmlns:a="http://schemas.openxmlformats.org/drawingml/2006/main">
-      <a:srgbClr val="F7F9FB"/>
+      <a:srgbClr val="F4F8FC"/>
     </a:solidFill>
   </c:spPr>
 </c:chartSpace>
@@ -3654,7 +3654,7 @@
           </c:tx>
           <c:spPr>
             <a:solidFill xmlns:a="http://schemas.openxmlformats.org/drawingml/2006/main">
-              <a:srgbClr val="07866E"/>
+              <a:srgbClr val="126AA7"/>
             </a:solidFill>
           </c:spPr>
           <c:cat>
@@ -3831,7 +3831,7 @@
       </c:valAx>
       <c:spPr>
         <a:solidFill xmlns:a="http://schemas.openxmlformats.org/drawingml/2006/main">
-          <a:srgbClr val="F7F9FB"/>
+          <a:srgbClr val="F4F8FC"/>
         </a:solidFill>
       </c:spPr>
     </c:plotArea>
@@ -3839,7 +3839,7 @@
   </c:chart>
   <c:spPr>
     <a:solidFill xmlns:a="http://schemas.openxmlformats.org/drawingml/2006/main">
-      <a:srgbClr val="F7F9FB"/>
+      <a:srgbClr val="F4F8FC"/>
     </a:solidFill>
   </c:spPr>
 </c:chartSpace>
@@ -3862,7 +3862,7 @@
           </c:tx>
           <c:spPr>
             <a:solidFill xmlns:a="http://schemas.openxmlformats.org/drawingml/2006/main">
-              <a:srgbClr val="07866E"/>
+              <a:srgbClr val="126AA7"/>
             </a:solidFill>
           </c:spPr>
           <c:cat>
@@ -4086,7 +4086,7 @@
       </c:valAx>
       <c:spPr>
         <a:solidFill xmlns:a="http://schemas.openxmlformats.org/drawingml/2006/main">
-          <a:srgbClr val="F7F9FB"/>
+          <a:srgbClr val="F4F8FC"/>
         </a:solidFill>
       </c:spPr>
     </c:plotArea>
@@ -4111,7 +4111,7 @@
   </c:chart>
   <c:spPr>
     <a:solidFill xmlns:a="http://schemas.openxmlformats.org/drawingml/2006/main">
-      <a:srgbClr val="F7F9FB"/>
+      <a:srgbClr val="F4F8FC"/>
     </a:solidFill>
   </c:spPr>
 </c:chartSpace>
@@ -4123,7 +4123,7 @@
     <p:bg>
       <p:bgPr>
         <a:solidFill xmlns:a="http://schemas.openxmlformats.org/drawingml/2006/main">
-          <a:srgbClr val="14283E"/>
+          <a:srgbClr val="17324B"/>
         </a:solidFill>
       </p:bgPr>
     </p:bg>
@@ -4141,7 +4141,7 @@
           <p:cNvPr id="5" name="">
             <a:extLst xmlns:a="http://schemas.openxmlformats.org/drawingml/2006/main">
               <a:ext uri="{FF2B5EF4-FFF2-40B4-BE49-F238E27FC236}">
-                <a16:creationId xmlns:a16="http://schemas.microsoft.com/office/drawing/2014/main" id="{AB41E2FA-7765-4D57-907C-4A369500999A}"/>
+                <a16:creationId xmlns:a16="http://schemas.microsoft.com/office/drawing/2014/main" id="{621C0F71-404D-4A46-82A6-4CEAED2E85DD}"/>
               </a:ext>
             </a:extLst>
           </p:cNvPr>
@@ -4221,7 +4221,7 @@
           <p:cNvPr id="2" name="">
             <a:extLst xmlns:a="http://schemas.openxmlformats.org/drawingml/2006/main">
               <a:ext uri="{FF2B5EF4-FFF2-40B4-BE49-F238E27FC236}">
-                <a16:creationId xmlns:a16="http://schemas.microsoft.com/office/drawing/2014/main" id="{60A1FC55-361C-44A7-B716-F165A0EF6C52}"/>
+                <a16:creationId xmlns:a16="http://schemas.microsoft.com/office/drawing/2014/main" id="{0DAB2380-2851-41E1-8CB0-BAF229C48C62}"/>
               </a:ext>
             </a:extLst>
           </p:cNvPr>
@@ -4252,7 +4252,7 @@
             <a:pPr>
               <a:defRPr sz="2475" b="0">
                 <a:solidFill>
-                  <a:srgbClr val="76DEC1"/>
+                  <a:srgbClr val="FFE199"/>
                 </a:solidFill>
                 <a:latin typeface="DejaVu Sans"/>
                 <a:ea typeface="DejaVu Sans"/>
@@ -4262,7 +4262,7 @@
             <a:r>
               <a:rPr sz="2475" b="0">
                 <a:solidFill>
-                  <a:srgbClr val="76DEC1"/>
+                  <a:srgbClr val="FFE199"/>
                 </a:solidFill>
                 <a:latin typeface="DejaVu Sans"/>
                 <a:ea typeface="DejaVu Sans"/>
@@ -4278,7 +4278,7 @@
           <p:cNvPr id="3" name="">
             <a:extLst xmlns:a="http://schemas.openxmlformats.org/drawingml/2006/main">
               <a:ext uri="{FF2B5EF4-FFF2-40B4-BE49-F238E27FC236}">
-                <a16:creationId xmlns:a16="http://schemas.microsoft.com/office/drawing/2014/main" id="{B0EFA735-0CB9-4AE2-9ACA-7B16B99B5120}"/>
+                <a16:creationId xmlns:a16="http://schemas.microsoft.com/office/drawing/2014/main" id="{A96EBBF7-FFBC-4863-80B9-8B74E72856F9}"/>
               </a:ext>
             </a:extLst>
           </p:cNvPr>
@@ -4335,7 +4335,7 @@
           <p:cNvPr id="4" name="">
             <a:extLst xmlns:a="http://schemas.openxmlformats.org/drawingml/2006/main">
               <a:ext uri="{FF2B5EF4-FFF2-40B4-BE49-F238E27FC236}">
-                <a16:creationId xmlns:a16="http://schemas.microsoft.com/office/drawing/2014/main" id="{D80262FA-E4D7-4A7F-9A19-CDF09F83A679}"/>
+                <a16:creationId xmlns:a16="http://schemas.microsoft.com/office/drawing/2014/main" id="{E86D3421-15D7-4008-8C5F-971E4192C082}"/>
               </a:ext>
             </a:extLst>
           </p:cNvPr>
@@ -4390,7 +4390,7 @@
     </p:spTree>
     <p:extLst>
       <p:ext uri="{BB962C8B-B14F-4D97-AF65-F5344CB8AC3E}">
-        <p14:creationId xmlns:p14="http://schemas.microsoft.com/office/powerpoint/2010/main" val="529995328"/>
+        <p14:creationId xmlns:p14="http://schemas.microsoft.com/office/powerpoint/2010/main" val="1464032557"/>
       </p:ext>
     </p:extLst>
   </p:cSld>
@@ -4403,7 +4403,7 @@
     <p:bg>
       <p:bgPr>
         <a:solidFill xmlns:a="http://schemas.openxmlformats.org/drawingml/2006/main">
-          <a:srgbClr val="F7F9FB"/>
+          <a:srgbClr val="F4F8FC"/>
         </a:solidFill>
       </p:bgPr>
     </p:bg>
@@ -4421,7 +4421,7 @@
           <p:cNvPr id="7" name="">
             <a:extLst xmlns:a="http://schemas.openxmlformats.org/drawingml/2006/main">
               <a:ext uri="{FF2B5EF4-FFF2-40B4-BE49-F238E27FC236}">
-                <a16:creationId xmlns:a16="http://schemas.microsoft.com/office/drawing/2014/main" id="{6EFAC72C-2702-4580-8AAC-9E7348345EB8}"/>
+                <a16:creationId xmlns:a16="http://schemas.microsoft.com/office/drawing/2014/main" id="{EBA2A9EF-E13F-46A7-9973-E34401A63517}"/>
               </a:ext>
             </a:extLst>
           </p:cNvPr>
@@ -4452,7 +4452,7 @@
             <a:pPr>
               <a:defRPr sz="3300" b="1">
                 <a:solidFill>
-                  <a:srgbClr val="14283E"/>
+                  <a:srgbClr val="17324B"/>
                 </a:solidFill>
                 <a:latin typeface="DejaVu Sans"/>
                 <a:ea typeface="DejaVu Sans"/>
@@ -4462,7 +4462,7 @@
             <a:r>
               <a:rPr sz="3300" b="1">
                 <a:solidFill>
-                  <a:srgbClr val="14283E"/>
+                  <a:srgbClr val="17324B"/>
                 </a:solidFill>
                 <a:latin typeface="DejaVu Sans"/>
                 <a:ea typeface="DejaVu Sans"/>
@@ -4478,7 +4478,7 @@
           <p:cNvPr id="2" name="">
             <a:extLst xmlns:a="http://schemas.openxmlformats.org/drawingml/2006/main">
               <a:ext uri="{FF2B5EF4-FFF2-40B4-BE49-F238E27FC236}">
-                <a16:creationId xmlns:a16="http://schemas.microsoft.com/office/drawing/2014/main" id="{F847726B-C79B-480B-8B22-6CAFB540DE0B}"/>
+                <a16:creationId xmlns:a16="http://schemas.microsoft.com/office/drawing/2014/main" id="{337684C5-0655-4460-AB11-634AECA99ABB}"/>
               </a:ext>
             </a:extLst>
           </p:cNvPr>
@@ -4509,7 +4509,7 @@
             <a:pPr>
               <a:defRPr sz="2400" b="1">
                 <a:solidFill>
-                  <a:srgbClr val="07866E"/>
+                  <a:srgbClr val="126AA7"/>
                 </a:solidFill>
                 <a:latin typeface="DejaVu Sans"/>
                 <a:ea typeface="DejaVu Sans"/>
@@ -4519,7 +4519,7 @@
             <a:r>
               <a:rPr sz="2400" b="1">
                 <a:solidFill>
-                  <a:srgbClr val="07866E"/>
+                  <a:srgbClr val="126AA7"/>
                 </a:solidFill>
                 <a:latin typeface="DejaVu Sans"/>
                 <a:ea typeface="DejaVu Sans"/>
@@ -4535,7 +4535,7 @@
           <p:cNvPr id="3" name="">
             <a:extLst xmlns:a="http://schemas.openxmlformats.org/drawingml/2006/main">
               <a:ext uri="{FF2B5EF4-FFF2-40B4-BE49-F238E27FC236}">
-                <a16:creationId xmlns:a16="http://schemas.microsoft.com/office/drawing/2014/main" id="{9F4AD920-CE02-4503-8B6C-60E0921AEC9D}"/>
+                <a16:creationId xmlns:a16="http://schemas.microsoft.com/office/drawing/2014/main" id="{166A218E-26D3-4C2F-887A-5D2EC4FC0EBB}"/>
               </a:ext>
             </a:extLst>
           </p:cNvPr>
@@ -4566,7 +4566,7 @@
             <a:pPr>
               <a:defRPr sz="2250" b="0">
                 <a:solidFill>
-                  <a:srgbClr val="14283E"/>
+                  <a:srgbClr val="17324B"/>
                 </a:solidFill>
                 <a:latin typeface="DejaVu Sans"/>
                 <a:ea typeface="DejaVu Sans"/>
@@ -4576,7 +4576,7 @@
             <a:r>
               <a:rPr sz="2250" b="0">
                 <a:solidFill>
-                  <a:srgbClr val="14283E"/>
+                  <a:srgbClr val="17324B"/>
                 </a:solidFill>
                 <a:latin typeface="DejaVu Sans"/>
                 <a:ea typeface="DejaVu Sans"/>
@@ -4589,7 +4589,7 @@
             <a:pPr>
               <a:defRPr sz="2250" b="0">
                 <a:solidFill>
-                  <a:srgbClr val="14283E"/>
+                  <a:srgbClr val="17324B"/>
                 </a:solidFill>
                 <a:latin typeface="DejaVu Sans"/>
                 <a:ea typeface="DejaVu Sans"/>
@@ -4599,7 +4599,7 @@
             <a:r>
               <a:rPr sz="2250" b="0">
                 <a:solidFill>
-                  <a:srgbClr val="14283E"/>
+                  <a:srgbClr val="17324B"/>
                 </a:solidFill>
                 <a:latin typeface="DejaVu Sans"/>
                 <a:ea typeface="DejaVu Sans"/>
@@ -4615,7 +4615,7 @@
           <p:cNvPr id="4" name="">
             <a:extLst xmlns:a="http://schemas.openxmlformats.org/drawingml/2006/main">
               <a:ext uri="{FF2B5EF4-FFF2-40B4-BE49-F238E27FC236}">
-                <a16:creationId xmlns:a16="http://schemas.microsoft.com/office/drawing/2014/main" id="{A6B06B7B-B58B-4411-AF4E-09999FFF4D03}"/>
+                <a16:creationId xmlns:a16="http://schemas.microsoft.com/office/drawing/2014/main" id="{B7F113F5-C8C3-4F03-9D70-328DA98962AD}"/>
               </a:ext>
             </a:extLst>
           </p:cNvPr>
@@ -4646,7 +4646,7 @@
             <a:pPr>
               <a:defRPr sz="2400" b="1">
                 <a:solidFill>
-                  <a:srgbClr val="07866E"/>
+                  <a:srgbClr val="126AA7"/>
                 </a:solidFill>
                 <a:latin typeface="DejaVu Sans"/>
                 <a:ea typeface="DejaVu Sans"/>
@@ -4656,7 +4656,7 @@
             <a:r>
               <a:rPr sz="2400" b="1">
                 <a:solidFill>
-                  <a:srgbClr val="07866E"/>
+                  <a:srgbClr val="126AA7"/>
                 </a:solidFill>
                 <a:latin typeface="DejaVu Sans"/>
                 <a:ea typeface="DejaVu Sans"/>
@@ -4672,7 +4672,7 @@
           <p:cNvPr id="5" name="">
             <a:extLst xmlns:a="http://schemas.openxmlformats.org/drawingml/2006/main">
               <a:ext uri="{FF2B5EF4-FFF2-40B4-BE49-F238E27FC236}">
-                <a16:creationId xmlns:a16="http://schemas.microsoft.com/office/drawing/2014/main" id="{0120E31D-997D-4ACA-A111-9566E7FB704D}"/>
+                <a16:creationId xmlns:a16="http://schemas.microsoft.com/office/drawing/2014/main" id="{115016C4-E293-40A9-AE5A-BF884AEC7CFC}"/>
               </a:ext>
             </a:extLst>
           </p:cNvPr>
@@ -4703,7 +4703,7 @@
             <a:pPr>
               <a:defRPr sz="2250" b="0">
                 <a:solidFill>
-                  <a:srgbClr val="14283E"/>
+                  <a:srgbClr val="17324B"/>
                 </a:solidFill>
                 <a:latin typeface="DejaVu Sans"/>
                 <a:ea typeface="DejaVu Sans"/>
@@ -4713,7 +4713,7 @@
             <a:r>
               <a:rPr sz="2250" b="0">
                 <a:solidFill>
-                  <a:srgbClr val="14283E"/>
+                  <a:srgbClr val="17324B"/>
                 </a:solidFill>
                 <a:latin typeface="DejaVu Sans"/>
                 <a:ea typeface="DejaVu Sans"/>
@@ -4726,7 +4726,7 @@
             <a:pPr>
               <a:defRPr sz="2250" b="0">
                 <a:solidFill>
-                  <a:srgbClr val="14283E"/>
+                  <a:srgbClr val="17324B"/>
                 </a:solidFill>
                 <a:latin typeface="DejaVu Sans"/>
                 <a:ea typeface="DejaVu Sans"/>
@@ -4736,7 +4736,7 @@
             <a:r>
               <a:rPr sz="2250" b="0">
                 <a:solidFill>
-                  <a:srgbClr val="14283E"/>
+                  <a:srgbClr val="17324B"/>
                 </a:solidFill>
                 <a:latin typeface="DejaVu Sans"/>
                 <a:ea typeface="DejaVu Sans"/>
@@ -4752,7 +4752,7 @@
           <p:cNvPr id="6" name="">
             <a:extLst xmlns:a="http://schemas.openxmlformats.org/drawingml/2006/main">
               <a:ext uri="{FF2B5EF4-FFF2-40B4-BE49-F238E27FC236}">
-                <a16:creationId xmlns:a16="http://schemas.microsoft.com/office/drawing/2014/main" id="{969715D3-B48E-4A4D-AD38-171B97C10DBC}"/>
+                <a16:creationId xmlns:a16="http://schemas.microsoft.com/office/drawing/2014/main" id="{4486FD95-B5BF-4CA7-9D0B-605555E21CB6}"/>
               </a:ext>
             </a:extLst>
           </p:cNvPr>
@@ -4807,7 +4807,7 @@
     </p:spTree>
     <p:extLst>
       <p:ext uri="{BB962C8B-B14F-4D97-AF65-F5344CB8AC3E}">
-        <p14:creationId xmlns:p14="http://schemas.microsoft.com/office/powerpoint/2010/main" val="443008730"/>
+        <p14:creationId xmlns:p14="http://schemas.microsoft.com/office/powerpoint/2010/main" val="1673183627"/>
       </p:ext>
     </p:extLst>
   </p:cSld>
@@ -4820,7 +4820,7 @@
     <p:bg>
       <p:bgPr>
         <a:solidFill xmlns:a="http://schemas.openxmlformats.org/drawingml/2006/main">
-          <a:srgbClr val="F7F9FB"/>
+          <a:srgbClr val="F4F8FC"/>
         </a:solidFill>
       </p:bgPr>
     </p:bg>
@@ -4838,7 +4838,7 @@
           <p:cNvPr id="9" name="">
             <a:extLst xmlns:a="http://schemas.openxmlformats.org/drawingml/2006/main">
               <a:ext uri="{FF2B5EF4-FFF2-40B4-BE49-F238E27FC236}">
-                <a16:creationId xmlns:a16="http://schemas.microsoft.com/office/drawing/2014/main" id="{B4D2C928-14B9-4B4B-A0FF-25AEC50CE2D1}"/>
+                <a16:creationId xmlns:a16="http://schemas.microsoft.com/office/drawing/2014/main" id="{6BFC0DCA-7507-4DD0-88CC-8D67F15D6365}"/>
               </a:ext>
             </a:extLst>
           </p:cNvPr>
@@ -4869,7 +4869,7 @@
             <a:pPr>
               <a:defRPr sz="3300" b="1">
                 <a:solidFill>
-                  <a:srgbClr val="14283E"/>
+                  <a:srgbClr val="17324B"/>
                 </a:solidFill>
                 <a:latin typeface="DejaVu Sans"/>
                 <a:ea typeface="DejaVu Sans"/>
@@ -4879,7 +4879,7 @@
             <a:r>
               <a:rPr sz="3300" b="1">
                 <a:solidFill>
-                  <a:srgbClr val="14283E"/>
+                  <a:srgbClr val="17324B"/>
                 </a:solidFill>
                 <a:latin typeface="DejaVu Sans"/>
                 <a:ea typeface="DejaVu Sans"/>
@@ -4895,7 +4895,7 @@
           <p:cNvPr id="2" name="">
             <a:extLst xmlns:a="http://schemas.openxmlformats.org/drawingml/2006/main">
               <a:ext uri="{FF2B5EF4-FFF2-40B4-BE49-F238E27FC236}">
-                <a16:creationId xmlns:a16="http://schemas.microsoft.com/office/drawing/2014/main" id="{4BE70481-6AC1-44D6-B975-0D3CB12CB917}"/>
+                <a16:creationId xmlns:a16="http://schemas.microsoft.com/office/drawing/2014/main" id="{7A9AC974-5F0E-468C-9363-893E23AEEBFB}"/>
               </a:ext>
             </a:extLst>
           </p:cNvPr>
@@ -4926,7 +4926,7 @@
             <a:pPr>
               <a:defRPr sz="2400" b="1">
                 <a:solidFill>
-                  <a:srgbClr val="07866E"/>
+                  <a:srgbClr val="126AA7"/>
                 </a:solidFill>
                 <a:latin typeface="DejaVu Sans"/>
                 <a:ea typeface="DejaVu Sans"/>
@@ -4936,7 +4936,7 @@
             <a:r>
               <a:rPr sz="2400" b="1">
                 <a:solidFill>
-                  <a:srgbClr val="07866E"/>
+                  <a:srgbClr val="126AA7"/>
                 </a:solidFill>
                 <a:latin typeface="DejaVu Sans"/>
                 <a:ea typeface="DejaVu Sans"/>
@@ -4952,7 +4952,7 @@
           <p:cNvPr id="3" name="">
             <a:extLst xmlns:a="http://schemas.openxmlformats.org/drawingml/2006/main">
               <a:ext uri="{FF2B5EF4-FFF2-40B4-BE49-F238E27FC236}">
-                <a16:creationId xmlns:a16="http://schemas.microsoft.com/office/drawing/2014/main" id="{43A11740-E779-4D44-85E3-6B8410B92DF3}"/>
+                <a16:creationId xmlns:a16="http://schemas.microsoft.com/office/drawing/2014/main" id="{6C07D662-3938-42ED-9B56-19F48CEAAD49}"/>
               </a:ext>
             </a:extLst>
           </p:cNvPr>
@@ -4983,7 +4983,7 @@
             <a:pPr>
               <a:defRPr sz="2550" b="1">
                 <a:solidFill>
-                  <a:srgbClr val="14283E"/>
+                  <a:srgbClr val="17324B"/>
                 </a:solidFill>
                 <a:latin typeface="DejaVu Sans"/>
                 <a:ea typeface="DejaVu Sans"/>
@@ -4993,7 +4993,7 @@
             <a:r>
               <a:rPr sz="2550" b="1">
                 <a:solidFill>
-                  <a:srgbClr val="14283E"/>
+                  <a:srgbClr val="17324B"/>
                 </a:solidFill>
                 <a:latin typeface="DejaVu Sans"/>
                 <a:ea typeface="DejaVu Sans"/>
@@ -5006,7 +5006,7 @@
             <a:pPr>
               <a:defRPr sz="2550" b="1">
                 <a:solidFill>
-                  <a:srgbClr val="14283E"/>
+                  <a:srgbClr val="17324B"/>
                 </a:solidFill>
                 <a:latin typeface="DejaVu Sans"/>
                 <a:ea typeface="DejaVu Sans"/>
@@ -5016,7 +5016,7 @@
             <a:r>
               <a:rPr sz="2550" b="1">
                 <a:solidFill>
-                  <a:srgbClr val="14283E"/>
+                  <a:srgbClr val="17324B"/>
                 </a:solidFill>
                 <a:latin typeface="DejaVu Sans"/>
                 <a:ea typeface="DejaVu Sans"/>
@@ -5032,7 +5032,7 @@
           <p:cNvPr id="4" name="">
             <a:extLst xmlns:a="http://schemas.openxmlformats.org/drawingml/2006/main">
               <a:ext uri="{FF2B5EF4-FFF2-40B4-BE49-F238E27FC236}">
-                <a16:creationId xmlns:a16="http://schemas.microsoft.com/office/drawing/2014/main" id="{FCDFDD0A-198F-42EC-8B70-B0333C44A9CD}"/>
+                <a16:creationId xmlns:a16="http://schemas.microsoft.com/office/drawing/2014/main" id="{16F811A7-6B97-4108-887F-C57256EB7401}"/>
               </a:ext>
             </a:extLst>
           </p:cNvPr>
@@ -5063,7 +5063,7 @@
             <a:pPr>
               <a:defRPr sz="2025" b="0">
                 <a:solidFill>
-                  <a:srgbClr val="14283E"/>
+                  <a:srgbClr val="17324B"/>
                 </a:solidFill>
                 <a:latin typeface="DejaVu Sans"/>
                 <a:ea typeface="DejaVu Sans"/>
@@ -5073,7 +5073,7 @@
             <a:r>
               <a:rPr sz="2025" b="0">
                 <a:solidFill>
-                  <a:srgbClr val="14283E"/>
+                  <a:srgbClr val="17324B"/>
                 </a:solidFill>
                 <a:latin typeface="DejaVu Sans"/>
                 <a:ea typeface="DejaVu Sans"/>
@@ -5086,7 +5086,7 @@
             <a:pPr>
               <a:defRPr sz="2025" b="0">
                 <a:solidFill>
-                  <a:srgbClr val="14283E"/>
+                  <a:srgbClr val="17324B"/>
                 </a:solidFill>
                 <a:latin typeface="DejaVu Sans"/>
                 <a:ea typeface="DejaVu Sans"/>
@@ -5096,7 +5096,7 @@
             <a:r>
               <a:rPr sz="2025" b="0">
                 <a:solidFill>
-                  <a:srgbClr val="14283E"/>
+                  <a:srgbClr val="17324B"/>
                 </a:solidFill>
                 <a:latin typeface="DejaVu Sans"/>
                 <a:ea typeface="DejaVu Sans"/>
@@ -5109,7 +5109,7 @@
             <a:pPr>
               <a:defRPr sz="2025" b="0">
                 <a:solidFill>
-                  <a:srgbClr val="14283E"/>
+                  <a:srgbClr val="17324B"/>
                 </a:solidFill>
                 <a:latin typeface="DejaVu Sans"/>
                 <a:ea typeface="DejaVu Sans"/>
@@ -5119,7 +5119,7 @@
             <a:r>
               <a:rPr sz="2025" b="0">
                 <a:solidFill>
-                  <a:srgbClr val="14283E"/>
+                  <a:srgbClr val="17324B"/>
                 </a:solidFill>
                 <a:latin typeface="DejaVu Sans"/>
                 <a:ea typeface="DejaVu Sans"/>
@@ -5135,7 +5135,7 @@
           <p:cNvPr id="5" name="">
             <a:extLst xmlns:a="http://schemas.openxmlformats.org/drawingml/2006/main">
               <a:ext uri="{FF2B5EF4-FFF2-40B4-BE49-F238E27FC236}">
-                <a16:creationId xmlns:a16="http://schemas.microsoft.com/office/drawing/2014/main" id="{6D6F7C64-D639-49D4-910E-04328D23145A}"/>
+                <a16:creationId xmlns:a16="http://schemas.microsoft.com/office/drawing/2014/main" id="{80634464-C8AF-49C4-91F1-24EC0E5A45DE}"/>
               </a:ext>
             </a:extLst>
           </p:cNvPr>
@@ -5166,7 +5166,7 @@
             <a:pPr>
               <a:defRPr sz="2400" b="1">
                 <a:solidFill>
-                  <a:srgbClr val="07866E"/>
+                  <a:srgbClr val="126AA7"/>
                 </a:solidFill>
                 <a:latin typeface="DejaVu Sans"/>
                 <a:ea typeface="DejaVu Sans"/>
@@ -5176,7 +5176,7 @@
             <a:r>
               <a:rPr sz="2400" b="1">
                 <a:solidFill>
-                  <a:srgbClr val="07866E"/>
+                  <a:srgbClr val="126AA7"/>
                 </a:solidFill>
                 <a:latin typeface="DejaVu Sans"/>
                 <a:ea typeface="DejaVu Sans"/>
@@ -5192,7 +5192,7 @@
           <p:cNvPr id="6" name="">
             <a:extLst xmlns:a="http://schemas.openxmlformats.org/drawingml/2006/main">
               <a:ext uri="{FF2B5EF4-FFF2-40B4-BE49-F238E27FC236}">
-                <a16:creationId xmlns:a16="http://schemas.microsoft.com/office/drawing/2014/main" id="{F0029DE6-FA46-4FFB-A4F6-CB78900A3B55}"/>
+                <a16:creationId xmlns:a16="http://schemas.microsoft.com/office/drawing/2014/main" id="{85EDA6FD-E30D-4FBB-A02C-57751BA7C1AC}"/>
               </a:ext>
             </a:extLst>
           </p:cNvPr>
@@ -5223,7 +5223,7 @@
             <a:pPr>
               <a:defRPr sz="2550" b="1">
                 <a:solidFill>
-                  <a:srgbClr val="14283E"/>
+                  <a:srgbClr val="17324B"/>
                 </a:solidFill>
                 <a:latin typeface="DejaVu Sans"/>
                 <a:ea typeface="DejaVu Sans"/>
@@ -5233,7 +5233,7 @@
             <a:r>
               <a:rPr sz="2550" b="1">
                 <a:solidFill>
-                  <a:srgbClr val="14283E"/>
+                  <a:srgbClr val="17324B"/>
                 </a:solidFill>
                 <a:latin typeface="DejaVu Sans"/>
                 <a:ea typeface="DejaVu Sans"/>
@@ -5246,7 +5246,7 @@
             <a:pPr>
               <a:defRPr sz="2550" b="1">
                 <a:solidFill>
-                  <a:srgbClr val="14283E"/>
+                  <a:srgbClr val="17324B"/>
                 </a:solidFill>
                 <a:latin typeface="DejaVu Sans"/>
                 <a:ea typeface="DejaVu Sans"/>
@@ -5256,7 +5256,7 @@
             <a:r>
               <a:rPr sz="2550" b="1">
                 <a:solidFill>
-                  <a:srgbClr val="14283E"/>
+                  <a:srgbClr val="17324B"/>
                 </a:solidFill>
                 <a:latin typeface="DejaVu Sans"/>
                 <a:ea typeface="DejaVu Sans"/>
@@ -5272,7 +5272,7 @@
           <p:cNvPr id="7" name="">
             <a:extLst xmlns:a="http://schemas.openxmlformats.org/drawingml/2006/main">
               <a:ext uri="{FF2B5EF4-FFF2-40B4-BE49-F238E27FC236}">
-                <a16:creationId xmlns:a16="http://schemas.microsoft.com/office/drawing/2014/main" id="{E2713538-1013-4225-A48C-365E34907D58}"/>
+                <a16:creationId xmlns:a16="http://schemas.microsoft.com/office/drawing/2014/main" id="{DA02E68C-C392-4B52-86B3-20CABC16C2D8}"/>
               </a:ext>
             </a:extLst>
           </p:cNvPr>
@@ -5303,7 +5303,7 @@
             <a:pPr>
               <a:defRPr sz="2025" b="0">
                 <a:solidFill>
-                  <a:srgbClr val="14283E"/>
+                  <a:srgbClr val="17324B"/>
                 </a:solidFill>
                 <a:latin typeface="DejaVu Sans"/>
                 <a:ea typeface="DejaVu Sans"/>
@@ -5313,7 +5313,7 @@
             <a:r>
               <a:rPr sz="2025" b="0">
                 <a:solidFill>
-                  <a:srgbClr val="14283E"/>
+                  <a:srgbClr val="17324B"/>
                 </a:solidFill>
                 <a:latin typeface="DejaVu Sans"/>
                 <a:ea typeface="DejaVu Sans"/>
@@ -5326,7 +5326,7 @@
             <a:pPr>
               <a:defRPr sz="2025" b="0">
                 <a:solidFill>
-                  <a:srgbClr val="14283E"/>
+                  <a:srgbClr val="17324B"/>
                 </a:solidFill>
                 <a:latin typeface="DejaVu Sans"/>
                 <a:ea typeface="DejaVu Sans"/>
@@ -5336,7 +5336,7 @@
             <a:r>
               <a:rPr sz="2025" b="0">
                 <a:solidFill>
-                  <a:srgbClr val="14283E"/>
+                  <a:srgbClr val="17324B"/>
                 </a:solidFill>
                 <a:latin typeface="DejaVu Sans"/>
                 <a:ea typeface="DejaVu Sans"/>
@@ -5349,7 +5349,7 @@
             <a:pPr>
               <a:defRPr sz="2025" b="0">
                 <a:solidFill>
-                  <a:srgbClr val="14283E"/>
+                  <a:srgbClr val="17324B"/>
                 </a:solidFill>
                 <a:latin typeface="DejaVu Sans"/>
                 <a:ea typeface="DejaVu Sans"/>
@@ -5359,7 +5359,7 @@
             <a:r>
               <a:rPr sz="2025" b="0">
                 <a:solidFill>
-                  <a:srgbClr val="14283E"/>
+                  <a:srgbClr val="17324B"/>
                 </a:solidFill>
                 <a:latin typeface="DejaVu Sans"/>
                 <a:ea typeface="DejaVu Sans"/>
@@ -5375,7 +5375,7 @@
           <p:cNvPr id="8" name="">
             <a:extLst xmlns:a="http://schemas.openxmlformats.org/drawingml/2006/main">
               <a:ext uri="{FF2B5EF4-FFF2-40B4-BE49-F238E27FC236}">
-                <a16:creationId xmlns:a16="http://schemas.microsoft.com/office/drawing/2014/main" id="{66ADF2BF-E055-4102-81D0-F87722B71581}"/>
+                <a16:creationId xmlns:a16="http://schemas.microsoft.com/office/drawing/2014/main" id="{E0804E1A-7923-4F26-93AA-82314A528916}"/>
               </a:ext>
             </a:extLst>
           </p:cNvPr>
@@ -5430,7 +5430,7 @@
     </p:spTree>
     <p:extLst>
       <p:ext uri="{BB962C8B-B14F-4D97-AF65-F5344CB8AC3E}">
-        <p14:creationId xmlns:p14="http://schemas.microsoft.com/office/powerpoint/2010/main" val="512804488"/>
+        <p14:creationId xmlns:p14="http://schemas.microsoft.com/office/powerpoint/2010/main" val="572965379"/>
       </p:ext>
     </p:extLst>
   </p:cSld>
@@ -5443,7 +5443,7 @@
     <p:bg>
       <p:bgPr>
         <a:solidFill xmlns:a="http://schemas.openxmlformats.org/drawingml/2006/main">
-          <a:srgbClr val="F7F9FB"/>
+          <a:srgbClr val="F4F8FC"/>
         </a:solidFill>
       </p:bgPr>
     </p:bg>
@@ -5461,7 +5461,7 @@
           <p:cNvPr id="8" name="">
             <a:extLst xmlns:a="http://schemas.openxmlformats.org/drawingml/2006/main">
               <a:ext uri="{FF2B5EF4-FFF2-40B4-BE49-F238E27FC236}">
-                <a16:creationId xmlns:a16="http://schemas.microsoft.com/office/drawing/2014/main" id="{561267DF-FE75-413F-AC5C-DCB34971D1D6}"/>
+                <a16:creationId xmlns:a16="http://schemas.microsoft.com/office/drawing/2014/main" id="{E0214178-0BCE-415D-9D6A-70B75F04FB63}"/>
               </a:ext>
             </a:extLst>
           </p:cNvPr>
@@ -5492,7 +5492,7 @@
             <a:pPr>
               <a:defRPr sz="3300" b="1">
                 <a:solidFill>
-                  <a:srgbClr val="14283E"/>
+                  <a:srgbClr val="17324B"/>
                 </a:solidFill>
                 <a:latin typeface="DejaVu Sans"/>
                 <a:ea typeface="DejaVu Sans"/>
@@ -5502,7 +5502,7 @@
             <a:r>
               <a:rPr sz="3300" b="1">
                 <a:solidFill>
-                  <a:srgbClr val="14283E"/>
+                  <a:srgbClr val="17324B"/>
                 </a:solidFill>
                 <a:latin typeface="DejaVu Sans"/>
                 <a:ea typeface="DejaVu Sans"/>
@@ -5518,7 +5518,7 @@
           <p:cNvPr id="2" name="">
             <a:extLst xmlns:a="http://schemas.openxmlformats.org/drawingml/2006/main">
               <a:ext uri="{FF2B5EF4-FFF2-40B4-BE49-F238E27FC236}">
-                <a16:creationId xmlns:a16="http://schemas.microsoft.com/office/drawing/2014/main" id="{DCB6D55B-EA81-4CAF-930B-CDDC475BD629}"/>
+                <a16:creationId xmlns:a16="http://schemas.microsoft.com/office/drawing/2014/main" id="{8D674713-8D34-4903-B47A-0C653081B7A6}"/>
               </a:ext>
             </a:extLst>
           </p:cNvPr>
@@ -5549,7 +5549,7 @@
             <a:pPr>
               <a:defRPr sz="2550" b="1">
                 <a:solidFill>
-                  <a:srgbClr val="14283E"/>
+                  <a:srgbClr val="17324B"/>
                 </a:solidFill>
                 <a:latin typeface="DejaVu Sans"/>
                 <a:ea typeface="DejaVu Sans"/>
@@ -5559,7 +5559,7 @@
             <a:r>
               <a:rPr sz="2550" b="1">
                 <a:solidFill>
-                  <a:srgbClr val="14283E"/>
+                  <a:srgbClr val="17324B"/>
                 </a:solidFill>
                 <a:latin typeface="DejaVu Sans"/>
                 <a:ea typeface="DejaVu Sans"/>
@@ -5575,7 +5575,7 @@
           <p:cNvPr id="3" name="">
             <a:extLst xmlns:a="http://schemas.openxmlformats.org/drawingml/2006/main">
               <a:ext uri="{FF2B5EF4-FFF2-40B4-BE49-F238E27FC236}">
-                <a16:creationId xmlns:a16="http://schemas.microsoft.com/office/drawing/2014/main" id="{6A1CF44A-5DBD-42B5-9D33-B57C4D3A48FA}"/>
+                <a16:creationId xmlns:a16="http://schemas.microsoft.com/office/drawing/2014/main" id="{9A8FDF94-4732-40B0-9DEA-922AC34D0629}"/>
               </a:ext>
             </a:extLst>
           </p:cNvPr>
@@ -5606,7 +5606,7 @@
             <a:pPr>
               <a:defRPr sz="2625" b="0">
                 <a:solidFill>
-                  <a:srgbClr val="07866E"/>
+                  <a:srgbClr val="126AA7"/>
                 </a:solidFill>
                 <a:latin typeface="DejaVu Sans"/>
                 <a:ea typeface="DejaVu Sans"/>
@@ -5616,7 +5616,7 @@
             <a:r>
               <a:rPr sz="2625" b="0">
                 <a:solidFill>
-                  <a:srgbClr val="07866E"/>
+                  <a:srgbClr val="126AA7"/>
                 </a:solidFill>
                 <a:latin typeface="DejaVu Sans"/>
                 <a:ea typeface="DejaVu Sans"/>
@@ -5632,7 +5632,7 @@
           <p:cNvPr id="4" name="">
             <a:extLst xmlns:a="http://schemas.openxmlformats.org/drawingml/2006/main">
               <a:ext uri="{FF2B5EF4-FFF2-40B4-BE49-F238E27FC236}">
-                <a16:creationId xmlns:a16="http://schemas.microsoft.com/office/drawing/2014/main" id="{61D772B4-30B1-418B-A60B-C646E11E279A}"/>
+                <a16:creationId xmlns:a16="http://schemas.microsoft.com/office/drawing/2014/main" id="{2FD11053-830B-4C59-B445-E85F8DA14C0C}"/>
               </a:ext>
             </a:extLst>
           </p:cNvPr>
@@ -5663,7 +5663,7 @@
             <a:pPr>
               <a:defRPr sz="2550" b="1">
                 <a:solidFill>
-                  <a:srgbClr val="14283E"/>
+                  <a:srgbClr val="17324B"/>
                 </a:solidFill>
                 <a:latin typeface="DejaVu Sans"/>
                 <a:ea typeface="DejaVu Sans"/>
@@ -5673,7 +5673,7 @@
             <a:r>
               <a:rPr sz="2550" b="1">
                 <a:solidFill>
-                  <a:srgbClr val="14283E"/>
+                  <a:srgbClr val="17324B"/>
                 </a:solidFill>
                 <a:latin typeface="DejaVu Sans"/>
                 <a:ea typeface="DejaVu Sans"/>
@@ -5689,7 +5689,7 @@
           <p:cNvPr id="5" name="">
             <a:extLst xmlns:a="http://schemas.openxmlformats.org/drawingml/2006/main">
               <a:ext uri="{FF2B5EF4-FFF2-40B4-BE49-F238E27FC236}">
-                <a16:creationId xmlns:a16="http://schemas.microsoft.com/office/drawing/2014/main" id="{DC866B43-1FDB-497A-A3B0-0A05DBD013E5}"/>
+                <a16:creationId xmlns:a16="http://schemas.microsoft.com/office/drawing/2014/main" id="{AB2DBDE9-9EA6-4439-B901-FDB34FC1C7CF}"/>
               </a:ext>
             </a:extLst>
           </p:cNvPr>
@@ -5720,7 +5720,7 @@
             <a:pPr>
               <a:defRPr sz="2625" b="0">
                 <a:solidFill>
-                  <a:srgbClr val="07866E"/>
+                  <a:srgbClr val="126AA7"/>
                 </a:solidFill>
                 <a:latin typeface="DejaVu Sans"/>
                 <a:ea typeface="DejaVu Sans"/>
@@ -5730,7 +5730,7 @@
             <a:r>
               <a:rPr sz="2625" b="0">
                 <a:solidFill>
-                  <a:srgbClr val="07866E"/>
+                  <a:srgbClr val="126AA7"/>
                 </a:solidFill>
                 <a:latin typeface="DejaVu Sans"/>
                 <a:ea typeface="DejaVu Sans"/>
@@ -5746,7 +5746,7 @@
           <p:cNvPr id="6" name="">
             <a:extLst xmlns:a="http://schemas.openxmlformats.org/drawingml/2006/main">
               <a:ext uri="{FF2B5EF4-FFF2-40B4-BE49-F238E27FC236}">
-                <a16:creationId xmlns:a16="http://schemas.microsoft.com/office/drawing/2014/main" id="{EB89157E-0C97-4ECB-8EF3-ACA15C9042CD}"/>
+                <a16:creationId xmlns:a16="http://schemas.microsoft.com/office/drawing/2014/main" id="{08035E26-2C24-49A1-9943-ED5F22D55C0F}"/>
               </a:ext>
             </a:extLst>
           </p:cNvPr>
@@ -5777,7 +5777,7 @@
             <a:pPr>
               <a:defRPr sz="2100" b="0">
                 <a:solidFill>
-                  <a:srgbClr val="14283E"/>
+                  <a:srgbClr val="17324B"/>
                 </a:solidFill>
                 <a:latin typeface="DejaVu Sans"/>
                 <a:ea typeface="DejaVu Sans"/>
@@ -5787,7 +5787,7 @@
             <a:r>
               <a:rPr sz="2100" b="0">
                 <a:solidFill>
-                  <a:srgbClr val="14283E"/>
+                  <a:srgbClr val="17324B"/>
                 </a:solidFill>
                 <a:latin typeface="DejaVu Sans"/>
                 <a:ea typeface="DejaVu Sans"/>
@@ -5803,7 +5803,7 @@
           <p:cNvPr id="7" name="">
             <a:extLst xmlns:a="http://schemas.openxmlformats.org/drawingml/2006/main">
               <a:ext uri="{FF2B5EF4-FFF2-40B4-BE49-F238E27FC236}">
-                <a16:creationId xmlns:a16="http://schemas.microsoft.com/office/drawing/2014/main" id="{28B61DF0-1072-411C-9FA8-3F2CD261D3A7}"/>
+                <a16:creationId xmlns:a16="http://schemas.microsoft.com/office/drawing/2014/main" id="{A97B3741-AED7-4C89-A10B-758232FF5EF8}"/>
               </a:ext>
             </a:extLst>
           </p:cNvPr>
@@ -5858,7 +5858,7 @@
     </p:spTree>
     <p:extLst>
       <p:ext uri="{BB962C8B-B14F-4D97-AF65-F5344CB8AC3E}">
-        <p14:creationId xmlns:p14="http://schemas.microsoft.com/office/powerpoint/2010/main" val="765140056"/>
+        <p14:creationId xmlns:p14="http://schemas.microsoft.com/office/powerpoint/2010/main" val="129405925"/>
       </p:ext>
     </p:extLst>
   </p:cSld>
@@ -5871,7 +5871,7 @@
     <p:bg>
       <p:bgPr>
         <a:solidFill xmlns:a="http://schemas.openxmlformats.org/drawingml/2006/main">
-          <a:srgbClr val="F7F9FB"/>
+          <a:srgbClr val="F4F8FC"/>
         </a:solidFill>
       </p:bgPr>
     </p:bg>
@@ -5889,7 +5889,7 @@
           <p:cNvPr id="4" name="">
             <a:extLst xmlns:a="http://schemas.openxmlformats.org/drawingml/2006/main">
               <a:ext uri="{FF2B5EF4-FFF2-40B4-BE49-F238E27FC236}">
-                <a16:creationId xmlns:a16="http://schemas.microsoft.com/office/drawing/2014/main" id="{D25FD9FE-AD5B-4F35-846D-2880EBFA21DD}"/>
+                <a16:creationId xmlns:a16="http://schemas.microsoft.com/office/drawing/2014/main" id="{34A73D0F-0F08-4628-B65E-B9A49EC9DE59}"/>
               </a:ext>
             </a:extLst>
           </p:cNvPr>
@@ -5920,7 +5920,7 @@
             <a:pPr>
               <a:defRPr sz="3300" b="1">
                 <a:solidFill>
-                  <a:srgbClr val="14283E"/>
+                  <a:srgbClr val="17324B"/>
                 </a:solidFill>
                 <a:latin typeface="DejaVu Sans"/>
                 <a:ea typeface="DejaVu Sans"/>
@@ -5930,7 +5930,7 @@
             <a:r>
               <a:rPr sz="3300" b="1">
                 <a:solidFill>
-                  <a:srgbClr val="14283E"/>
+                  <a:srgbClr val="17324B"/>
                 </a:solidFill>
                 <a:latin typeface="DejaVu Sans"/>
                 <a:ea typeface="DejaVu Sans"/>
@@ -5953,7 +5953,7 @@
         </p:xfrm>
         <a:graphic xmlns:a="http://schemas.openxmlformats.org/drawingml/2006/main">
           <a:graphicData uri="http://schemas.openxmlformats.org/drawingml/2006/chart">
-            <c:chart xmlns:r="http://schemas.openxmlformats.org/officeDocument/2006/relationships" xmlns:c="http://schemas.openxmlformats.org/drawingml/2006/chart" r:id="Rea20fa16e3e14a59"/>
+            <c:chart xmlns:r="http://schemas.openxmlformats.org/officeDocument/2006/relationships" xmlns:c="http://schemas.openxmlformats.org/drawingml/2006/chart" r:id="Rffa6a9c05d8241bd"/>
           </a:graphicData>
         </a:graphic>
       </p:graphicFrame>
@@ -5962,7 +5962,7 @@
           <p:cNvPr id="3" name="">
             <a:extLst xmlns:a="http://schemas.openxmlformats.org/drawingml/2006/main">
               <a:ext uri="{FF2B5EF4-FFF2-40B4-BE49-F238E27FC236}">
-                <a16:creationId xmlns:a16="http://schemas.microsoft.com/office/drawing/2014/main" id="{5B60C1C5-1661-44DB-986A-9521ED6E25AC}"/>
+                <a16:creationId xmlns:a16="http://schemas.microsoft.com/office/drawing/2014/main" id="{11D43B86-BEED-4C4B-B84A-ABEB41EE87C7}"/>
               </a:ext>
             </a:extLst>
           </p:cNvPr>
@@ -6017,7 +6017,7 @@
     </p:spTree>
     <p:extLst>
       <p:ext uri="{BB962C8B-B14F-4D97-AF65-F5344CB8AC3E}">
-        <p14:creationId xmlns:p14="http://schemas.microsoft.com/office/powerpoint/2010/main" val="838215429"/>
+        <p14:creationId xmlns:p14="http://schemas.microsoft.com/office/powerpoint/2010/main" val="598043404"/>
       </p:ext>
     </p:extLst>
   </p:cSld>
@@ -6030,7 +6030,7 @@
     <p:bg>
       <p:bgPr>
         <a:solidFill xmlns:a="http://schemas.openxmlformats.org/drawingml/2006/main">
-          <a:srgbClr val="F7F9FB"/>
+          <a:srgbClr val="F4F8FC"/>
         </a:solidFill>
       </p:bgPr>
     </p:bg>
@@ -6048,7 +6048,7 @@
           <p:cNvPr id="5" name="">
             <a:extLst xmlns:a="http://schemas.openxmlformats.org/drawingml/2006/main">
               <a:ext uri="{FF2B5EF4-FFF2-40B4-BE49-F238E27FC236}">
-                <a16:creationId xmlns:a16="http://schemas.microsoft.com/office/drawing/2014/main" id="{2148FC85-4E12-4A3F-9903-679DE8F423C3}"/>
+                <a16:creationId xmlns:a16="http://schemas.microsoft.com/office/drawing/2014/main" id="{C24B5C98-1B9D-4991-AB5A-5F25B76F329E}"/>
               </a:ext>
             </a:extLst>
           </p:cNvPr>
@@ -6079,7 +6079,7 @@
             <a:pPr>
               <a:defRPr sz="3300" b="1">
                 <a:solidFill>
-                  <a:srgbClr val="14283E"/>
+                  <a:srgbClr val="17324B"/>
                 </a:solidFill>
                 <a:latin typeface="DejaVu Sans"/>
                 <a:ea typeface="DejaVu Sans"/>
@@ -6089,7 +6089,7 @@
             <a:r>
               <a:rPr sz="3300" b="1">
                 <a:solidFill>
-                  <a:srgbClr val="14283E"/>
+                  <a:srgbClr val="17324B"/>
                 </a:solidFill>
                 <a:latin typeface="DejaVu Sans"/>
                 <a:ea typeface="DejaVu Sans"/>
@@ -6112,7 +6112,7 @@
         </p:xfrm>
         <a:graphic xmlns:a="http://schemas.openxmlformats.org/drawingml/2006/main">
           <a:graphicData uri="http://schemas.openxmlformats.org/drawingml/2006/chart">
-            <c:chart xmlns:r="http://schemas.openxmlformats.org/officeDocument/2006/relationships" xmlns:c="http://schemas.openxmlformats.org/drawingml/2006/chart" r:id="Rf1a9513dafbd47a0"/>
+            <c:chart xmlns:r="http://schemas.openxmlformats.org/officeDocument/2006/relationships" xmlns:c="http://schemas.openxmlformats.org/drawingml/2006/chart" r:id="R8140b31f481441f9"/>
           </a:graphicData>
         </a:graphic>
       </p:graphicFrame>
@@ -6121,7 +6121,7 @@
           <p:cNvPr id="3" name="">
             <a:extLst xmlns:a="http://schemas.openxmlformats.org/drawingml/2006/main">
               <a:ext uri="{FF2B5EF4-FFF2-40B4-BE49-F238E27FC236}">
-                <a16:creationId xmlns:a16="http://schemas.microsoft.com/office/drawing/2014/main" id="{40E8DBF7-8F78-4E44-BEFF-8DAE8E296C50}"/>
+                <a16:creationId xmlns:a16="http://schemas.microsoft.com/office/drawing/2014/main" id="{EB2F61F2-92BC-48B6-9172-58C723760434}"/>
               </a:ext>
             </a:extLst>
           </p:cNvPr>
@@ -6152,7 +6152,7 @@
             <a:pPr>
               <a:defRPr sz="2025" b="1">
                 <a:solidFill>
-                  <a:srgbClr val="14283E"/>
+                  <a:srgbClr val="17324B"/>
                 </a:solidFill>
                 <a:latin typeface="DejaVu Sans"/>
                 <a:ea typeface="DejaVu Sans"/>
@@ -6162,7 +6162,7 @@
             <a:r>
               <a:rPr sz="2025" b="1">
                 <a:solidFill>
-                  <a:srgbClr val="14283E"/>
+                  <a:srgbClr val="17324B"/>
                 </a:solidFill>
                 <a:latin typeface="DejaVu Sans"/>
                 <a:ea typeface="DejaVu Sans"/>
@@ -6178,7 +6178,7 @@
           <p:cNvPr id="4" name="">
             <a:extLst xmlns:a="http://schemas.openxmlformats.org/drawingml/2006/main">
               <a:ext uri="{FF2B5EF4-FFF2-40B4-BE49-F238E27FC236}">
-                <a16:creationId xmlns:a16="http://schemas.microsoft.com/office/drawing/2014/main" id="{A88CD7A7-ADAF-46F1-B0DF-850A37B422D3}"/>
+                <a16:creationId xmlns:a16="http://schemas.microsoft.com/office/drawing/2014/main" id="{486B750F-3100-48C0-9D60-5E7866361862}"/>
               </a:ext>
             </a:extLst>
           </p:cNvPr>
@@ -6233,7 +6233,7 @@
     </p:spTree>
     <p:extLst>
       <p:ext uri="{BB962C8B-B14F-4D97-AF65-F5344CB8AC3E}">
-        <p14:creationId xmlns:p14="http://schemas.microsoft.com/office/powerpoint/2010/main" val="1016758337"/>
+        <p14:creationId xmlns:p14="http://schemas.microsoft.com/office/powerpoint/2010/main" val="1381901291"/>
       </p:ext>
     </p:extLst>
   </p:cSld>
@@ -6246,7 +6246,7 @@
     <p:bg>
       <p:bgPr>
         <a:solidFill xmlns:a="http://schemas.openxmlformats.org/drawingml/2006/main">
-          <a:srgbClr val="F7F9FB"/>
+          <a:srgbClr val="F4F8FC"/>
         </a:solidFill>
       </p:bgPr>
     </p:bg>
@@ -6264,7 +6264,7 @@
           <p:cNvPr id="8" name="">
             <a:extLst xmlns:a="http://schemas.openxmlformats.org/drawingml/2006/main">
               <a:ext uri="{FF2B5EF4-FFF2-40B4-BE49-F238E27FC236}">
-                <a16:creationId xmlns:a16="http://schemas.microsoft.com/office/drawing/2014/main" id="{9CF7087A-B14F-46FB-BA4B-CD8627AAE36C}"/>
+                <a16:creationId xmlns:a16="http://schemas.microsoft.com/office/drawing/2014/main" id="{0A222028-64CC-491D-A5E4-0A148A4C09F5}"/>
               </a:ext>
             </a:extLst>
           </p:cNvPr>
@@ -6295,7 +6295,7 @@
             <a:pPr>
               <a:defRPr sz="3300" b="1">
                 <a:solidFill>
-                  <a:srgbClr val="14283E"/>
+                  <a:srgbClr val="17324B"/>
                 </a:solidFill>
                 <a:latin typeface="DejaVu Sans"/>
                 <a:ea typeface="DejaVu Sans"/>
@@ -6305,7 +6305,7 @@
             <a:r>
               <a:rPr sz="3300" b="1">
                 <a:solidFill>
-                  <a:srgbClr val="14283E"/>
+                  <a:srgbClr val="17324B"/>
                 </a:solidFill>
                 <a:latin typeface="DejaVu Sans"/>
                 <a:ea typeface="DejaVu Sans"/>
@@ -6321,7 +6321,7 @@
           <p:cNvPr id="2" name="">
             <a:extLst xmlns:a="http://schemas.openxmlformats.org/drawingml/2006/main">
               <a:ext uri="{FF2B5EF4-FFF2-40B4-BE49-F238E27FC236}">
-                <a16:creationId xmlns:a16="http://schemas.microsoft.com/office/drawing/2014/main" id="{947174CB-7BC8-4DA8-8EBE-ED08BC8EA150}"/>
+                <a16:creationId xmlns:a16="http://schemas.microsoft.com/office/drawing/2014/main" id="{1AF0A545-D167-41D4-B475-3862F110B717}"/>
               </a:ext>
             </a:extLst>
           </p:cNvPr>
@@ -6352,7 +6352,7 @@
             <a:pPr>
               <a:defRPr sz="2400" b="1">
                 <a:solidFill>
-                  <a:srgbClr val="07866E"/>
+                  <a:srgbClr val="126AA7"/>
                 </a:solidFill>
                 <a:latin typeface="DejaVu Sans"/>
                 <a:ea typeface="DejaVu Sans"/>
@@ -6362,7 +6362,7 @@
             <a:r>
               <a:rPr sz="2400" b="1">
                 <a:solidFill>
-                  <a:srgbClr val="07866E"/>
+                  <a:srgbClr val="126AA7"/>
                 </a:solidFill>
                 <a:latin typeface="DejaVu Sans"/>
                 <a:ea typeface="DejaVu Sans"/>
@@ -6378,7 +6378,7 @@
           <p:cNvPr id="3" name="">
             <a:extLst xmlns:a="http://schemas.openxmlformats.org/drawingml/2006/main">
               <a:ext uri="{FF2B5EF4-FFF2-40B4-BE49-F238E27FC236}">
-                <a16:creationId xmlns:a16="http://schemas.microsoft.com/office/drawing/2014/main" id="{239B680C-619D-45DE-8214-F99924F8C94B}"/>
+                <a16:creationId xmlns:a16="http://schemas.microsoft.com/office/drawing/2014/main" id="{7906D325-7095-4EA2-93C6-239991FED414}"/>
               </a:ext>
             </a:extLst>
           </p:cNvPr>
@@ -6409,7 +6409,7 @@
             <a:pPr>
               <a:defRPr sz="2325" b="0">
                 <a:solidFill>
-                  <a:srgbClr val="14283E"/>
+                  <a:srgbClr val="17324B"/>
                 </a:solidFill>
                 <a:latin typeface="DejaVu Sans"/>
                 <a:ea typeface="DejaVu Sans"/>
@@ -6419,7 +6419,7 @@
             <a:r>
               <a:rPr sz="2325" b="0">
                 <a:solidFill>
-                  <a:srgbClr val="14283E"/>
+                  <a:srgbClr val="17324B"/>
                 </a:solidFill>
                 <a:latin typeface="DejaVu Sans"/>
                 <a:ea typeface="DejaVu Sans"/>
@@ -6435,7 +6435,7 @@
           <p:cNvPr id="4" name="">
             <a:extLst xmlns:a="http://schemas.openxmlformats.org/drawingml/2006/main">
               <a:ext uri="{FF2B5EF4-FFF2-40B4-BE49-F238E27FC236}">
-                <a16:creationId xmlns:a16="http://schemas.microsoft.com/office/drawing/2014/main" id="{0D0DB649-923A-4FFA-B42B-8E34C079CDFF}"/>
+                <a16:creationId xmlns:a16="http://schemas.microsoft.com/office/drawing/2014/main" id="{BB6444B8-C500-489C-B676-1D69E7045597}"/>
               </a:ext>
             </a:extLst>
           </p:cNvPr>
@@ -6466,7 +6466,7 @@
             <a:pPr>
               <a:defRPr sz="2400" b="1">
                 <a:solidFill>
-                  <a:srgbClr val="07866E"/>
+                  <a:srgbClr val="126AA7"/>
                 </a:solidFill>
                 <a:latin typeface="DejaVu Sans"/>
                 <a:ea typeface="DejaVu Sans"/>
@@ -6476,7 +6476,7 @@
             <a:r>
               <a:rPr sz="2400" b="1">
                 <a:solidFill>
-                  <a:srgbClr val="07866E"/>
+                  <a:srgbClr val="126AA7"/>
                 </a:solidFill>
                 <a:latin typeface="DejaVu Sans"/>
                 <a:ea typeface="DejaVu Sans"/>
@@ -6492,7 +6492,7 @@
           <p:cNvPr id="5" name="">
             <a:extLst xmlns:a="http://schemas.openxmlformats.org/drawingml/2006/main">
               <a:ext uri="{FF2B5EF4-FFF2-40B4-BE49-F238E27FC236}">
-                <a16:creationId xmlns:a16="http://schemas.microsoft.com/office/drawing/2014/main" id="{1A3B08E5-7F6C-4DB6-9779-7DB375ECAC22}"/>
+                <a16:creationId xmlns:a16="http://schemas.microsoft.com/office/drawing/2014/main" id="{16B89813-EA86-4FB9-AADF-1943FDB5824A}"/>
               </a:ext>
             </a:extLst>
           </p:cNvPr>
@@ -6523,7 +6523,7 @@
             <a:pPr>
               <a:defRPr sz="2250" b="1">
                 <a:solidFill>
-                  <a:srgbClr val="14283E"/>
+                  <a:srgbClr val="17324B"/>
                 </a:solidFill>
                 <a:latin typeface="DejaVu Sans"/>
                 <a:ea typeface="DejaVu Sans"/>
@@ -6533,7 +6533,7 @@
             <a:r>
               <a:rPr sz="2250" b="1">
                 <a:solidFill>
-                  <a:srgbClr val="14283E"/>
+                  <a:srgbClr val="17324B"/>
                 </a:solidFill>
                 <a:latin typeface="DejaVu Sans"/>
                 <a:ea typeface="DejaVu Sans"/>
@@ -6549,7 +6549,7 @@
           <p:cNvPr id="6" name="">
             <a:extLst xmlns:a="http://schemas.openxmlformats.org/drawingml/2006/main">
               <a:ext uri="{FF2B5EF4-FFF2-40B4-BE49-F238E27FC236}">
-                <a16:creationId xmlns:a16="http://schemas.microsoft.com/office/drawing/2014/main" id="{7AB27E2D-7112-4A00-9414-B6E4347B4A3F}"/>
+                <a16:creationId xmlns:a16="http://schemas.microsoft.com/office/drawing/2014/main" id="{512FED93-FE0A-4656-A28A-B7C9534A7EED}"/>
               </a:ext>
             </a:extLst>
           </p:cNvPr>
@@ -6580,7 +6580,7 @@
             <a:pPr>
               <a:defRPr sz="1875" b="0">
                 <a:solidFill>
-                  <a:srgbClr val="14283E"/>
+                  <a:srgbClr val="17324B"/>
                 </a:solidFill>
                 <a:latin typeface="DejaVu Sans"/>
                 <a:ea typeface="DejaVu Sans"/>
@@ -6590,7 +6590,7 @@
             <a:r>
               <a:rPr sz="1875" b="0">
                 <a:solidFill>
-                  <a:srgbClr val="14283E"/>
+                  <a:srgbClr val="17324B"/>
                 </a:solidFill>
                 <a:latin typeface="DejaVu Sans"/>
                 <a:ea typeface="DejaVu Sans"/>
@@ -6606,7 +6606,7 @@
           <p:cNvPr id="7" name="">
             <a:extLst xmlns:a="http://schemas.openxmlformats.org/drawingml/2006/main">
               <a:ext uri="{FF2B5EF4-FFF2-40B4-BE49-F238E27FC236}">
-                <a16:creationId xmlns:a16="http://schemas.microsoft.com/office/drawing/2014/main" id="{C03B3FBA-BF2E-4A94-BD4F-A0AE8B426F87}"/>
+                <a16:creationId xmlns:a16="http://schemas.microsoft.com/office/drawing/2014/main" id="{01B75CF3-4DC6-44A7-B71D-AE3B45CEE02F}"/>
               </a:ext>
             </a:extLst>
           </p:cNvPr>
@@ -6661,7 +6661,7 @@
     </p:spTree>
     <p:extLst>
       <p:ext uri="{BB962C8B-B14F-4D97-AF65-F5344CB8AC3E}">
-        <p14:creationId xmlns:p14="http://schemas.microsoft.com/office/powerpoint/2010/main" val="1698463695"/>
+        <p14:creationId xmlns:p14="http://schemas.microsoft.com/office/powerpoint/2010/main" val="1613330210"/>
       </p:ext>
     </p:extLst>
   </p:cSld>
@@ -6674,7 +6674,7 @@
     <p:bg>
       <p:bgPr>
         <a:solidFill xmlns:a="http://schemas.openxmlformats.org/drawingml/2006/main">
-          <a:srgbClr val="F7F9FB"/>
+          <a:srgbClr val="F4F8FC"/>
         </a:solidFill>
       </p:bgPr>
     </p:bg>
@@ -6692,7 +6692,7 @@
           <p:cNvPr id="8" name="">
             <a:extLst xmlns:a="http://schemas.openxmlformats.org/drawingml/2006/main">
               <a:ext uri="{FF2B5EF4-FFF2-40B4-BE49-F238E27FC236}">
-                <a16:creationId xmlns:a16="http://schemas.microsoft.com/office/drawing/2014/main" id="{B95211E8-F23C-4A1F-B5EB-4E242BBAA681}"/>
+                <a16:creationId xmlns:a16="http://schemas.microsoft.com/office/drawing/2014/main" id="{906230E6-9827-4D4A-8038-1D5C6A1E34DD}"/>
               </a:ext>
             </a:extLst>
           </p:cNvPr>
@@ -6723,7 +6723,7 @@
             <a:pPr>
               <a:defRPr sz="3300" b="1">
                 <a:solidFill>
-                  <a:srgbClr val="14283E"/>
+                  <a:srgbClr val="17324B"/>
                 </a:solidFill>
                 <a:latin typeface="DejaVu Sans"/>
                 <a:ea typeface="DejaVu Sans"/>
@@ -6733,7 +6733,7 @@
             <a:r>
               <a:rPr sz="3300" b="1">
                 <a:solidFill>
-                  <a:srgbClr val="14283E"/>
+                  <a:srgbClr val="17324B"/>
                 </a:solidFill>
                 <a:latin typeface="DejaVu Sans"/>
                 <a:ea typeface="DejaVu Sans"/>
@@ -6749,7 +6749,7 @@
           <p:cNvPr id="2" name="">
             <a:extLst xmlns:a="http://schemas.openxmlformats.org/drawingml/2006/main">
               <a:ext uri="{FF2B5EF4-FFF2-40B4-BE49-F238E27FC236}">
-                <a16:creationId xmlns:a16="http://schemas.microsoft.com/office/drawing/2014/main" id="{695C25C4-0A1C-4938-8E6E-FE83DCA9E0AE}"/>
+                <a16:creationId xmlns:a16="http://schemas.microsoft.com/office/drawing/2014/main" id="{96019A96-AC84-49E2-99F8-9BA2374C15F4}"/>
               </a:ext>
             </a:extLst>
           </p:cNvPr>
@@ -6780,7 +6780,7 @@
             <a:pPr>
               <a:defRPr sz="2400" b="1">
                 <a:solidFill>
-                  <a:srgbClr val="07866E"/>
+                  <a:srgbClr val="126AA7"/>
                 </a:solidFill>
                 <a:latin typeface="DejaVu Sans"/>
                 <a:ea typeface="DejaVu Sans"/>
@@ -6790,7 +6790,7 @@
             <a:r>
               <a:rPr sz="2400" b="1">
                 <a:solidFill>
-                  <a:srgbClr val="07866E"/>
+                  <a:srgbClr val="126AA7"/>
                 </a:solidFill>
                 <a:latin typeface="DejaVu Sans"/>
                 <a:ea typeface="DejaVu Sans"/>
@@ -6806,7 +6806,7 @@
           <p:cNvPr id="3" name="">
             <a:extLst xmlns:a="http://schemas.openxmlformats.org/drawingml/2006/main">
               <a:ext uri="{FF2B5EF4-FFF2-40B4-BE49-F238E27FC236}">
-                <a16:creationId xmlns:a16="http://schemas.microsoft.com/office/drawing/2014/main" id="{F07CFADA-62E3-41EF-9D3B-3543F2C2232A}"/>
+                <a16:creationId xmlns:a16="http://schemas.microsoft.com/office/drawing/2014/main" id="{0274F68D-BE1B-463D-B30A-5E6D6623268A}"/>
               </a:ext>
             </a:extLst>
           </p:cNvPr>
@@ -6837,7 +6837,7 @@
             <a:pPr>
               <a:defRPr sz="2325" b="0">
                 <a:solidFill>
-                  <a:srgbClr val="14283E"/>
+                  <a:srgbClr val="17324B"/>
                 </a:solidFill>
                 <a:latin typeface="DejaVu Sans"/>
                 <a:ea typeface="DejaVu Sans"/>
@@ -6847,7 +6847,7 @@
             <a:r>
               <a:rPr sz="2325" b="0">
                 <a:solidFill>
-                  <a:srgbClr val="14283E"/>
+                  <a:srgbClr val="17324B"/>
                 </a:solidFill>
                 <a:latin typeface="DejaVu Sans"/>
                 <a:ea typeface="DejaVu Sans"/>
@@ -6863,7 +6863,7 @@
           <p:cNvPr id="4" name="">
             <a:extLst xmlns:a="http://schemas.openxmlformats.org/drawingml/2006/main">
               <a:ext uri="{FF2B5EF4-FFF2-40B4-BE49-F238E27FC236}">
-                <a16:creationId xmlns:a16="http://schemas.microsoft.com/office/drawing/2014/main" id="{E77A0D67-2DD4-4D2B-AB4A-6BCB5A3C11AB}"/>
+                <a16:creationId xmlns:a16="http://schemas.microsoft.com/office/drawing/2014/main" id="{632070E6-23C5-4B99-9140-6F9966DA0774}"/>
               </a:ext>
             </a:extLst>
           </p:cNvPr>
@@ -6894,7 +6894,7 @@
             <a:pPr>
               <a:defRPr sz="2400" b="1">
                 <a:solidFill>
-                  <a:srgbClr val="07866E"/>
+                  <a:srgbClr val="126AA7"/>
                 </a:solidFill>
                 <a:latin typeface="DejaVu Sans"/>
                 <a:ea typeface="DejaVu Sans"/>
@@ -6904,7 +6904,7 @@
             <a:r>
               <a:rPr sz="2400" b="1">
                 <a:solidFill>
-                  <a:srgbClr val="07866E"/>
+                  <a:srgbClr val="126AA7"/>
                 </a:solidFill>
                 <a:latin typeface="DejaVu Sans"/>
                 <a:ea typeface="DejaVu Sans"/>
@@ -6920,7 +6920,7 @@
           <p:cNvPr id="5" name="">
             <a:extLst xmlns:a="http://schemas.openxmlformats.org/drawingml/2006/main">
               <a:ext uri="{FF2B5EF4-FFF2-40B4-BE49-F238E27FC236}">
-                <a16:creationId xmlns:a16="http://schemas.microsoft.com/office/drawing/2014/main" id="{A1F44D1C-895E-42B7-99DE-A0A768E1FF38}"/>
+                <a16:creationId xmlns:a16="http://schemas.microsoft.com/office/drawing/2014/main" id="{96D2F782-F54D-4971-923A-30728A586D85}"/>
               </a:ext>
             </a:extLst>
           </p:cNvPr>
@@ -6951,7 +6951,7 @@
             <a:pPr>
               <a:defRPr sz="2325" b="0">
                 <a:solidFill>
-                  <a:srgbClr val="14283E"/>
+                  <a:srgbClr val="17324B"/>
                 </a:solidFill>
                 <a:latin typeface="DejaVu Sans"/>
                 <a:ea typeface="DejaVu Sans"/>
@@ -6961,7 +6961,7 @@
             <a:r>
               <a:rPr sz="2325" b="0">
                 <a:solidFill>
-                  <a:srgbClr val="14283E"/>
+                  <a:srgbClr val="17324B"/>
                 </a:solidFill>
                 <a:latin typeface="DejaVu Sans"/>
                 <a:ea typeface="DejaVu Sans"/>
@@ -6977,7 +6977,7 @@
           <p:cNvPr id="6" name="">
             <a:extLst xmlns:a="http://schemas.openxmlformats.org/drawingml/2006/main">
               <a:ext uri="{FF2B5EF4-FFF2-40B4-BE49-F238E27FC236}">
-                <a16:creationId xmlns:a16="http://schemas.microsoft.com/office/drawing/2014/main" id="{373EAD3C-2E3D-40B6-BD5E-6024E3BABE7B}"/>
+                <a16:creationId xmlns:a16="http://schemas.microsoft.com/office/drawing/2014/main" id="{EEC6019E-56F6-4855-BF74-C5F7F284DB30}"/>
               </a:ext>
             </a:extLst>
           </p:cNvPr>
@@ -7008,7 +7008,7 @@
             <a:pPr>
               <a:defRPr sz="2025" b="1">
                 <a:solidFill>
-                  <a:srgbClr val="14283E"/>
+                  <a:srgbClr val="17324B"/>
                 </a:solidFill>
                 <a:latin typeface="DejaVu Sans"/>
                 <a:ea typeface="DejaVu Sans"/>
@@ -7018,7 +7018,7 @@
             <a:r>
               <a:rPr sz="2025" b="1">
                 <a:solidFill>
-                  <a:srgbClr val="14283E"/>
+                  <a:srgbClr val="17324B"/>
                 </a:solidFill>
                 <a:latin typeface="DejaVu Sans"/>
                 <a:ea typeface="DejaVu Sans"/>
@@ -7034,7 +7034,7 @@
           <p:cNvPr id="7" name="">
             <a:extLst xmlns:a="http://schemas.openxmlformats.org/drawingml/2006/main">
               <a:ext uri="{FF2B5EF4-FFF2-40B4-BE49-F238E27FC236}">
-                <a16:creationId xmlns:a16="http://schemas.microsoft.com/office/drawing/2014/main" id="{68A724C9-96FC-4AC4-A288-D2502C335D40}"/>
+                <a16:creationId xmlns:a16="http://schemas.microsoft.com/office/drawing/2014/main" id="{FC89FB06-1F2D-4D77-9773-ECC4FF487857}"/>
               </a:ext>
             </a:extLst>
           </p:cNvPr>
@@ -7089,7 +7089,7 @@
     </p:spTree>
     <p:extLst>
       <p:ext uri="{BB962C8B-B14F-4D97-AF65-F5344CB8AC3E}">
-        <p14:creationId xmlns:p14="http://schemas.microsoft.com/office/powerpoint/2010/main" val="1628488048"/>
+        <p14:creationId xmlns:p14="http://schemas.microsoft.com/office/powerpoint/2010/main" val="863671809"/>
       </p:ext>
     </p:extLst>
   </p:cSld>
@@ -7102,7 +7102,7 @@
     <p:bg>
       <p:bgPr>
         <a:solidFill xmlns:a="http://schemas.openxmlformats.org/drawingml/2006/main">
-          <a:srgbClr val="F7F9FB"/>
+          <a:srgbClr val="F4F8FC"/>
         </a:solidFill>
       </p:bgPr>
     </p:bg>
@@ -7120,7 +7120,7 @@
           <p:cNvPr id="5" name="">
             <a:extLst xmlns:a="http://schemas.openxmlformats.org/drawingml/2006/main">
               <a:ext uri="{FF2B5EF4-FFF2-40B4-BE49-F238E27FC236}">
-                <a16:creationId xmlns:a16="http://schemas.microsoft.com/office/drawing/2014/main" id="{0A42C3AA-86F0-4305-B45B-313B44A26D45}"/>
+                <a16:creationId xmlns:a16="http://schemas.microsoft.com/office/drawing/2014/main" id="{9F0A74B8-3D6B-48EB-BE1B-7EE2F6FBEAAF}"/>
               </a:ext>
             </a:extLst>
           </p:cNvPr>
@@ -7151,7 +7151,7 @@
             <a:pPr>
               <a:defRPr sz="3300" b="1">
                 <a:solidFill>
-                  <a:srgbClr val="14283E"/>
+                  <a:srgbClr val="17324B"/>
                 </a:solidFill>
                 <a:latin typeface="DejaVu Sans"/>
                 <a:ea typeface="DejaVu Sans"/>
@@ -7161,7 +7161,7 @@
             <a:r>
               <a:rPr sz="3300" b="1">
                 <a:solidFill>
-                  <a:srgbClr val="14283E"/>
+                  <a:srgbClr val="17324B"/>
                 </a:solidFill>
                 <a:latin typeface="DejaVu Sans"/>
                 <a:ea typeface="DejaVu Sans"/>
@@ -7184,7 +7184,7 @@
         </p:xfrm>
         <a:graphic xmlns:a="http://schemas.openxmlformats.org/drawingml/2006/main">
           <a:graphicData uri="http://schemas.openxmlformats.org/drawingml/2006/chart">
-            <c:chart xmlns:r="http://schemas.openxmlformats.org/officeDocument/2006/relationships" xmlns:c="http://schemas.openxmlformats.org/drawingml/2006/chart" r:id="R481f118c9f504943"/>
+            <c:chart xmlns:r="http://schemas.openxmlformats.org/officeDocument/2006/relationships" xmlns:c="http://schemas.openxmlformats.org/drawingml/2006/chart" r:id="R77cd17f2d9514616"/>
           </a:graphicData>
         </a:graphic>
       </p:graphicFrame>
@@ -7193,7 +7193,7 @@
           <p:cNvPr id="3" name="">
             <a:extLst xmlns:a="http://schemas.openxmlformats.org/drawingml/2006/main">
               <a:ext uri="{FF2B5EF4-FFF2-40B4-BE49-F238E27FC236}">
-                <a16:creationId xmlns:a16="http://schemas.microsoft.com/office/drawing/2014/main" id="{4B7BC5BB-81D6-40C2-B1DE-1BBBFF5CA4B7}"/>
+                <a16:creationId xmlns:a16="http://schemas.microsoft.com/office/drawing/2014/main" id="{A5425574-C07D-493B-92B8-7ADA13325490}"/>
               </a:ext>
             </a:extLst>
           </p:cNvPr>
@@ -7224,7 +7224,7 @@
             <a:pPr>
               <a:defRPr sz="2025" b="1">
                 <a:solidFill>
-                  <a:srgbClr val="14283E"/>
+                  <a:srgbClr val="17324B"/>
                 </a:solidFill>
                 <a:latin typeface="DejaVu Sans"/>
                 <a:ea typeface="DejaVu Sans"/>
@@ -7234,7 +7234,7 @@
             <a:r>
               <a:rPr sz="2025" b="1">
                 <a:solidFill>
-                  <a:srgbClr val="14283E"/>
+                  <a:srgbClr val="17324B"/>
                 </a:solidFill>
                 <a:latin typeface="DejaVu Sans"/>
                 <a:ea typeface="DejaVu Sans"/>
@@ -7250,7 +7250,7 @@
           <p:cNvPr id="4" name="">
             <a:extLst xmlns:a="http://schemas.openxmlformats.org/drawingml/2006/main">
               <a:ext uri="{FF2B5EF4-FFF2-40B4-BE49-F238E27FC236}">
-                <a16:creationId xmlns:a16="http://schemas.microsoft.com/office/drawing/2014/main" id="{D5CDA3FE-2899-4C84-B0E8-A7C4BDC05347}"/>
+                <a16:creationId xmlns:a16="http://schemas.microsoft.com/office/drawing/2014/main" id="{9A4CDC84-F5C8-4426-B2EE-15214199FE88}"/>
               </a:ext>
             </a:extLst>
           </p:cNvPr>
@@ -7305,7 +7305,7 @@
     </p:spTree>
     <p:extLst>
       <p:ext uri="{BB962C8B-B14F-4D97-AF65-F5344CB8AC3E}">
-        <p14:creationId xmlns:p14="http://schemas.microsoft.com/office/powerpoint/2010/main" val="1036903283"/>
+        <p14:creationId xmlns:p14="http://schemas.microsoft.com/office/powerpoint/2010/main" val="65169313"/>
       </p:ext>
     </p:extLst>
   </p:cSld>
@@ -7318,7 +7318,7 @@
     <p:bg>
       <p:bgPr>
         <a:solidFill xmlns:a="http://schemas.openxmlformats.org/drawingml/2006/main">
-          <a:srgbClr val="F7F9FB"/>
+          <a:srgbClr val="F4F8FC"/>
         </a:solidFill>
       </p:bgPr>
     </p:bg>
@@ -7336,7 +7336,7 @@
           <p:cNvPr id="8" name="">
             <a:extLst xmlns:a="http://schemas.openxmlformats.org/drawingml/2006/main">
               <a:ext uri="{FF2B5EF4-FFF2-40B4-BE49-F238E27FC236}">
-                <a16:creationId xmlns:a16="http://schemas.microsoft.com/office/drawing/2014/main" id="{641904BA-FF40-444B-AD77-2BE7391FA078}"/>
+                <a16:creationId xmlns:a16="http://schemas.microsoft.com/office/drawing/2014/main" id="{593D495A-C4AE-4A3A-BFCF-2FB6C1CB0D55}"/>
               </a:ext>
             </a:extLst>
           </p:cNvPr>
@@ -7367,7 +7367,7 @@
             <a:pPr>
               <a:defRPr sz="3300" b="1">
                 <a:solidFill>
-                  <a:srgbClr val="14283E"/>
+                  <a:srgbClr val="17324B"/>
                 </a:solidFill>
                 <a:latin typeface="DejaVu Sans"/>
                 <a:ea typeface="DejaVu Sans"/>
@@ -7377,7 +7377,7 @@
             <a:r>
               <a:rPr sz="3300" b="1">
                 <a:solidFill>
-                  <a:srgbClr val="14283E"/>
+                  <a:srgbClr val="17324B"/>
                 </a:solidFill>
                 <a:latin typeface="DejaVu Sans"/>
                 <a:ea typeface="DejaVu Sans"/>
@@ -7393,7 +7393,7 @@
           <p:cNvPr id="2" name="">
             <a:extLst xmlns:a="http://schemas.openxmlformats.org/drawingml/2006/main">
               <a:ext uri="{FF2B5EF4-FFF2-40B4-BE49-F238E27FC236}">
-                <a16:creationId xmlns:a16="http://schemas.microsoft.com/office/drawing/2014/main" id="{FFAC5F5C-E693-4841-A4E6-B5FC2CC53B5F}"/>
+                <a16:creationId xmlns:a16="http://schemas.microsoft.com/office/drawing/2014/main" id="{0077359E-F29A-4E6D-878C-1A045652A70F}"/>
               </a:ext>
             </a:extLst>
           </p:cNvPr>
@@ -7424,7 +7424,7 @@
             <a:pPr>
               <a:defRPr sz="2325" b="1">
                 <a:solidFill>
-                  <a:srgbClr val="07866E"/>
+                  <a:srgbClr val="126AA7"/>
                 </a:solidFill>
                 <a:latin typeface="DejaVu Sans"/>
                 <a:ea typeface="DejaVu Sans"/>
@@ -7434,7 +7434,7 @@
             <a:r>
               <a:rPr sz="2325" b="1">
                 <a:solidFill>
-                  <a:srgbClr val="07866E"/>
+                  <a:srgbClr val="126AA7"/>
                 </a:solidFill>
                 <a:latin typeface="DejaVu Sans"/>
                 <a:ea typeface="DejaVu Sans"/>
@@ -7450,7 +7450,7 @@
           <p:cNvPr id="3" name="">
             <a:extLst xmlns:a="http://schemas.openxmlformats.org/drawingml/2006/main">
               <a:ext uri="{FF2B5EF4-FFF2-40B4-BE49-F238E27FC236}">
-                <a16:creationId xmlns:a16="http://schemas.microsoft.com/office/drawing/2014/main" id="{FD76FC4B-BC79-4AD5-9037-CDE062119EDD}"/>
+                <a16:creationId xmlns:a16="http://schemas.microsoft.com/office/drawing/2014/main" id="{3F33517F-D170-486D-A7FA-9DF9CFC51653}"/>
               </a:ext>
             </a:extLst>
           </p:cNvPr>
@@ -7481,7 +7481,7 @@
             <a:pPr>
               <a:defRPr sz="2100" b="0">
                 <a:solidFill>
-                  <a:srgbClr val="14283E"/>
+                  <a:srgbClr val="17324B"/>
                 </a:solidFill>
                 <a:latin typeface="DejaVu Sans"/>
                 <a:ea typeface="DejaVu Sans"/>
@@ -7491,7 +7491,7 @@
             <a:r>
               <a:rPr sz="2100" b="0">
                 <a:solidFill>
-                  <a:srgbClr val="14283E"/>
+                  <a:srgbClr val="17324B"/>
                 </a:solidFill>
                 <a:latin typeface="DejaVu Sans"/>
                 <a:ea typeface="DejaVu Sans"/>
@@ -7504,7 +7504,7 @@
             <a:pPr>
               <a:defRPr sz="2100" b="0">
                 <a:solidFill>
-                  <a:srgbClr val="14283E"/>
+                  <a:srgbClr val="17324B"/>
                 </a:solidFill>
                 <a:latin typeface="DejaVu Sans"/>
                 <a:ea typeface="DejaVu Sans"/>
@@ -7514,7 +7514,7 @@
             <a:r>
               <a:rPr sz="2100" b="0">
                 <a:solidFill>
-                  <a:srgbClr val="14283E"/>
+                  <a:srgbClr val="17324B"/>
                 </a:solidFill>
                 <a:latin typeface="DejaVu Sans"/>
                 <a:ea typeface="DejaVu Sans"/>
@@ -7530,7 +7530,7 @@
           <p:cNvPr id="4" name="">
             <a:extLst xmlns:a="http://schemas.openxmlformats.org/drawingml/2006/main">
               <a:ext uri="{FF2B5EF4-FFF2-40B4-BE49-F238E27FC236}">
-                <a16:creationId xmlns:a16="http://schemas.microsoft.com/office/drawing/2014/main" id="{1F9067BB-951B-4CD9-857F-98F0440611FC}"/>
+                <a16:creationId xmlns:a16="http://schemas.microsoft.com/office/drawing/2014/main" id="{8D30E2B7-077E-403A-8CEA-ACB3F8DAF8A9}"/>
               </a:ext>
             </a:extLst>
           </p:cNvPr>
@@ -7561,7 +7561,7 @@
             <a:pPr>
               <a:defRPr sz="2325" b="1">
                 <a:solidFill>
-                  <a:srgbClr val="07866E"/>
+                  <a:srgbClr val="126AA7"/>
                 </a:solidFill>
                 <a:latin typeface="DejaVu Sans"/>
                 <a:ea typeface="DejaVu Sans"/>
@@ -7571,7 +7571,7 @@
             <a:r>
               <a:rPr sz="2325" b="1">
                 <a:solidFill>
-                  <a:srgbClr val="07866E"/>
+                  <a:srgbClr val="126AA7"/>
                 </a:solidFill>
                 <a:latin typeface="DejaVu Sans"/>
                 <a:ea typeface="DejaVu Sans"/>
@@ -7587,7 +7587,7 @@
           <p:cNvPr id="5" name="">
             <a:extLst xmlns:a="http://schemas.openxmlformats.org/drawingml/2006/main">
               <a:ext uri="{FF2B5EF4-FFF2-40B4-BE49-F238E27FC236}">
-                <a16:creationId xmlns:a16="http://schemas.microsoft.com/office/drawing/2014/main" id="{31C0C0BC-11FD-4E33-AB21-7AD2793A6C18}"/>
+                <a16:creationId xmlns:a16="http://schemas.microsoft.com/office/drawing/2014/main" id="{9973D5F3-978A-4FDF-9819-3328DA2FEE12}"/>
               </a:ext>
             </a:extLst>
           </p:cNvPr>
@@ -7618,7 +7618,7 @@
             <a:pPr>
               <a:defRPr sz="2100" b="0">
                 <a:solidFill>
-                  <a:srgbClr val="14283E"/>
+                  <a:srgbClr val="17324B"/>
                 </a:solidFill>
                 <a:latin typeface="DejaVu Sans"/>
                 <a:ea typeface="DejaVu Sans"/>
@@ -7628,7 +7628,7 @@
             <a:r>
               <a:rPr sz="2100" b="0">
                 <a:solidFill>
-                  <a:srgbClr val="14283E"/>
+                  <a:srgbClr val="17324B"/>
                 </a:solidFill>
                 <a:latin typeface="DejaVu Sans"/>
                 <a:ea typeface="DejaVu Sans"/>
@@ -7641,7 +7641,7 @@
             <a:pPr>
               <a:defRPr sz="2100" b="0">
                 <a:solidFill>
-                  <a:srgbClr val="14283E"/>
+                  <a:srgbClr val="17324B"/>
                 </a:solidFill>
                 <a:latin typeface="DejaVu Sans"/>
                 <a:ea typeface="DejaVu Sans"/>
@@ -7651,7 +7651,7 @@
             <a:r>
               <a:rPr sz="2100" b="0">
                 <a:solidFill>
-                  <a:srgbClr val="14283E"/>
+                  <a:srgbClr val="17324B"/>
                 </a:solidFill>
                 <a:latin typeface="DejaVu Sans"/>
                 <a:ea typeface="DejaVu Sans"/>
@@ -7667,7 +7667,7 @@
           <p:cNvPr id="6" name="">
             <a:extLst xmlns:a="http://schemas.openxmlformats.org/drawingml/2006/main">
               <a:ext uri="{FF2B5EF4-FFF2-40B4-BE49-F238E27FC236}">
-                <a16:creationId xmlns:a16="http://schemas.microsoft.com/office/drawing/2014/main" id="{3659B535-91D8-4745-94C6-F247A30FD9C0}"/>
+                <a16:creationId xmlns:a16="http://schemas.microsoft.com/office/drawing/2014/main" id="{13F1E465-91CC-471E-843F-7C48AC778D3D}"/>
               </a:ext>
             </a:extLst>
           </p:cNvPr>
@@ -7698,7 +7698,7 @@
             <a:pPr>
               <a:defRPr sz="2250" b="1">
                 <a:solidFill>
-                  <a:srgbClr val="14283E"/>
+                  <a:srgbClr val="17324B"/>
                 </a:solidFill>
                 <a:latin typeface="DejaVu Sans"/>
                 <a:ea typeface="DejaVu Sans"/>
@@ -7708,7 +7708,7 @@
             <a:r>
               <a:rPr sz="2250" b="1">
                 <a:solidFill>
-                  <a:srgbClr val="14283E"/>
+                  <a:srgbClr val="17324B"/>
                 </a:solidFill>
                 <a:latin typeface="DejaVu Sans"/>
                 <a:ea typeface="DejaVu Sans"/>
@@ -7724,7 +7724,7 @@
           <p:cNvPr id="7" name="">
             <a:extLst xmlns:a="http://schemas.openxmlformats.org/drawingml/2006/main">
               <a:ext uri="{FF2B5EF4-FFF2-40B4-BE49-F238E27FC236}">
-                <a16:creationId xmlns:a16="http://schemas.microsoft.com/office/drawing/2014/main" id="{76A68C1C-0C2D-4AF8-A57F-069EE04E044E}"/>
+                <a16:creationId xmlns:a16="http://schemas.microsoft.com/office/drawing/2014/main" id="{CDEB43DB-AFCC-44F1-8A2D-80DDF27C0D2A}"/>
               </a:ext>
             </a:extLst>
           </p:cNvPr>
@@ -7779,7 +7779,7 @@
     </p:spTree>
     <p:extLst>
       <p:ext uri="{BB962C8B-B14F-4D97-AF65-F5344CB8AC3E}">
-        <p14:creationId xmlns:p14="http://schemas.microsoft.com/office/powerpoint/2010/main" val="1245578541"/>
+        <p14:creationId xmlns:p14="http://schemas.microsoft.com/office/powerpoint/2010/main" val="642984493"/>
       </p:ext>
     </p:extLst>
   </p:cSld>

</xml_diff>